<commit_message>
Pointless commit but i need to update my branch for updates
</commit_message>
<xml_diff>
--- a/Presentation/TIVIDY-Presentation.pptx
+++ b/Presentation/TIVIDY-Presentation.pptx
@@ -5,10 +5,10 @@
     <p:sldMasterId id="2147483648" r:id="rId4"/>
   </p:sldMasterIdLst>
   <p:notesMasterIdLst>
-    <p:notesMasterId r:id="rId38"/>
+    <p:notesMasterId r:id="rId36"/>
   </p:notesMasterIdLst>
   <p:handoutMasterIdLst>
-    <p:handoutMasterId r:id="rId39"/>
+    <p:handoutMasterId r:id="rId37"/>
   </p:handoutMasterIdLst>
   <p:sldIdLst>
     <p:sldId id="340" r:id="rId5"/>
@@ -19,31 +19,29 @@
     <p:sldId id="346" r:id="rId10"/>
     <p:sldId id="344" r:id="rId11"/>
     <p:sldId id="360" r:id="rId12"/>
-    <p:sldId id="361" r:id="rId13"/>
-    <p:sldId id="362" r:id="rId14"/>
-    <p:sldId id="363" r:id="rId15"/>
-    <p:sldId id="364" r:id="rId16"/>
-    <p:sldId id="367" r:id="rId17"/>
-    <p:sldId id="369" r:id="rId18"/>
-    <p:sldId id="368" r:id="rId19"/>
-    <p:sldId id="370" r:id="rId20"/>
-    <p:sldId id="371" r:id="rId21"/>
-    <p:sldId id="372" r:id="rId22"/>
-    <p:sldId id="373" r:id="rId23"/>
-    <p:sldId id="365" r:id="rId24"/>
-    <p:sldId id="366" r:id="rId25"/>
-    <p:sldId id="374" r:id="rId26"/>
-    <p:sldId id="376" r:id="rId27"/>
-    <p:sldId id="377" r:id="rId28"/>
-    <p:sldId id="378" r:id="rId29"/>
-    <p:sldId id="380" r:id="rId30"/>
-    <p:sldId id="382" r:id="rId31"/>
-    <p:sldId id="379" r:id="rId32"/>
-    <p:sldId id="383" r:id="rId33"/>
-    <p:sldId id="384" r:id="rId34"/>
-    <p:sldId id="385" r:id="rId35"/>
-    <p:sldId id="386" r:id="rId36"/>
-    <p:sldId id="355" r:id="rId37"/>
+    <p:sldId id="362" r:id="rId13"/>
+    <p:sldId id="372" r:id="rId14"/>
+    <p:sldId id="361" r:id="rId15"/>
+    <p:sldId id="363" r:id="rId16"/>
+    <p:sldId id="364" r:id="rId17"/>
+    <p:sldId id="367" r:id="rId18"/>
+    <p:sldId id="369" r:id="rId19"/>
+    <p:sldId id="368" r:id="rId20"/>
+    <p:sldId id="370" r:id="rId21"/>
+    <p:sldId id="371" r:id="rId22"/>
+    <p:sldId id="374" r:id="rId23"/>
+    <p:sldId id="376" r:id="rId24"/>
+    <p:sldId id="377" r:id="rId25"/>
+    <p:sldId id="378" r:id="rId26"/>
+    <p:sldId id="380" r:id="rId27"/>
+    <p:sldId id="382" r:id="rId28"/>
+    <p:sldId id="379" r:id="rId29"/>
+    <p:sldId id="383" r:id="rId30"/>
+    <p:sldId id="387" r:id="rId31"/>
+    <p:sldId id="384" r:id="rId32"/>
+    <p:sldId id="385" r:id="rId33"/>
+    <p:sldId id="386" r:id="rId34"/>
+    <p:sldId id="355" r:id="rId35"/>
   </p:sldIdLst>
   <p:sldSz cx="12192000" cy="6858000"/>
   <p:notesSz cx="6858000" cy="9144000"/>
@@ -253,7 +251,7 @@
           <a:p>
             <a:fld id="{E4E69F83-204D-4778-AAD0-A0F851A3AEEE}" type="datetimeFigureOut">
               <a:rPr lang="en-US" smtClean="0"/>
-              <a:t>10/27/2026</a:t>
+              <a:t>11/1/2026</a:t>
             </a:fld>
             <a:endParaRPr lang="en-US" dirty="0"/>
           </a:p>
@@ -430,7 +428,7 @@
           <a:p>
             <a:fld id="{85AE3C21-C3CB-4B8D-9033-56C1B3CE75FA}" type="datetimeFigureOut">
               <a:rPr lang="en-US" smtClean="0"/>
-              <a:t>10/27/2026</a:t>
+              <a:t>11/1/2026</a:t>
             </a:fld>
             <a:endParaRPr lang="en-US" dirty="0"/>
           </a:p>
@@ -789,114 +787,6 @@
         <p:cNvPr id="1" name="">
           <a:extLst>
             <a:ext uri="{FF2B5EF4-FFF2-40B4-BE49-F238E27FC236}">
-              <a16:creationId xmlns:a16="http://schemas.microsoft.com/office/drawing/2014/main" id="{EF245ACA-3B56-E9B1-EE13-D68F3AEE294B}"/>
-            </a:ext>
-          </a:extLst>
-        </p:cNvPr>
-        <p:cNvGrpSpPr/>
-        <p:nvPr/>
-      </p:nvGrpSpPr>
-      <p:grpSpPr>
-        <a:xfrm>
-          <a:off x="0" y="0"/>
-          <a:ext cx="0" cy="0"/>
-          <a:chOff x="0" y="0"/>
-          <a:chExt cx="0" cy="0"/>
-        </a:xfrm>
-      </p:grpSpPr>
-      <p:sp>
-        <p:nvSpPr>
-          <p:cNvPr id="2" name="Slide Image Placeholder 1">
-            <a:extLst>
-              <a:ext uri="{FF2B5EF4-FFF2-40B4-BE49-F238E27FC236}">
-                <a16:creationId xmlns:a16="http://schemas.microsoft.com/office/drawing/2014/main" id="{183F2BBE-65E7-E4A8-060F-E1AB94CEA416}"/>
-              </a:ext>
-            </a:extLst>
-          </p:cNvPr>
-          <p:cNvSpPr>
-            <a:spLocks noGrp="1" noRot="1" noChangeAspect="1"/>
-          </p:cNvSpPr>
-          <p:nvPr>
-            <p:ph type="sldImg"/>
-          </p:nvPr>
-        </p:nvSpPr>
-        <p:spPr/>
-      </p:sp>
-      <p:sp>
-        <p:nvSpPr>
-          <p:cNvPr id="3" name="Notes Placeholder 2">
-            <a:extLst>
-              <a:ext uri="{FF2B5EF4-FFF2-40B4-BE49-F238E27FC236}">
-                <a16:creationId xmlns:a16="http://schemas.microsoft.com/office/drawing/2014/main" id="{4F62BAD7-28E7-6B8C-7235-303E26AD8479}"/>
-              </a:ext>
-            </a:extLst>
-          </p:cNvPr>
-          <p:cNvSpPr>
-            <a:spLocks noGrp="1"/>
-          </p:cNvSpPr>
-          <p:nvPr>
-            <p:ph type="body" idx="1"/>
-          </p:nvPr>
-        </p:nvSpPr>
-        <p:spPr/>
-        <p:txBody>
-          <a:bodyPr/>
-          <a:lstStyle/>
-          <a:p>
-            <a:endParaRPr lang="en-US" dirty="0"/>
-          </a:p>
-        </p:txBody>
-      </p:sp>
-      <p:sp>
-        <p:nvSpPr>
-          <p:cNvPr id="4" name="Slide Number Placeholder 3">
-            <a:extLst>
-              <a:ext uri="{FF2B5EF4-FFF2-40B4-BE49-F238E27FC236}">
-                <a16:creationId xmlns:a16="http://schemas.microsoft.com/office/drawing/2014/main" id="{ECE99653-8655-6102-6B87-4350DFDD2CDB}"/>
-              </a:ext>
-            </a:extLst>
-          </p:cNvPr>
-          <p:cNvSpPr>
-            <a:spLocks noGrp="1"/>
-          </p:cNvSpPr>
-          <p:nvPr>
-            <p:ph type="sldNum" sz="quarter" idx="5"/>
-          </p:nvPr>
-        </p:nvSpPr>
-        <p:spPr/>
-        <p:txBody>
-          <a:bodyPr/>
-          <a:lstStyle/>
-          <a:p>
-            <a:fld id="{17732C3C-A191-48C2-A7E8-9C96AF841A7A}" type="slidenum">
-              <a:rPr lang="en-US" smtClean="0"/>
-              <a:t>22</a:t>
-            </a:fld>
-            <a:endParaRPr lang="en-US" dirty="0"/>
-          </a:p>
-        </p:txBody>
-      </p:sp>
-    </p:spTree>
-    <p:extLst>
-      <p:ext uri="{BB962C8B-B14F-4D97-AF65-F5344CB8AC3E}">
-        <p14:creationId xmlns:p14="http://schemas.microsoft.com/office/powerpoint/2010/main" val="1872019951"/>
-      </p:ext>
-    </p:extLst>
-  </p:cSld>
-  <p:clrMapOvr>
-    <a:masterClrMapping/>
-  </p:clrMapOvr>
-</p:notes>
-</file>
-
-<file path=ppt/notesSlides/notesSlide11.xml><?xml version="1.0" encoding="utf-8"?>
-<p:notes xmlns:a="http://schemas.openxmlformats.org/drawingml/2006/main" xmlns:r="http://schemas.openxmlformats.org/officeDocument/2006/relationships" xmlns:p="http://schemas.openxmlformats.org/presentationml/2006/main">
-  <p:cSld>
-    <p:spTree>
-      <p:nvGrpSpPr>
-        <p:cNvPr id="1" name="">
-          <a:extLst>
-            <a:ext uri="{FF2B5EF4-FFF2-40B4-BE49-F238E27FC236}">
               <a16:creationId xmlns:a16="http://schemas.microsoft.com/office/drawing/2014/main" id="{9F80BC47-5135-C696-3F59-A95EAF46AD9B}"/>
             </a:ext>
           </a:extLst>
@@ -978,7 +868,7 @@
           <a:p>
             <a:fld id="{17732C3C-A191-48C2-A7E8-9C96AF841A7A}" type="slidenum">
               <a:rPr lang="en-US" smtClean="0"/>
-              <a:t>23</a:t>
+              <a:t>20</a:t>
             </a:fld>
             <a:endParaRPr lang="en-US" dirty="0"/>
           </a:p>
@@ -997,7 +887,7 @@
 </p:notes>
 </file>
 
-<file path=ppt/notesSlides/notesSlide12.xml><?xml version="1.0" encoding="utf-8"?>
+<file path=ppt/notesSlides/notesSlide11.xml><?xml version="1.0" encoding="utf-8"?>
 <p:notes xmlns:a="http://schemas.openxmlformats.org/drawingml/2006/main" xmlns:r="http://schemas.openxmlformats.org/officeDocument/2006/relationships" xmlns:p="http://schemas.openxmlformats.org/presentationml/2006/main">
   <p:cSld>
     <p:spTree>
@@ -1086,7 +976,7 @@
           <a:p>
             <a:fld id="{17732C3C-A191-48C2-A7E8-9C96AF841A7A}" type="slidenum">
               <a:rPr lang="en-US" smtClean="0"/>
-              <a:t>24</a:t>
+              <a:t>21</a:t>
             </a:fld>
             <a:endParaRPr lang="en-US" dirty="0"/>
           </a:p>
@@ -1105,7 +995,7 @@
 </p:notes>
 </file>
 
-<file path=ppt/notesSlides/notesSlide13.xml><?xml version="1.0" encoding="utf-8"?>
+<file path=ppt/notesSlides/notesSlide12.xml><?xml version="1.0" encoding="utf-8"?>
 <p:notes xmlns:a="http://schemas.openxmlformats.org/drawingml/2006/main" xmlns:r="http://schemas.openxmlformats.org/officeDocument/2006/relationships" xmlns:p="http://schemas.openxmlformats.org/presentationml/2006/main">
   <p:cSld>
     <p:spTree>
@@ -1194,7 +1084,7 @@
           <a:p>
             <a:fld id="{17732C3C-A191-48C2-A7E8-9C96AF841A7A}" type="slidenum">
               <a:rPr lang="en-US" smtClean="0"/>
-              <a:t>25</a:t>
+              <a:t>22</a:t>
             </a:fld>
             <a:endParaRPr lang="en-US" dirty="0"/>
           </a:p>
@@ -1213,7 +1103,7 @@
 </p:notes>
 </file>
 
-<file path=ppt/notesSlides/notesSlide14.xml><?xml version="1.0" encoding="utf-8"?>
+<file path=ppt/notesSlides/notesSlide13.xml><?xml version="1.0" encoding="utf-8"?>
 <p:notes xmlns:a="http://schemas.openxmlformats.org/drawingml/2006/main" xmlns:r="http://schemas.openxmlformats.org/officeDocument/2006/relationships" xmlns:p="http://schemas.openxmlformats.org/presentationml/2006/main">
   <p:cSld>
     <p:spTree>
@@ -1302,7 +1192,7 @@
           <a:p>
             <a:fld id="{17732C3C-A191-48C2-A7E8-9C96AF841A7A}" type="slidenum">
               <a:rPr lang="en-US" smtClean="0"/>
-              <a:t>26</a:t>
+              <a:t>23</a:t>
             </a:fld>
             <a:endParaRPr lang="en-US" dirty="0"/>
           </a:p>
@@ -1321,7 +1211,7 @@
 </p:notes>
 </file>
 
-<file path=ppt/notesSlides/notesSlide15.xml><?xml version="1.0" encoding="utf-8"?>
+<file path=ppt/notesSlides/notesSlide14.xml><?xml version="1.0" encoding="utf-8"?>
 <p:notes xmlns:a="http://schemas.openxmlformats.org/drawingml/2006/main" xmlns:r="http://schemas.openxmlformats.org/officeDocument/2006/relationships" xmlns:p="http://schemas.openxmlformats.org/presentationml/2006/main">
   <p:cSld>
     <p:spTree>
@@ -1410,7 +1300,7 @@
           <a:p>
             <a:fld id="{17732C3C-A191-48C2-A7E8-9C96AF841A7A}" type="slidenum">
               <a:rPr lang="en-US" smtClean="0"/>
-              <a:t>27</a:t>
+              <a:t>24</a:t>
             </a:fld>
             <a:endParaRPr lang="en-US" dirty="0"/>
           </a:p>
@@ -1429,7 +1319,7 @@
 </p:notes>
 </file>
 
-<file path=ppt/notesSlides/notesSlide16.xml><?xml version="1.0" encoding="utf-8"?>
+<file path=ppt/notesSlides/notesSlide15.xml><?xml version="1.0" encoding="utf-8"?>
 <p:notes xmlns:a="http://schemas.openxmlformats.org/drawingml/2006/main" xmlns:r="http://schemas.openxmlformats.org/officeDocument/2006/relationships" xmlns:p="http://schemas.openxmlformats.org/presentationml/2006/main">
   <p:cSld>
     <p:spTree>
@@ -1518,7 +1408,7 @@
           <a:p>
             <a:fld id="{17732C3C-A191-48C2-A7E8-9C96AF841A7A}" type="slidenum">
               <a:rPr lang="en-US" smtClean="0"/>
-              <a:t>28</a:t>
+              <a:t>25</a:t>
             </a:fld>
             <a:endParaRPr lang="en-US" dirty="0"/>
           </a:p>
@@ -1537,7 +1427,7 @@
 </p:notes>
 </file>
 
-<file path=ppt/notesSlides/notesSlide17.xml><?xml version="1.0" encoding="utf-8"?>
+<file path=ppt/notesSlides/notesSlide16.xml><?xml version="1.0" encoding="utf-8"?>
 <p:notes xmlns:a="http://schemas.openxmlformats.org/drawingml/2006/main" xmlns:r="http://schemas.openxmlformats.org/officeDocument/2006/relationships" xmlns:p="http://schemas.openxmlformats.org/presentationml/2006/main">
   <p:cSld>
     <p:spTree>
@@ -1626,7 +1516,7 @@
           <a:p>
             <a:fld id="{17732C3C-A191-48C2-A7E8-9C96AF841A7A}" type="slidenum">
               <a:rPr lang="en-US" smtClean="0"/>
-              <a:t>31</a:t>
+              <a:t>29</a:t>
             </a:fld>
             <a:endParaRPr lang="en-US" dirty="0"/>
           </a:p>
@@ -1645,7 +1535,7 @@
 </p:notes>
 </file>
 
-<file path=ppt/notesSlides/notesSlide18.xml><?xml version="1.0" encoding="utf-8"?>
+<file path=ppt/notesSlides/notesSlide17.xml><?xml version="1.0" encoding="utf-8"?>
 <p:notes xmlns:a="http://schemas.openxmlformats.org/drawingml/2006/main" xmlns:r="http://schemas.openxmlformats.org/officeDocument/2006/relationships" xmlns:p="http://schemas.openxmlformats.org/presentationml/2006/main">
   <p:cSld>
     <p:spTree>
@@ -1734,7 +1624,7 @@
           <a:p>
             <a:fld id="{17732C3C-A191-48C2-A7E8-9C96AF841A7A}" type="slidenum">
               <a:rPr lang="en-US" smtClean="0"/>
-              <a:t>32</a:t>
+              <a:t>30</a:t>
             </a:fld>
             <a:endParaRPr lang="en-US" dirty="0"/>
           </a:p>
@@ -1753,7 +1643,7 @@
 </p:notes>
 </file>
 
-<file path=ppt/notesSlides/notesSlide19.xml><?xml version="1.0" encoding="utf-8"?>
+<file path=ppt/notesSlides/notesSlide18.xml><?xml version="1.0" encoding="utf-8"?>
 <p:notes xmlns:a="http://schemas.openxmlformats.org/drawingml/2006/main" xmlns:r="http://schemas.openxmlformats.org/officeDocument/2006/relationships" xmlns:p="http://schemas.openxmlformats.org/presentationml/2006/main">
   <p:cSld>
     <p:spTree>
@@ -1818,7 +1708,7 @@
           <a:p>
             <a:fld id="{17732C3C-A191-48C2-A7E8-9C96AF841A7A}" type="slidenum">
               <a:rPr lang="en-US" smtClean="0"/>
-              <a:t>33</a:t>
+              <a:t>31</a:t>
             </a:fld>
             <a:endParaRPr lang="en-US" dirty="0"/>
           </a:p>
@@ -2370,13 +2260,7 @@
   <p:cSld>
     <p:spTree>
       <p:nvGrpSpPr>
-        <p:cNvPr id="1" name="">
-          <a:extLst>
-            <a:ext uri="{FF2B5EF4-FFF2-40B4-BE49-F238E27FC236}">
-              <a16:creationId xmlns:a16="http://schemas.microsoft.com/office/drawing/2014/main" id="{6F7E32B0-5B22-0B9D-F726-89E26D66BD4C}"/>
-            </a:ext>
-          </a:extLst>
-        </p:cNvPr>
+        <p:cNvPr id="1" name=""/>
         <p:cNvGrpSpPr/>
         <p:nvPr/>
       </p:nvGrpSpPr>
@@ -2390,13 +2274,7 @@
       </p:grpSpPr>
       <p:sp>
         <p:nvSpPr>
-          <p:cNvPr id="2" name="Slide Image Placeholder 1">
-            <a:extLst>
-              <a:ext uri="{FF2B5EF4-FFF2-40B4-BE49-F238E27FC236}">
-                <a16:creationId xmlns:a16="http://schemas.microsoft.com/office/drawing/2014/main" id="{3C1E99AC-5193-A00B-3A3C-A42DA089B7CE}"/>
-              </a:ext>
-            </a:extLst>
-          </p:cNvPr>
+          <p:cNvPr id="2" name="Slide Image Placeholder 1"/>
           <p:cNvSpPr>
             <a:spLocks noGrp="1" noRot="1" noChangeAspect="1"/>
           </p:cNvSpPr>
@@ -2408,13 +2286,7 @@
       </p:sp>
       <p:sp>
         <p:nvSpPr>
-          <p:cNvPr id="3" name="Notes Placeholder 2">
-            <a:extLst>
-              <a:ext uri="{FF2B5EF4-FFF2-40B4-BE49-F238E27FC236}">
-                <a16:creationId xmlns:a16="http://schemas.microsoft.com/office/drawing/2014/main" id="{CB4449AA-6890-A55A-D2A7-148C5B836BD8}"/>
-              </a:ext>
-            </a:extLst>
-          </p:cNvPr>
+          <p:cNvPr id="3" name="Notes Placeholder 2"/>
           <p:cNvSpPr>
             <a:spLocks noGrp="1"/>
           </p:cNvSpPr>
@@ -2427,19 +2299,13 @@
           <a:bodyPr/>
           <a:lstStyle/>
           <a:p>
-            <a:endParaRPr lang="en-US" dirty="0"/>
-          </a:p>
-        </p:txBody>
-      </p:sp>
-      <p:sp>
-        <p:nvSpPr>
-          <p:cNvPr id="4" name="Slide Number Placeholder 3">
-            <a:extLst>
-              <a:ext uri="{FF2B5EF4-FFF2-40B4-BE49-F238E27FC236}">
-                <a16:creationId xmlns:a16="http://schemas.microsoft.com/office/drawing/2014/main" id="{DFDE574A-1E71-A96F-A060-2FDD5B0D0B85}"/>
-              </a:ext>
-            </a:extLst>
-          </p:cNvPr>
+            <a:endParaRPr lang="en-ZA" dirty="0"/>
+          </a:p>
+        </p:txBody>
+      </p:sp>
+      <p:sp>
+        <p:nvSpPr>
+          <p:cNvPr id="4" name="Slide Number Placeholder 3"/>
           <p:cNvSpPr>
             <a:spLocks noGrp="1"/>
           </p:cNvSpPr>
@@ -2454,7 +2320,7 @@
           <a:p>
             <a:fld id="{17732C3C-A191-48C2-A7E8-9C96AF841A7A}" type="slidenum">
               <a:rPr lang="en-US" smtClean="0"/>
-              <a:t>20</a:t>
+              <a:t>9</a:t>
             </a:fld>
             <a:endParaRPr lang="en-US" dirty="0"/>
           </a:p>
@@ -2463,7 +2329,7 @@
     </p:spTree>
     <p:extLst>
       <p:ext uri="{BB962C8B-B14F-4D97-AF65-F5344CB8AC3E}">
-        <p14:creationId xmlns:p14="http://schemas.microsoft.com/office/powerpoint/2010/main" val="2739344512"/>
+        <p14:creationId xmlns:p14="http://schemas.microsoft.com/office/powerpoint/2010/main" val="4085080008"/>
       </p:ext>
     </p:extLst>
   </p:cSld>
@@ -2481,7 +2347,7 @@
         <p:cNvPr id="1" name="">
           <a:extLst>
             <a:ext uri="{FF2B5EF4-FFF2-40B4-BE49-F238E27FC236}">
-              <a16:creationId xmlns:a16="http://schemas.microsoft.com/office/drawing/2014/main" id="{BA0FBEEF-C417-1E21-91EC-D71DC294992C}"/>
+              <a16:creationId xmlns:a16="http://schemas.microsoft.com/office/drawing/2014/main" id="{EF245ACA-3B56-E9B1-EE13-D68F3AEE294B}"/>
             </a:ext>
           </a:extLst>
         </p:cNvPr>
@@ -2501,7 +2367,7 @@
           <p:cNvPr id="2" name="Slide Image Placeholder 1">
             <a:extLst>
               <a:ext uri="{FF2B5EF4-FFF2-40B4-BE49-F238E27FC236}">
-                <a16:creationId xmlns:a16="http://schemas.microsoft.com/office/drawing/2014/main" id="{1A953E08-01CF-F1B3-51DD-7852965E9842}"/>
+                <a16:creationId xmlns:a16="http://schemas.microsoft.com/office/drawing/2014/main" id="{183F2BBE-65E7-E4A8-060F-E1AB94CEA416}"/>
               </a:ext>
             </a:extLst>
           </p:cNvPr>
@@ -2519,7 +2385,7 @@
           <p:cNvPr id="3" name="Notes Placeholder 2">
             <a:extLst>
               <a:ext uri="{FF2B5EF4-FFF2-40B4-BE49-F238E27FC236}">
-                <a16:creationId xmlns:a16="http://schemas.microsoft.com/office/drawing/2014/main" id="{317F96A9-F803-79C3-3766-95275236C148}"/>
+                <a16:creationId xmlns:a16="http://schemas.microsoft.com/office/drawing/2014/main" id="{4F62BAD7-28E7-6B8C-7235-303E26AD8479}"/>
               </a:ext>
             </a:extLst>
           </p:cNvPr>
@@ -2544,7 +2410,7 @@
           <p:cNvPr id="4" name="Slide Number Placeholder 3">
             <a:extLst>
               <a:ext uri="{FF2B5EF4-FFF2-40B4-BE49-F238E27FC236}">
-                <a16:creationId xmlns:a16="http://schemas.microsoft.com/office/drawing/2014/main" id="{84022E55-8423-BC33-BD13-B2E1C2B27A22}"/>
+                <a16:creationId xmlns:a16="http://schemas.microsoft.com/office/drawing/2014/main" id="{ECE99653-8655-6102-6B87-4350DFDD2CDB}"/>
               </a:ext>
             </a:extLst>
           </p:cNvPr>
@@ -2562,7 +2428,7 @@
           <a:p>
             <a:fld id="{17732C3C-A191-48C2-A7E8-9C96AF841A7A}" type="slidenum">
               <a:rPr lang="en-US" smtClean="0"/>
-              <a:t>21</a:t>
+              <a:t>19</a:t>
             </a:fld>
             <a:endParaRPr lang="en-US" dirty="0"/>
           </a:p>
@@ -2571,7 +2437,7 @@
     </p:spTree>
     <p:extLst>
       <p:ext uri="{BB962C8B-B14F-4D97-AF65-F5344CB8AC3E}">
-        <p14:creationId xmlns:p14="http://schemas.microsoft.com/office/powerpoint/2010/main" val="2398792446"/>
+        <p14:creationId xmlns:p14="http://schemas.microsoft.com/office/powerpoint/2010/main" val="1872019951"/>
       </p:ext>
     </p:extLst>
   </p:cSld>
@@ -8437,7 +8303,7 @@
           <a:p>
             <a:fld id="{86F7BD38-A805-4B2C-9BDF-D56E94387879}" type="datetime1">
               <a:rPr lang="en-US" smtClean="0"/>
-              <a:t>10/27/2026</a:t>
+              <a:t>11/1/2026</a:t>
             </a:fld>
             <a:endParaRPr lang="en-US" dirty="0"/>
           </a:p>
@@ -9053,7 +8919,7 @@
         <p:cNvPr id="1" name="">
           <a:extLst>
             <a:ext uri="{FF2B5EF4-FFF2-40B4-BE49-F238E27FC236}">
-              <a16:creationId xmlns:a16="http://schemas.microsoft.com/office/drawing/2014/main" id="{0D086A51-AFEF-F42E-BFB5-65545E543311}"/>
+              <a16:creationId xmlns:a16="http://schemas.microsoft.com/office/drawing/2014/main" id="{371509B3-3068-87A2-C9FC-0CA0D12C6094}"/>
             </a:ext>
           </a:extLst>
         </p:cNvPr>
@@ -9073,7 +8939,7 @@
           <p:cNvPr id="2" name="Title 1">
             <a:extLst>
               <a:ext uri="{FF2B5EF4-FFF2-40B4-BE49-F238E27FC236}">
-                <a16:creationId xmlns:a16="http://schemas.microsoft.com/office/drawing/2014/main" id="{A5D0654D-BAA9-4383-8C36-F9F56988D298}"/>
+                <a16:creationId xmlns:a16="http://schemas.microsoft.com/office/drawing/2014/main" id="{DB0D614A-62D4-CAE6-091C-6CEAAACD4B2D}"/>
               </a:ext>
             </a:extLst>
           </p:cNvPr>
@@ -9084,14 +8950,19 @@
             <p:ph type="title"/>
           </p:nvPr>
         </p:nvSpPr>
-        <p:spPr/>
+        <p:spPr>
+          <a:xfrm>
+            <a:off x="6651097" y="422551"/>
+            <a:ext cx="5302778" cy="563930"/>
+          </a:xfrm>
+        </p:spPr>
         <p:txBody>
           <a:bodyPr/>
           <a:lstStyle/>
           <a:p>
             <a:r>
               <a:rPr lang="en-ZA" noProof="0" dirty="0"/>
-              <a:t>Composite 1</a:t>
+              <a:t>Visitor</a:t>
             </a:r>
           </a:p>
         </p:txBody>
@@ -9101,7 +8972,7 @@
           <p:cNvPr id="3" name="Content Placeholder 2">
             <a:extLst>
               <a:ext uri="{FF2B5EF4-FFF2-40B4-BE49-F238E27FC236}">
-                <a16:creationId xmlns:a16="http://schemas.microsoft.com/office/drawing/2014/main" id="{4944273A-1F30-01D9-9A95-1509553BF907}"/>
+                <a16:creationId xmlns:a16="http://schemas.microsoft.com/office/drawing/2014/main" id="{015F2D93-D18E-F4C4-8BFB-A98F6253374C}"/>
               </a:ext>
             </a:extLst>
           </p:cNvPr>
@@ -9115,7 +8986,7 @@
         <p:spPr/>
         <p:txBody>
           <a:bodyPr>
-            <a:normAutofit lnSpcReduction="10000"/>
+            <a:normAutofit/>
           </a:bodyPr>
           <a:lstStyle/>
           <a:p>
@@ -9129,7 +9000,7 @@
             <a:pPr lvl="0"/>
             <a:r>
               <a:rPr lang="en-ZA" noProof="0" dirty="0"/>
-              <a:t>Provide a recursive tree-like structure to store Workflows and Work Items to be worked upon.</a:t>
+              <a:t>Provides methods that use double dispatch to operate on the state Booleans of Work Items and Workflows in different ways.</a:t>
             </a:r>
           </a:p>
           <a:p>
@@ -9142,9 +9013,10 @@
           <a:p>
             <a:pPr lvl="0"/>
             <a:r>
-              <a:rPr lang="en-ZA" noProof="0" dirty="0"/>
-              <a:t>A workflow can consist of multiple smaller workflows, both containing work items.</a:t>
-            </a:r>
+              <a:rPr lang="en-ZA" dirty="0"/>
+              <a:t>Components of Workflows differ in what they contain and what they do while still being similar in state. Visitor allows operations on the Booleans to match intent but cater to differences.</a:t>
+            </a:r>
+            <a:endParaRPr lang="en-ZA" noProof="0" dirty="0"/>
           </a:p>
           <a:p>
             <a:pPr lvl="0"/>
@@ -9157,20 +9029,17 @@
             <a:pPr lvl="0"/>
             <a:r>
               <a:rPr lang="en-ZA" noProof="0" dirty="0"/>
-              <a:t>Works alongside Façade to change its States, Memento to store snapshots of its states, Participant Composite to do work on work items, Observer to notify other patterns upon change, Decorator to provide addition functionality, and Iterator to traverse the tree.</a:t>
-            </a:r>
-          </a:p>
-          <a:p>
-            <a:endParaRPr lang="en-ZA" noProof="0" dirty="0"/>
+              <a:t>Instantiated in the Workflow Composite to provide double dispatching per Leaf or Composite.</a:t>
+            </a:r>
           </a:p>
         </p:txBody>
       </p:sp>
       <p:pic>
         <p:nvPicPr>
-          <p:cNvPr id="5" name="Picture 4">
-            <a:extLst>
-              <a:ext uri="{FF2B5EF4-FFF2-40B4-BE49-F238E27FC236}">
-                <a16:creationId xmlns:a16="http://schemas.microsoft.com/office/drawing/2014/main" id="{7BCCFC73-6917-63F6-9CBD-AEAE3E7FBA16}"/>
+          <p:cNvPr id="20" name="Picture 19">
+            <a:extLst>
+              <a:ext uri="{FF2B5EF4-FFF2-40B4-BE49-F238E27FC236}">
+                <a16:creationId xmlns:a16="http://schemas.microsoft.com/office/drawing/2014/main" id="{DE910F19-6FE3-1069-68E5-4248592ABD41}"/>
               </a:ext>
             </a:extLst>
           </p:cNvPr>
@@ -9187,8 +9056,158 @@
         </p:blipFill>
         <p:spPr>
           <a:xfrm>
-            <a:off x="620415" y="1147366"/>
-            <a:ext cx="4751685" cy="4563267"/>
+            <a:off x="1852411" y="986481"/>
+            <a:ext cx="2300489" cy="860727"/>
+          </a:xfrm>
+          <a:prstGeom prst="rect">
+            <a:avLst/>
+          </a:prstGeom>
+        </p:spPr>
+      </p:pic>
+      <p:pic>
+        <p:nvPicPr>
+          <p:cNvPr id="22" name="Picture 21">
+            <a:extLst>
+              <a:ext uri="{FF2B5EF4-FFF2-40B4-BE49-F238E27FC236}">
+                <a16:creationId xmlns:a16="http://schemas.microsoft.com/office/drawing/2014/main" id="{E6FE96D6-4D38-3F2B-47A7-EDD6828AC278}"/>
+              </a:ext>
+            </a:extLst>
+          </p:cNvPr>
+          <p:cNvPicPr>
+            <a:picLocks noChangeAspect="1"/>
+          </p:cNvPicPr>
+          <p:nvPr/>
+        </p:nvPicPr>
+        <p:blipFill>
+          <a:blip r:embed="rId3"/>
+          <a:stretch>
+            <a:fillRect/>
+          </a:stretch>
+        </p:blipFill>
+        <p:spPr>
+          <a:xfrm>
+            <a:off x="523676" y="3610796"/>
+            <a:ext cx="2300489" cy="845078"/>
+          </a:xfrm>
+          <a:prstGeom prst="rect">
+            <a:avLst/>
+          </a:prstGeom>
+        </p:spPr>
+      </p:pic>
+      <p:pic>
+        <p:nvPicPr>
+          <p:cNvPr id="24" name="Picture 23">
+            <a:extLst>
+              <a:ext uri="{FF2B5EF4-FFF2-40B4-BE49-F238E27FC236}">
+                <a16:creationId xmlns:a16="http://schemas.microsoft.com/office/drawing/2014/main" id="{E8D9F76E-CB45-096E-5E4C-71151E07A130}"/>
+              </a:ext>
+            </a:extLst>
+          </p:cNvPr>
+          <p:cNvPicPr>
+            <a:picLocks noChangeAspect="1"/>
+          </p:cNvPicPr>
+          <p:nvPr/>
+        </p:nvPicPr>
+        <p:blipFill>
+          <a:blip r:embed="rId4"/>
+          <a:stretch>
+            <a:fillRect/>
+          </a:stretch>
+        </p:blipFill>
+        <p:spPr>
+          <a:xfrm>
+            <a:off x="504623" y="2440359"/>
+            <a:ext cx="2316139" cy="837253"/>
+          </a:xfrm>
+          <a:prstGeom prst="rect">
+            <a:avLst/>
+          </a:prstGeom>
+        </p:spPr>
+      </p:pic>
+      <p:pic>
+        <p:nvPicPr>
+          <p:cNvPr id="26" name="Picture 25">
+            <a:extLst>
+              <a:ext uri="{FF2B5EF4-FFF2-40B4-BE49-F238E27FC236}">
+                <a16:creationId xmlns:a16="http://schemas.microsoft.com/office/drawing/2014/main" id="{8B42F42A-8BA1-83EA-0EE9-40A7E62A7333}"/>
+              </a:ext>
+            </a:extLst>
+          </p:cNvPr>
+          <p:cNvPicPr>
+            <a:picLocks noChangeAspect="1"/>
+          </p:cNvPicPr>
+          <p:nvPr/>
+        </p:nvPicPr>
+        <p:blipFill>
+          <a:blip r:embed="rId5"/>
+          <a:stretch>
+            <a:fillRect/>
+          </a:stretch>
+        </p:blipFill>
+        <p:spPr>
+          <a:xfrm>
+            <a:off x="1747837" y="5027254"/>
+            <a:ext cx="2308314" cy="821604"/>
+          </a:xfrm>
+          <a:prstGeom prst="rect">
+            <a:avLst/>
+          </a:prstGeom>
+        </p:spPr>
+      </p:pic>
+      <p:pic>
+        <p:nvPicPr>
+          <p:cNvPr id="28" name="Picture 27">
+            <a:extLst>
+              <a:ext uri="{FF2B5EF4-FFF2-40B4-BE49-F238E27FC236}">
+                <a16:creationId xmlns:a16="http://schemas.microsoft.com/office/drawing/2014/main" id="{227549BD-A0CA-AA13-F4AC-4F617B78CE40}"/>
+              </a:ext>
+            </a:extLst>
+          </p:cNvPr>
+          <p:cNvPicPr>
+            <a:picLocks noChangeAspect="1"/>
+          </p:cNvPicPr>
+          <p:nvPr/>
+        </p:nvPicPr>
+        <p:blipFill>
+          <a:blip r:embed="rId6"/>
+          <a:stretch>
+            <a:fillRect/>
+          </a:stretch>
+        </p:blipFill>
+        <p:spPr>
+          <a:xfrm>
+            <a:off x="3062076" y="3634270"/>
+            <a:ext cx="2316139" cy="821604"/>
+          </a:xfrm>
+          <a:prstGeom prst="rect">
+            <a:avLst/>
+          </a:prstGeom>
+        </p:spPr>
+      </p:pic>
+      <p:pic>
+        <p:nvPicPr>
+          <p:cNvPr id="30" name="Picture 29">
+            <a:extLst>
+              <a:ext uri="{FF2B5EF4-FFF2-40B4-BE49-F238E27FC236}">
+                <a16:creationId xmlns:a16="http://schemas.microsoft.com/office/drawing/2014/main" id="{0AE8986A-3C99-BF64-C9A9-7B65FA645B47}"/>
+              </a:ext>
+            </a:extLst>
+          </p:cNvPr>
+          <p:cNvPicPr>
+            <a:picLocks noChangeAspect="1"/>
+          </p:cNvPicPr>
+          <p:nvPr/>
+        </p:nvPicPr>
+        <p:blipFill>
+          <a:blip r:embed="rId7"/>
+          <a:stretch>
+            <a:fillRect/>
+          </a:stretch>
+        </p:blipFill>
+        <p:spPr>
+          <a:xfrm>
+            <a:off x="3085893" y="2470298"/>
+            <a:ext cx="2308314" cy="821604"/>
           </a:xfrm>
           <a:prstGeom prst="rect">
             <a:avLst/>
@@ -9198,7 +9217,7 @@
     </p:spTree>
     <p:extLst>
       <p:ext uri="{BB962C8B-B14F-4D97-AF65-F5344CB8AC3E}">
-        <p14:creationId xmlns:p14="http://schemas.microsoft.com/office/powerpoint/2010/main" val="2478020933"/>
+        <p14:creationId xmlns:p14="http://schemas.microsoft.com/office/powerpoint/2010/main" val="3139366889"/>
       </p:ext>
     </p:extLst>
   </p:cSld>
@@ -9209,6 +9228,213 @@
 </file>
 
 <file path=ppt/slides/slide11.xml><?xml version="1.0" encoding="utf-8"?>
+<p:sld xmlns:a="http://schemas.openxmlformats.org/drawingml/2006/main" xmlns:r="http://schemas.openxmlformats.org/officeDocument/2006/relationships" xmlns:p="http://schemas.openxmlformats.org/presentationml/2006/main">
+  <p:cSld>
+    <p:spTree>
+      <p:nvGrpSpPr>
+        <p:cNvPr id="1" name="">
+          <a:extLst>
+            <a:ext uri="{FF2B5EF4-FFF2-40B4-BE49-F238E27FC236}">
+              <a16:creationId xmlns:a16="http://schemas.microsoft.com/office/drawing/2014/main" id="{4821863A-9F16-28AC-0CF2-F43AABA963B0}"/>
+            </a:ext>
+          </a:extLst>
+        </p:cNvPr>
+        <p:cNvGrpSpPr/>
+        <p:nvPr/>
+      </p:nvGrpSpPr>
+      <p:grpSpPr>
+        <a:xfrm>
+          <a:off x="0" y="0"/>
+          <a:ext cx="0" cy="0"/>
+          <a:chOff x="0" y="0"/>
+          <a:chExt cx="0" cy="0"/>
+        </a:xfrm>
+      </p:grpSpPr>
+      <p:sp>
+        <p:nvSpPr>
+          <p:cNvPr id="2" name="Title 1">
+            <a:extLst>
+              <a:ext uri="{FF2B5EF4-FFF2-40B4-BE49-F238E27FC236}">
+                <a16:creationId xmlns:a16="http://schemas.microsoft.com/office/drawing/2014/main" id="{68DAEA9A-8AA5-711C-6EFC-C92AAD1E78B1}"/>
+              </a:ext>
+            </a:extLst>
+          </p:cNvPr>
+          <p:cNvSpPr>
+            <a:spLocks noGrp="1"/>
+          </p:cNvSpPr>
+          <p:nvPr>
+            <p:ph type="title"/>
+          </p:nvPr>
+        </p:nvSpPr>
+        <p:spPr/>
+        <p:txBody>
+          <a:bodyPr/>
+          <a:lstStyle/>
+          <a:p>
+            <a:r>
+              <a:rPr lang="en-ZA" noProof="0" dirty="0"/>
+              <a:t>Memento</a:t>
+            </a:r>
+          </a:p>
+        </p:txBody>
+      </p:sp>
+      <p:sp>
+        <p:nvSpPr>
+          <p:cNvPr id="3" name="Content Placeholder 2">
+            <a:extLst>
+              <a:ext uri="{FF2B5EF4-FFF2-40B4-BE49-F238E27FC236}">
+                <a16:creationId xmlns:a16="http://schemas.microsoft.com/office/drawing/2014/main" id="{D8FB1B4E-0018-68AB-F987-6978ED6249D0}"/>
+              </a:ext>
+            </a:extLst>
+          </p:cNvPr>
+          <p:cNvSpPr>
+            <a:spLocks noGrp="1"/>
+          </p:cNvSpPr>
+          <p:nvPr>
+            <p:ph sz="quarter" idx="10"/>
+          </p:nvPr>
+        </p:nvSpPr>
+        <p:spPr/>
+        <p:txBody>
+          <a:bodyPr>
+            <a:normAutofit fontScale="92500"/>
+          </a:bodyPr>
+          <a:lstStyle/>
+          <a:p>
+            <a:pPr lvl="0"/>
+            <a:r>
+              <a:rPr lang="en-ZA" b="1" noProof="0" dirty="0"/>
+              <a:t>Role:</a:t>
+            </a:r>
+          </a:p>
+          <a:p>
+            <a:pPr lvl="0"/>
+            <a:r>
+              <a:rPr lang="en-ZA" noProof="0" dirty="0"/>
+              <a:t>Saves a snapshot of the current version of the system.</a:t>
+            </a:r>
+          </a:p>
+          <a:p>
+            <a:pPr lvl="0"/>
+            <a:r>
+              <a:rPr lang="en-ZA" noProof="0" dirty="0"/>
+              <a:t>Provides version history.</a:t>
+            </a:r>
+          </a:p>
+          <a:p>
+            <a:pPr lvl="0"/>
+            <a:r>
+              <a:rPr lang="en-ZA" b="1" noProof="0" dirty="0"/>
+              <a:t>Reason: </a:t>
+            </a:r>
+          </a:p>
+          <a:p>
+            <a:pPr lvl="0"/>
+            <a:r>
+              <a:rPr lang="en-ZA" noProof="0" dirty="0"/>
+              <a:t>Often people give way to human error. Allows easy restoration after a mistake. </a:t>
+            </a:r>
+          </a:p>
+          <a:p>
+            <a:pPr lvl="0"/>
+            <a:r>
+              <a:rPr lang="en-ZA" noProof="0" dirty="0"/>
+              <a:t>Memento tracks a process history so it can be documented throughout its lifecycle.</a:t>
+            </a:r>
+          </a:p>
+          <a:p>
+            <a:pPr lvl="0"/>
+            <a:r>
+              <a:rPr lang="en-ZA" b="1" noProof="0" dirty="0"/>
+              <a:t>Relationships: </a:t>
+            </a:r>
+          </a:p>
+          <a:p>
+            <a:pPr lvl="0"/>
+            <a:r>
+              <a:rPr lang="en-ZA" noProof="0" dirty="0"/>
+              <a:t>Works alongside Façade so versions can easily be saved, regressed or retrieved. Records State of the Workflow Composite. Uses Iterator to traverse version histories.</a:t>
+            </a:r>
+          </a:p>
+          <a:p>
+            <a:endParaRPr lang="en-ZA" noProof="0" dirty="0"/>
+          </a:p>
+        </p:txBody>
+      </p:sp>
+      <p:pic>
+        <p:nvPicPr>
+          <p:cNvPr id="8" name="Picture 7">
+            <a:extLst>
+              <a:ext uri="{FF2B5EF4-FFF2-40B4-BE49-F238E27FC236}">
+                <a16:creationId xmlns:a16="http://schemas.microsoft.com/office/drawing/2014/main" id="{2AA94C2B-CB4D-38B4-F289-15D835F48E0B}"/>
+              </a:ext>
+            </a:extLst>
+          </p:cNvPr>
+          <p:cNvPicPr>
+            <a:picLocks noChangeAspect="1"/>
+          </p:cNvPicPr>
+          <p:nvPr/>
+        </p:nvPicPr>
+        <p:blipFill>
+          <a:blip r:embed="rId2"/>
+          <a:stretch>
+            <a:fillRect/>
+          </a:stretch>
+        </p:blipFill>
+        <p:spPr>
+          <a:xfrm>
+            <a:off x="623404" y="4052044"/>
+            <a:ext cx="4662972" cy="1400811"/>
+          </a:xfrm>
+          <a:prstGeom prst="rect">
+            <a:avLst/>
+          </a:prstGeom>
+        </p:spPr>
+      </p:pic>
+      <p:pic>
+        <p:nvPicPr>
+          <p:cNvPr id="10" name="Picture 9">
+            <a:extLst>
+              <a:ext uri="{FF2B5EF4-FFF2-40B4-BE49-F238E27FC236}">
+                <a16:creationId xmlns:a16="http://schemas.microsoft.com/office/drawing/2014/main" id="{C0D630AE-D0C9-6E78-0376-F7DCA95193A2}"/>
+              </a:ext>
+            </a:extLst>
+          </p:cNvPr>
+          <p:cNvPicPr>
+            <a:picLocks noChangeAspect="1"/>
+          </p:cNvPicPr>
+          <p:nvPr/>
+        </p:nvPicPr>
+        <p:blipFill>
+          <a:blip r:embed="rId3"/>
+          <a:stretch>
+            <a:fillRect/>
+          </a:stretch>
+        </p:blipFill>
+        <p:spPr>
+          <a:xfrm>
+            <a:off x="1054387" y="1895402"/>
+            <a:ext cx="3801005" cy="1047896"/>
+          </a:xfrm>
+          <a:prstGeom prst="rect">
+            <a:avLst/>
+          </a:prstGeom>
+        </p:spPr>
+      </p:pic>
+    </p:spTree>
+    <p:extLst>
+      <p:ext uri="{BB962C8B-B14F-4D97-AF65-F5344CB8AC3E}">
+        <p14:creationId xmlns:p14="http://schemas.microsoft.com/office/powerpoint/2010/main" val="1447967475"/>
+      </p:ext>
+    </p:extLst>
+  </p:cSld>
+  <p:clrMapOvr>
+    <a:masterClrMapping/>
+  </p:clrMapOvr>
+</p:sld>
+</file>
+
+<file path=ppt/slides/slide12.xml><?xml version="1.0" encoding="utf-8"?>
 <p:sld xmlns:a="http://schemas.openxmlformats.org/drawingml/2006/main" xmlns:r="http://schemas.openxmlformats.org/officeDocument/2006/relationships" xmlns:p="http://schemas.openxmlformats.org/presentationml/2006/main">
   <p:cSld>
     <p:spTree>
@@ -9330,10 +9556,10 @@
       </p:sp>
       <p:pic>
         <p:nvPicPr>
-          <p:cNvPr id="6" name="Picture 5">
-            <a:extLst>
-              <a:ext uri="{FF2B5EF4-FFF2-40B4-BE49-F238E27FC236}">
-                <a16:creationId xmlns:a16="http://schemas.microsoft.com/office/drawing/2014/main" id="{78928B44-E853-90DC-2CA3-26903A51068C}"/>
+          <p:cNvPr id="5" name="Picture 4">
+            <a:extLst>
+              <a:ext uri="{FF2B5EF4-FFF2-40B4-BE49-F238E27FC236}">
+                <a16:creationId xmlns:a16="http://schemas.microsoft.com/office/drawing/2014/main" id="{21EB1AEA-1E20-5471-CC32-0082950DE596}"/>
               </a:ext>
             </a:extLst>
           </p:cNvPr>
@@ -9350,8 +9576,68 @@
         </p:blipFill>
         <p:spPr>
           <a:xfrm>
-            <a:off x="594680" y="2009774"/>
-            <a:ext cx="4828921" cy="2838451"/>
+            <a:off x="498709" y="704516"/>
+            <a:ext cx="3073997" cy="3198125"/>
+          </a:xfrm>
+          <a:prstGeom prst="rect">
+            <a:avLst/>
+          </a:prstGeom>
+        </p:spPr>
+      </p:pic>
+      <p:pic>
+        <p:nvPicPr>
+          <p:cNvPr id="8" name="Picture 7">
+            <a:extLst>
+              <a:ext uri="{FF2B5EF4-FFF2-40B4-BE49-F238E27FC236}">
+                <a16:creationId xmlns:a16="http://schemas.microsoft.com/office/drawing/2014/main" id="{1B5EF201-490F-3E7A-702E-146213991C1F}"/>
+              </a:ext>
+            </a:extLst>
+          </p:cNvPr>
+          <p:cNvPicPr>
+            <a:picLocks noChangeAspect="1"/>
+          </p:cNvPicPr>
+          <p:nvPr/>
+        </p:nvPicPr>
+        <p:blipFill>
+          <a:blip r:embed="rId3"/>
+          <a:stretch>
+            <a:fillRect/>
+          </a:stretch>
+        </p:blipFill>
+        <p:spPr>
+          <a:xfrm>
+            <a:off x="3634014" y="1895652"/>
+            <a:ext cx="1832716" cy="1387315"/>
+          </a:xfrm>
+          <a:prstGeom prst="rect">
+            <a:avLst/>
+          </a:prstGeom>
+        </p:spPr>
+      </p:pic>
+      <p:pic>
+        <p:nvPicPr>
+          <p:cNvPr id="10" name="Picture 9">
+            <a:extLst>
+              <a:ext uri="{FF2B5EF4-FFF2-40B4-BE49-F238E27FC236}">
+                <a16:creationId xmlns:a16="http://schemas.microsoft.com/office/drawing/2014/main" id="{7210501A-32AE-1F4A-1072-BA8B6C992A48}"/>
+              </a:ext>
+            </a:extLst>
+          </p:cNvPr>
+          <p:cNvPicPr>
+            <a:picLocks noChangeAspect="1"/>
+          </p:cNvPicPr>
+          <p:nvPr/>
+        </p:nvPicPr>
+        <p:blipFill>
+          <a:blip r:embed="rId4"/>
+          <a:stretch>
+            <a:fillRect/>
+          </a:stretch>
+        </p:blipFill>
+        <p:spPr>
+          <a:xfrm>
+            <a:off x="1595644" y="4050607"/>
+            <a:ext cx="3117807" cy="2102877"/>
           </a:xfrm>
           <a:prstGeom prst="rect">
             <a:avLst/>
@@ -9371,7 +9657,7 @@
 </p:sld>
 </file>
 
-<file path=ppt/slides/slide12.xml><?xml version="1.0" encoding="utf-8"?>
+<file path=ppt/slides/slide13.xml><?xml version="1.0" encoding="utf-8"?>
 <p:sld xmlns:a="http://schemas.openxmlformats.org/drawingml/2006/main" xmlns:r="http://schemas.openxmlformats.org/officeDocument/2006/relationships" xmlns:p="http://schemas.openxmlformats.org/presentationml/2006/main">
   <p:cSld>
     <p:spTree>
@@ -9441,7 +9727,7 @@
         <p:spPr/>
         <p:txBody>
           <a:bodyPr>
-            <a:normAutofit fontScale="92500"/>
+            <a:normAutofit/>
           </a:bodyPr>
           <a:lstStyle/>
           <a:p>
@@ -9455,15 +9741,7 @@
             <a:pPr lvl="0"/>
             <a:r>
               <a:rPr lang="en-ZA" noProof="0" dirty="0"/>
-              <a:t>Provide a means to notify all involved classes when a change occurs within a </a:t>
-            </a:r>
-            <a:r>
-              <a:rPr lang="en-ZA" noProof="0" dirty="0" err="1"/>
-              <a:t>WorkFlowComponent</a:t>
-            </a:r>
-            <a:r>
-              <a:rPr lang="en-ZA" noProof="0" dirty="0"/>
-              <a:t>.</a:t>
+              <a:t>Provides an Event registry for user-defined events that update all associated Workflow Components.</a:t>
             </a:r>
           </a:p>
           <a:p>
@@ -9476,9 +9754,10 @@
           <a:p>
             <a:pPr lvl="0"/>
             <a:r>
-              <a:rPr lang="en-ZA" noProof="0" dirty="0"/>
-              <a:t>A Workflow should be in sync with its work items. When either are changed all classes depending on them need to know to react.</a:t>
-            </a:r>
+              <a:rPr lang="en-ZA" dirty="0"/>
+              <a:t>Workflows would have specific circumstances where a factor occurs that causes certain workflows or work items to change state.</a:t>
+            </a:r>
+            <a:endParaRPr lang="en-ZA" noProof="0" dirty="0"/>
           </a:p>
           <a:p>
             <a:pPr lvl="0"/>
@@ -9491,8 +9770,17 @@
             <a:pPr lvl="0"/>
             <a:r>
               <a:rPr lang="en-ZA" noProof="0" dirty="0"/>
-              <a:t>Works alongside Façade to notify the user of any changes, Workflow Composite to update and notify components, Adapter to update non-attached classes to changes, and Chain of responsibility to allow an update if necessary. </a:t>
-            </a:r>
+              <a:t>Works alongside Façade to notify the user of any changes, when a certain event occurs, as well as handlers so that they might respond to the event according</a:t>
+            </a:r>
+            <a:r>
+              <a:rPr lang="en-ZA" dirty="0" err="1"/>
+              <a:t>ly</a:t>
+            </a:r>
+            <a:r>
+              <a:rPr lang="en-ZA" dirty="0"/>
+              <a:t>. </a:t>
+            </a:r>
+            <a:endParaRPr lang="en-ZA" noProof="0" dirty="0"/>
           </a:p>
           <a:p>
             <a:endParaRPr lang="en-ZA" noProof="0" dirty="0"/>
@@ -9501,10 +9789,10 @@
       </p:sp>
       <p:pic>
         <p:nvPicPr>
-          <p:cNvPr id="5" name="Picture 4">
-            <a:extLst>
-              <a:ext uri="{FF2B5EF4-FFF2-40B4-BE49-F238E27FC236}">
-                <a16:creationId xmlns:a16="http://schemas.microsoft.com/office/drawing/2014/main" id="{75C2ED3C-F25A-76F7-6043-25632F73C0C9}"/>
+          <p:cNvPr id="6" name="Picture 5">
+            <a:extLst>
+              <a:ext uri="{FF2B5EF4-FFF2-40B4-BE49-F238E27FC236}">
+                <a16:creationId xmlns:a16="http://schemas.microsoft.com/office/drawing/2014/main" id="{C12E6D08-9BED-64DB-653C-CAFE9E3C871A}"/>
               </a:ext>
             </a:extLst>
           </p:cNvPr>
@@ -9521,8 +9809,128 @@
         </p:blipFill>
         <p:spPr>
           <a:xfrm>
-            <a:off x="485775" y="2282232"/>
-            <a:ext cx="5029200" cy="2293536"/>
+            <a:off x="878719" y="3148989"/>
+            <a:ext cx="3107187" cy="1862856"/>
+          </a:xfrm>
+          <a:prstGeom prst="rect">
+            <a:avLst/>
+          </a:prstGeom>
+        </p:spPr>
+      </p:pic>
+      <p:pic>
+        <p:nvPicPr>
+          <p:cNvPr id="8" name="Picture 7">
+            <a:extLst>
+              <a:ext uri="{FF2B5EF4-FFF2-40B4-BE49-F238E27FC236}">
+                <a16:creationId xmlns:a16="http://schemas.microsoft.com/office/drawing/2014/main" id="{CB926AB0-D073-266E-F6E2-1C365D0D9877}"/>
+              </a:ext>
+            </a:extLst>
+          </p:cNvPr>
+          <p:cNvPicPr>
+            <a:picLocks noChangeAspect="1"/>
+          </p:cNvPicPr>
+          <p:nvPr/>
+        </p:nvPicPr>
+        <p:blipFill>
+          <a:blip r:embed="rId3"/>
+          <a:stretch>
+            <a:fillRect/>
+          </a:stretch>
+        </p:blipFill>
+        <p:spPr>
+          <a:xfrm>
+            <a:off x="1700997" y="5113545"/>
+            <a:ext cx="2677856" cy="989643"/>
+          </a:xfrm>
+          <a:prstGeom prst="rect">
+            <a:avLst/>
+          </a:prstGeom>
+        </p:spPr>
+      </p:pic>
+      <p:pic>
+        <p:nvPicPr>
+          <p:cNvPr id="10" name="Picture 9">
+            <a:extLst>
+              <a:ext uri="{FF2B5EF4-FFF2-40B4-BE49-F238E27FC236}">
+                <a16:creationId xmlns:a16="http://schemas.microsoft.com/office/drawing/2014/main" id="{2FEB1B21-0D79-E425-1F80-874074A0C011}"/>
+              </a:ext>
+            </a:extLst>
+          </p:cNvPr>
+          <p:cNvPicPr>
+            <a:picLocks noChangeAspect="1"/>
+          </p:cNvPicPr>
+          <p:nvPr/>
+        </p:nvPicPr>
+        <p:blipFill>
+          <a:blip r:embed="rId4"/>
+          <a:stretch>
+            <a:fillRect/>
+          </a:stretch>
+        </p:blipFill>
+        <p:spPr>
+          <a:xfrm>
+            <a:off x="1121879" y="1563001"/>
+            <a:ext cx="4344240" cy="931428"/>
+          </a:xfrm>
+          <a:prstGeom prst="rect">
+            <a:avLst/>
+          </a:prstGeom>
+        </p:spPr>
+      </p:pic>
+      <p:pic>
+        <p:nvPicPr>
+          <p:cNvPr id="12" name="Picture 11">
+            <a:extLst>
+              <a:ext uri="{FF2B5EF4-FFF2-40B4-BE49-F238E27FC236}">
+                <a16:creationId xmlns:a16="http://schemas.microsoft.com/office/drawing/2014/main" id="{4974134E-AAC1-E371-7F9F-444F8CC4C507}"/>
+              </a:ext>
+            </a:extLst>
+          </p:cNvPr>
+          <p:cNvPicPr>
+            <a:picLocks noChangeAspect="1"/>
+          </p:cNvPicPr>
+          <p:nvPr/>
+        </p:nvPicPr>
+        <p:blipFill>
+          <a:blip r:embed="rId5"/>
+          <a:stretch>
+            <a:fillRect/>
+          </a:stretch>
+        </p:blipFill>
+        <p:spPr>
+          <a:xfrm>
+            <a:off x="485774" y="704516"/>
+            <a:ext cx="3893079" cy="756785"/>
+          </a:xfrm>
+          <a:prstGeom prst="rect">
+            <a:avLst/>
+          </a:prstGeom>
+        </p:spPr>
+      </p:pic>
+      <p:pic>
+        <p:nvPicPr>
+          <p:cNvPr id="14" name="Picture 13">
+            <a:extLst>
+              <a:ext uri="{FF2B5EF4-FFF2-40B4-BE49-F238E27FC236}">
+                <a16:creationId xmlns:a16="http://schemas.microsoft.com/office/drawing/2014/main" id="{4FAA59C9-D78A-739B-A778-5C29411F39D2}"/>
+              </a:ext>
+            </a:extLst>
+          </p:cNvPr>
+          <p:cNvPicPr>
+            <a:picLocks noChangeAspect="1"/>
+          </p:cNvPicPr>
+          <p:nvPr/>
+        </p:nvPicPr>
+        <p:blipFill>
+          <a:blip r:embed="rId6"/>
+          <a:stretch>
+            <a:fillRect/>
+          </a:stretch>
+        </p:blipFill>
+        <p:spPr>
+          <a:xfrm>
+            <a:off x="485774" y="2596129"/>
+            <a:ext cx="3994954" cy="451160"/>
           </a:xfrm>
           <a:prstGeom prst="rect">
             <a:avLst/>
@@ -9542,7 +9950,7 @@
 </p:sld>
 </file>
 
-<file path=ppt/slides/slide13.xml><?xml version="1.0" encoding="utf-8"?>
+<file path=ppt/slides/slide14.xml><?xml version="1.0" encoding="utf-8"?>
 <p:sld xmlns:a="http://schemas.openxmlformats.org/drawingml/2006/main" xmlns:r="http://schemas.openxmlformats.org/officeDocument/2006/relationships" xmlns:p="http://schemas.openxmlformats.org/presentationml/2006/main">
   <p:cSld>
     <p:spTree>
@@ -9629,8 +10037,8 @@
               <a:t>Provide additional functionality to </a:t>
             </a:r>
             <a:r>
-              <a:rPr lang="en-ZA" noProof="0" dirty="0" err="1"/>
-              <a:t>WorkFlow</a:t>
+              <a:rPr lang="en-ZA" dirty="0"/>
+              <a:t>the Participant</a:t>
             </a:r>
             <a:r>
               <a:rPr lang="en-ZA" noProof="0" dirty="0"/>
@@ -9648,8 +10056,13 @@
             <a:pPr lvl="0"/>
             <a:r>
               <a:rPr lang="en-ZA" noProof="0" dirty="0"/>
-              <a:t>Each Workflow Component is generic. Decorator can wrap a component to diversify its functionality providing unique factors to a wrapped component.</a:t>
-            </a:r>
+              <a:t>Each Participant Component is generic. There was no way to differentiate members </a:t>
+            </a:r>
+            <a:r>
+              <a:rPr lang="en-ZA" dirty="0"/>
+              <a:t>by their Role or their role level, so Decorator provides this.</a:t>
+            </a:r>
+            <a:endParaRPr lang="en-ZA" noProof="0" dirty="0"/>
           </a:p>
           <a:p>
             <a:pPr lvl="0"/>
@@ -9662,7 +10075,7 @@
             <a:pPr lvl="0"/>
             <a:r>
               <a:rPr lang="en-ZA" noProof="0" dirty="0"/>
-              <a:t>Works alongside Workflow Composite, wrapping it to keep all current functionality while adding to it.</a:t>
+              <a:t>Works alongside Participant Composite, wrapping it to keep all current functionality while adding to it.</a:t>
             </a:r>
           </a:p>
           <a:p>
@@ -9672,10 +10085,10 @@
       </p:sp>
       <p:pic>
         <p:nvPicPr>
-          <p:cNvPr id="5" name="Picture 4">
-            <a:extLst>
-              <a:ext uri="{FF2B5EF4-FFF2-40B4-BE49-F238E27FC236}">
-                <a16:creationId xmlns:a16="http://schemas.microsoft.com/office/drawing/2014/main" id="{B922B213-8A4E-905B-000C-B389D1AABD0C}"/>
+          <p:cNvPr id="6" name="Picture 5">
+            <a:extLst>
+              <a:ext uri="{FF2B5EF4-FFF2-40B4-BE49-F238E27FC236}">
+                <a16:creationId xmlns:a16="http://schemas.microsoft.com/office/drawing/2014/main" id="{C1E3ED69-85E2-BA4B-67C6-98D01548ED7C}"/>
               </a:ext>
             </a:extLst>
           </p:cNvPr>
@@ -9692,8 +10105,38 @@
         </p:blipFill>
         <p:spPr>
           <a:xfrm>
-            <a:off x="609200" y="2541542"/>
-            <a:ext cx="4791475" cy="1774915"/>
+            <a:off x="635104" y="1313894"/>
+            <a:ext cx="3210373" cy="2915057"/>
+          </a:xfrm>
+          <a:prstGeom prst="rect">
+            <a:avLst/>
+          </a:prstGeom>
+        </p:spPr>
+      </p:pic>
+      <p:pic>
+        <p:nvPicPr>
+          <p:cNvPr id="8" name="Picture 7">
+            <a:extLst>
+              <a:ext uri="{FF2B5EF4-FFF2-40B4-BE49-F238E27FC236}">
+                <a16:creationId xmlns:a16="http://schemas.microsoft.com/office/drawing/2014/main" id="{F88B5E13-9CA4-C10C-DF72-61DB6F85F38E}"/>
+              </a:ext>
+            </a:extLst>
+          </p:cNvPr>
+          <p:cNvPicPr>
+            <a:picLocks noChangeAspect="1"/>
+          </p:cNvPicPr>
+          <p:nvPr/>
+        </p:nvPicPr>
+        <p:blipFill>
+          <a:blip r:embed="rId3"/>
+          <a:stretch>
+            <a:fillRect/>
+          </a:stretch>
+        </p:blipFill>
+        <p:spPr>
+          <a:xfrm>
+            <a:off x="2264106" y="4491551"/>
+            <a:ext cx="3162741" cy="1219370"/>
           </a:xfrm>
           <a:prstGeom prst="rect">
             <a:avLst/>
@@ -9713,7 +10156,7 @@
 </p:sld>
 </file>
 
-<file path=ppt/slides/slide14.xml><?xml version="1.0" encoding="utf-8"?>
+<file path=ppt/slides/slide15.xml><?xml version="1.0" encoding="utf-8"?>
 <p:sld xmlns:a="http://schemas.openxmlformats.org/drawingml/2006/main" xmlns:r="http://schemas.openxmlformats.org/officeDocument/2006/relationships" xmlns:p="http://schemas.openxmlformats.org/presentationml/2006/main">
   <p:cSld>
     <p:spTree>
@@ -9840,10 +10283,10 @@
       </p:sp>
       <p:pic>
         <p:nvPicPr>
-          <p:cNvPr id="5" name="Picture 4">
-            <a:extLst>
-              <a:ext uri="{FF2B5EF4-FFF2-40B4-BE49-F238E27FC236}">
-                <a16:creationId xmlns:a16="http://schemas.microsoft.com/office/drawing/2014/main" id="{5B00BDFE-668B-8B9D-F179-476854D0A52F}"/>
+          <p:cNvPr id="6" name="Picture 5">
+            <a:extLst>
+              <a:ext uri="{FF2B5EF4-FFF2-40B4-BE49-F238E27FC236}">
+                <a16:creationId xmlns:a16="http://schemas.microsoft.com/office/drawing/2014/main" id="{B2AE78E4-9D57-B846-2B42-DCE19D4074DA}"/>
               </a:ext>
             </a:extLst>
           </p:cNvPr>
@@ -9860,8 +10303,38 @@
         </p:blipFill>
         <p:spPr>
           <a:xfrm>
-            <a:off x="546871" y="2858925"/>
-            <a:ext cx="4882380" cy="1140149"/>
+            <a:off x="637877" y="3429001"/>
+            <a:ext cx="4661100" cy="1389288"/>
+          </a:xfrm>
+          <a:prstGeom prst="rect">
+            <a:avLst/>
+          </a:prstGeom>
+        </p:spPr>
+      </p:pic>
+      <p:pic>
+        <p:nvPicPr>
+          <p:cNvPr id="8" name="Picture 7">
+            <a:extLst>
+              <a:ext uri="{FF2B5EF4-FFF2-40B4-BE49-F238E27FC236}">
+                <a16:creationId xmlns:a16="http://schemas.microsoft.com/office/drawing/2014/main" id="{FC810F91-B4CF-B373-BA7B-BE6F1D77A515}"/>
+              </a:ext>
+            </a:extLst>
+          </p:cNvPr>
+          <p:cNvPicPr>
+            <a:picLocks noChangeAspect="1"/>
+          </p:cNvPicPr>
+          <p:nvPr/>
+        </p:nvPicPr>
+        <p:blipFill>
+          <a:blip r:embed="rId3"/>
+          <a:stretch>
+            <a:fillRect/>
+          </a:stretch>
+        </p:blipFill>
+        <p:spPr>
+          <a:xfrm>
+            <a:off x="637877" y="2068095"/>
+            <a:ext cx="4661100" cy="1360905"/>
           </a:xfrm>
           <a:prstGeom prst="rect">
             <a:avLst/>
@@ -9881,7 +10354,7 @@
 </p:sld>
 </file>
 
-<file path=ppt/slides/slide15.xml><?xml version="1.0" encoding="utf-8"?>
+<file path=ppt/slides/slide16.xml><?xml version="1.0" encoding="utf-8"?>
 <p:sld xmlns:a="http://schemas.openxmlformats.org/drawingml/2006/main" xmlns:r="http://schemas.openxmlformats.org/officeDocument/2006/relationships" xmlns:p="http://schemas.openxmlformats.org/presentationml/2006/main">
   <p:cSld>
     <p:spTree>
@@ -10008,10 +10481,10 @@
       </p:sp>
       <p:pic>
         <p:nvPicPr>
-          <p:cNvPr id="5" name="Picture 4">
-            <a:extLst>
-              <a:ext uri="{FF2B5EF4-FFF2-40B4-BE49-F238E27FC236}">
-                <a16:creationId xmlns:a16="http://schemas.microsoft.com/office/drawing/2014/main" id="{44442ADB-230D-E17C-BF78-A13FE5B9027E}"/>
+          <p:cNvPr id="6" name="Picture 5">
+            <a:extLst>
+              <a:ext uri="{FF2B5EF4-FFF2-40B4-BE49-F238E27FC236}">
+                <a16:creationId xmlns:a16="http://schemas.microsoft.com/office/drawing/2014/main" id="{C3237F97-D24E-BB46-3BA5-1F41F4E2CD86}"/>
               </a:ext>
             </a:extLst>
           </p:cNvPr>
@@ -10028,8 +10501,38 @@
         </p:blipFill>
         <p:spPr>
           <a:xfrm>
-            <a:off x="868961" y="1033462"/>
-            <a:ext cx="4175828" cy="4791075"/>
+            <a:off x="974472" y="2190550"/>
+            <a:ext cx="4016810" cy="938233"/>
+          </a:xfrm>
+          <a:prstGeom prst="rect">
+            <a:avLst/>
+          </a:prstGeom>
+        </p:spPr>
+      </p:pic>
+      <p:pic>
+        <p:nvPicPr>
+          <p:cNvPr id="8" name="Picture 7">
+            <a:extLst>
+              <a:ext uri="{FF2B5EF4-FFF2-40B4-BE49-F238E27FC236}">
+                <a16:creationId xmlns:a16="http://schemas.microsoft.com/office/drawing/2014/main" id="{8ED1A9AC-0DDC-ACC1-0DC1-0045031D6378}"/>
+              </a:ext>
+            </a:extLst>
+          </p:cNvPr>
+          <p:cNvPicPr>
+            <a:picLocks noChangeAspect="1"/>
+          </p:cNvPicPr>
+          <p:nvPr/>
+        </p:nvPicPr>
+        <p:blipFill>
+          <a:blip r:embed="rId3"/>
+          <a:stretch>
+            <a:fillRect/>
+          </a:stretch>
+        </p:blipFill>
+        <p:spPr>
+          <a:xfrm>
+            <a:off x="974472" y="3128783"/>
+            <a:ext cx="4024473" cy="1304484"/>
           </a:xfrm>
           <a:prstGeom prst="rect">
             <a:avLst/>
@@ -10049,7 +10552,7 @@
 </p:sld>
 </file>
 
-<file path=ppt/slides/slide16.xml><?xml version="1.0" encoding="utf-8"?>
+<file path=ppt/slides/slide17.xml><?xml version="1.0" encoding="utf-8"?>
 <p:sld xmlns:a="http://schemas.openxmlformats.org/drawingml/2006/main" xmlns:r="http://schemas.openxmlformats.org/officeDocument/2006/relationships" xmlns:p="http://schemas.openxmlformats.org/presentationml/2006/main">
   <p:cSld>
     <p:spTree>
@@ -10174,10 +10677,10 @@
       </p:sp>
       <p:pic>
         <p:nvPicPr>
-          <p:cNvPr id="5" name="Picture 4">
-            <a:extLst>
-              <a:ext uri="{FF2B5EF4-FFF2-40B4-BE49-F238E27FC236}">
-                <a16:creationId xmlns:a16="http://schemas.microsoft.com/office/drawing/2014/main" id="{8E17D2DB-4E86-F4D1-236E-924D79C54901}"/>
+          <p:cNvPr id="6" name="Picture 5">
+            <a:extLst>
+              <a:ext uri="{FF2B5EF4-FFF2-40B4-BE49-F238E27FC236}">
+                <a16:creationId xmlns:a16="http://schemas.microsoft.com/office/drawing/2014/main" id="{2816CB08-A0BC-D964-B952-8CAE5ABA6657}"/>
               </a:ext>
             </a:extLst>
           </p:cNvPr>
@@ -10194,8 +10697,98 @@
         </p:blipFill>
         <p:spPr>
           <a:xfrm>
-            <a:off x="654590" y="1419225"/>
-            <a:ext cx="4703729" cy="4019550"/>
+            <a:off x="2721110" y="704516"/>
+            <a:ext cx="2819794" cy="847843"/>
+          </a:xfrm>
+          <a:prstGeom prst="rect">
+            <a:avLst/>
+          </a:prstGeom>
+        </p:spPr>
+      </p:pic>
+      <p:pic>
+        <p:nvPicPr>
+          <p:cNvPr id="8" name="Picture 7">
+            <a:extLst>
+              <a:ext uri="{FF2B5EF4-FFF2-40B4-BE49-F238E27FC236}">
+                <a16:creationId xmlns:a16="http://schemas.microsoft.com/office/drawing/2014/main" id="{F213BFA0-E00E-EBC6-9E9B-0C44FDF6DEEC}"/>
+              </a:ext>
+            </a:extLst>
+          </p:cNvPr>
+          <p:cNvPicPr>
+            <a:picLocks noChangeAspect="1"/>
+          </p:cNvPicPr>
+          <p:nvPr/>
+        </p:nvPicPr>
+        <p:blipFill>
+          <a:blip r:embed="rId3"/>
+          <a:stretch>
+            <a:fillRect/>
+          </a:stretch>
+        </p:blipFill>
+        <p:spPr>
+          <a:xfrm>
+            <a:off x="458456" y="3916231"/>
+            <a:ext cx="5006519" cy="2192748"/>
+          </a:xfrm>
+          <a:prstGeom prst="rect">
+            <a:avLst/>
+          </a:prstGeom>
+        </p:spPr>
+      </p:pic>
+      <p:pic>
+        <p:nvPicPr>
+          <p:cNvPr id="10" name="Picture 9">
+            <a:extLst>
+              <a:ext uri="{FF2B5EF4-FFF2-40B4-BE49-F238E27FC236}">
+                <a16:creationId xmlns:a16="http://schemas.microsoft.com/office/drawing/2014/main" id="{1A20535E-51E5-B27F-C77C-19D0A4215B81}"/>
+              </a:ext>
+            </a:extLst>
+          </p:cNvPr>
+          <p:cNvPicPr>
+            <a:picLocks noChangeAspect="1"/>
+          </p:cNvPicPr>
+          <p:nvPr/>
+        </p:nvPicPr>
+        <p:blipFill>
+          <a:blip r:embed="rId4"/>
+          <a:stretch>
+            <a:fillRect/>
+          </a:stretch>
+        </p:blipFill>
+        <p:spPr>
+          <a:xfrm>
+            <a:off x="458456" y="704516"/>
+            <a:ext cx="1743318" cy="1362265"/>
+          </a:xfrm>
+          <a:prstGeom prst="rect">
+            <a:avLst/>
+          </a:prstGeom>
+        </p:spPr>
+      </p:pic>
+      <p:pic>
+        <p:nvPicPr>
+          <p:cNvPr id="12" name="Picture 11">
+            <a:extLst>
+              <a:ext uri="{FF2B5EF4-FFF2-40B4-BE49-F238E27FC236}">
+                <a16:creationId xmlns:a16="http://schemas.microsoft.com/office/drawing/2014/main" id="{2BCCC11C-33A4-56AE-1BF2-63B222766756}"/>
+              </a:ext>
+            </a:extLst>
+          </p:cNvPr>
+          <p:cNvPicPr>
+            <a:picLocks noChangeAspect="1"/>
+          </p:cNvPicPr>
+          <p:nvPr/>
+        </p:nvPicPr>
+        <p:blipFill>
+          <a:blip r:embed="rId5"/>
+          <a:stretch>
+            <a:fillRect/>
+          </a:stretch>
+        </p:blipFill>
+        <p:spPr>
+          <a:xfrm>
+            <a:off x="2281535" y="1667728"/>
+            <a:ext cx="3259369" cy="2133134"/>
           </a:xfrm>
           <a:prstGeom prst="rect">
             <a:avLst/>
@@ -10215,7 +10808,7 @@
 </p:sld>
 </file>
 
-<file path=ppt/slides/slide17.xml><?xml version="1.0" encoding="utf-8"?>
+<file path=ppt/slides/slide18.xml><?xml version="1.0" encoding="utf-8"?>
 <p:sld xmlns:a="http://schemas.openxmlformats.org/drawingml/2006/main" xmlns:r="http://schemas.openxmlformats.org/officeDocument/2006/relationships" xmlns:p="http://schemas.openxmlformats.org/presentationml/2006/main">
   <p:cSld>
     <p:spTree>
@@ -10266,7 +10859,7 @@
           <a:p>
             <a:r>
               <a:rPr lang="en-ZA" noProof="0" dirty="0"/>
-              <a:t>Adapter</a:t>
+              <a:t>Template Method</a:t>
             </a:r>
           </a:p>
         </p:txBody>
@@ -10303,9 +10896,34 @@
           <a:p>
             <a:pPr lvl="0"/>
             <a:r>
-              <a:rPr lang="en-ZA" noProof="0" dirty="0"/>
-              <a:t>Used to adapt updates to classes that are not notified of changes in the subjects of the Observer Pattern. </a:t>
-            </a:r>
+              <a:rPr lang="en-ZA" dirty="0"/>
+              <a:t>The observer calls a template method update that performs a sequence of primitive operations, </a:t>
+            </a:r>
+            <a:r>
+              <a:rPr lang="en-ZA" dirty="0" err="1"/>
+              <a:t>shouldReact</a:t>
+            </a:r>
+            <a:r>
+              <a:rPr lang="en-ZA" dirty="0"/>
+              <a:t>, </a:t>
+            </a:r>
+            <a:r>
+              <a:rPr lang="en-ZA" dirty="0" err="1"/>
+              <a:t>applyAction</a:t>
+            </a:r>
+            <a:r>
+              <a:rPr lang="en-ZA" dirty="0"/>
+              <a:t> and </a:t>
+            </a:r>
+            <a:r>
+              <a:rPr lang="en-ZA" dirty="0" err="1"/>
+              <a:t>afterUpdate</a:t>
+            </a:r>
+            <a:r>
+              <a:rPr lang="en-ZA" dirty="0"/>
+              <a:t>.</a:t>
+            </a:r>
+            <a:endParaRPr lang="en-ZA" noProof="0" dirty="0"/>
           </a:p>
           <a:p>
             <a:pPr lvl="0"/>
@@ -10316,7 +10934,10 @@
           </a:p>
           <a:p>
             <a:pPr lvl="0"/>
-            <a:endParaRPr lang="en-ZA" noProof="0" dirty="0"/>
+            <a:r>
+              <a:rPr lang="en-ZA" noProof="0" dirty="0"/>
+              <a:t>Observers are based on the events registry and with this means that certain observers should update on certain requirements and in unique ways.</a:t>
+            </a:r>
           </a:p>
           <a:p>
             <a:pPr lvl="0"/>
@@ -10329,17 +10950,22 @@
             <a:pPr lvl="0"/>
             <a:r>
               <a:rPr lang="en-ZA" noProof="0" dirty="0"/>
-              <a:t>Works with the Observer Pattern to send updates to classes that are not attached to the Subjects of the Observer.</a:t>
-            </a:r>
+              <a:t>Lies </a:t>
+            </a:r>
+            <a:r>
+              <a:rPr lang="en-ZA" dirty="0"/>
+              <a:t>within the Observer Pattern.</a:t>
+            </a:r>
+            <a:endParaRPr lang="en-ZA" noProof="0" dirty="0"/>
           </a:p>
         </p:txBody>
       </p:sp>
       <p:pic>
         <p:nvPicPr>
-          <p:cNvPr id="7" name="Picture 6">
-            <a:extLst>
-              <a:ext uri="{FF2B5EF4-FFF2-40B4-BE49-F238E27FC236}">
-                <a16:creationId xmlns:a16="http://schemas.microsoft.com/office/drawing/2014/main" id="{F53D55FF-3B1B-AD33-EA04-56157E19D826}"/>
+          <p:cNvPr id="10" name="Picture 9">
+            <a:extLst>
+              <a:ext uri="{FF2B5EF4-FFF2-40B4-BE49-F238E27FC236}">
+                <a16:creationId xmlns:a16="http://schemas.microsoft.com/office/drawing/2014/main" id="{93D8C0B6-1FD9-BA3F-68FF-E25E41BC80CE}"/>
               </a:ext>
             </a:extLst>
           </p:cNvPr>
@@ -10356,8 +10982,8 @@
         </p:blipFill>
         <p:spPr>
           <a:xfrm>
-            <a:off x="637820" y="3028045"/>
-            <a:ext cx="4705705" cy="801909"/>
+            <a:off x="598004" y="2910338"/>
+            <a:ext cx="4838146" cy="1037324"/>
           </a:xfrm>
           <a:prstGeom prst="rect">
             <a:avLst/>
@@ -10368,191 +10994,6 @@
     <p:extLst>
       <p:ext uri="{BB962C8B-B14F-4D97-AF65-F5344CB8AC3E}">
         <p14:creationId xmlns:p14="http://schemas.microsoft.com/office/powerpoint/2010/main" val="3361870458"/>
-      </p:ext>
-    </p:extLst>
-  </p:cSld>
-  <p:clrMapOvr>
-    <a:masterClrMapping/>
-  </p:clrMapOvr>
-</p:sld>
-</file>
-
-<file path=ppt/slides/slide18.xml><?xml version="1.0" encoding="utf-8"?>
-<p:sld xmlns:a="http://schemas.openxmlformats.org/drawingml/2006/main" xmlns:r="http://schemas.openxmlformats.org/officeDocument/2006/relationships" xmlns:p="http://schemas.openxmlformats.org/presentationml/2006/main">
-  <p:cSld>
-    <p:spTree>
-      <p:nvGrpSpPr>
-        <p:cNvPr id="1" name="">
-          <a:extLst>
-            <a:ext uri="{FF2B5EF4-FFF2-40B4-BE49-F238E27FC236}">
-              <a16:creationId xmlns:a16="http://schemas.microsoft.com/office/drawing/2014/main" id="{371509B3-3068-87A2-C9FC-0CA0D12C6094}"/>
-            </a:ext>
-          </a:extLst>
-        </p:cNvPr>
-        <p:cNvGrpSpPr/>
-        <p:nvPr/>
-      </p:nvGrpSpPr>
-      <p:grpSpPr>
-        <a:xfrm>
-          <a:off x="0" y="0"/>
-          <a:ext cx="0" cy="0"/>
-          <a:chOff x="0" y="0"/>
-          <a:chExt cx="0" cy="0"/>
-        </a:xfrm>
-      </p:grpSpPr>
-      <p:sp>
-        <p:nvSpPr>
-          <p:cNvPr id="2" name="Title 1">
-            <a:extLst>
-              <a:ext uri="{FF2B5EF4-FFF2-40B4-BE49-F238E27FC236}">
-                <a16:creationId xmlns:a16="http://schemas.microsoft.com/office/drawing/2014/main" id="{DB0D614A-62D4-CAE6-091C-6CEAAACD4B2D}"/>
-              </a:ext>
-            </a:extLst>
-          </p:cNvPr>
-          <p:cNvSpPr>
-            <a:spLocks noGrp="1"/>
-          </p:cNvSpPr>
-          <p:nvPr>
-            <p:ph type="title"/>
-          </p:nvPr>
-        </p:nvSpPr>
-        <p:spPr>
-          <a:xfrm>
-            <a:off x="6651097" y="422551"/>
-            <a:ext cx="5302778" cy="563930"/>
-          </a:xfrm>
-        </p:spPr>
-        <p:txBody>
-          <a:bodyPr/>
-          <a:lstStyle/>
-          <a:p>
-            <a:r>
-              <a:rPr lang="en-ZA" noProof="0" dirty="0"/>
-              <a:t>State</a:t>
-            </a:r>
-          </a:p>
-        </p:txBody>
-      </p:sp>
-      <p:sp>
-        <p:nvSpPr>
-          <p:cNvPr id="3" name="Content Placeholder 2">
-            <a:extLst>
-              <a:ext uri="{FF2B5EF4-FFF2-40B4-BE49-F238E27FC236}">
-                <a16:creationId xmlns:a16="http://schemas.microsoft.com/office/drawing/2014/main" id="{015F2D93-D18E-F4C4-8BFB-A98F6253374C}"/>
-              </a:ext>
-            </a:extLst>
-          </p:cNvPr>
-          <p:cNvSpPr>
-            <a:spLocks noGrp="1"/>
-          </p:cNvSpPr>
-          <p:nvPr>
-            <p:ph sz="quarter" idx="10"/>
-          </p:nvPr>
-        </p:nvSpPr>
-        <p:spPr/>
-        <p:txBody>
-          <a:bodyPr>
-            <a:normAutofit/>
-          </a:bodyPr>
-          <a:lstStyle/>
-          <a:p>
-            <a:pPr lvl="0"/>
-            <a:r>
-              <a:rPr lang="en-ZA" b="1" noProof="0" dirty="0"/>
-              <a:t>Role:</a:t>
-            </a:r>
-          </a:p>
-          <a:p>
-            <a:pPr lvl="0"/>
-            <a:r>
-              <a:rPr lang="en-ZA" noProof="0" dirty="0"/>
-              <a:t>Provide state to Workflow Composite components to allow different behaviour for different states. </a:t>
-            </a:r>
-          </a:p>
-          <a:p>
-            <a:pPr lvl="0"/>
-            <a:r>
-              <a:rPr lang="en-ZA" b="1" noProof="0" dirty="0"/>
-              <a:t>Reason: </a:t>
-            </a:r>
-          </a:p>
-          <a:p>
-            <a:pPr lvl="0"/>
-            <a:r>
-              <a:rPr lang="en-ZA" noProof="0" dirty="0"/>
-              <a:t>State allows for extensibility of the behaviour when in a certain state without changing the </a:t>
-            </a:r>
-            <a:r>
-              <a:rPr lang="en-ZA" dirty="0"/>
-              <a:t>code within the</a:t>
-            </a:r>
-            <a:r>
-              <a:rPr lang="en-ZA" noProof="0" dirty="0"/>
-              <a:t> Composite.</a:t>
-            </a:r>
-          </a:p>
-          <a:p>
-            <a:pPr lvl="0"/>
-            <a:r>
-              <a:rPr lang="en-ZA" b="1" noProof="0" dirty="0"/>
-              <a:t>Relationships: </a:t>
-            </a:r>
-          </a:p>
-          <a:p>
-            <a:pPr lvl="0"/>
-            <a:r>
-              <a:rPr lang="en-ZA" noProof="0" dirty="0"/>
-              <a:t>Used within the Workflow Composite and doubles as the </a:t>
-            </a:r>
-            <a:r>
-              <a:rPr lang="en-ZA" dirty="0"/>
-              <a:t>V</a:t>
-            </a:r>
-            <a:r>
-              <a:rPr lang="en-ZA" noProof="0" dirty="0" err="1"/>
-              <a:t>isitor</a:t>
-            </a:r>
-            <a:r>
-              <a:rPr lang="en-ZA" noProof="0" dirty="0"/>
-              <a:t> pattern.</a:t>
-            </a:r>
-          </a:p>
-        </p:txBody>
-      </p:sp>
-      <p:pic>
-        <p:nvPicPr>
-          <p:cNvPr id="5" name="Picture 4">
-            <a:extLst>
-              <a:ext uri="{FF2B5EF4-FFF2-40B4-BE49-F238E27FC236}">
-                <a16:creationId xmlns:a16="http://schemas.microsoft.com/office/drawing/2014/main" id="{AC14173D-936C-6D2A-A36C-1997ABDB1EEB}"/>
-              </a:ext>
-            </a:extLst>
-          </p:cNvPr>
-          <p:cNvPicPr>
-            <a:picLocks noChangeAspect="1"/>
-          </p:cNvPicPr>
-          <p:nvPr/>
-        </p:nvPicPr>
-        <p:blipFill>
-          <a:blip r:embed="rId2"/>
-          <a:stretch>
-            <a:fillRect/>
-          </a:stretch>
-        </p:blipFill>
-        <p:spPr>
-          <a:xfrm>
-            <a:off x="1723442" y="780024"/>
-            <a:ext cx="2277057" cy="5297952"/>
-          </a:xfrm>
-          <a:prstGeom prst="rect">
-            <a:avLst/>
-          </a:prstGeom>
-        </p:spPr>
-      </p:pic>
-    </p:spTree>
-    <p:extLst>
-      <p:ext uri="{BB962C8B-B14F-4D97-AF65-F5344CB8AC3E}">
-        <p14:creationId xmlns:p14="http://schemas.microsoft.com/office/powerpoint/2010/main" val="3139366889"/>
       </p:ext>
     </p:extLst>
   </p:cSld>
@@ -10570,7 +11011,7 @@
         <p:cNvPr id="1" name="">
           <a:extLst>
             <a:ext uri="{FF2B5EF4-FFF2-40B4-BE49-F238E27FC236}">
-              <a16:creationId xmlns:a16="http://schemas.microsoft.com/office/drawing/2014/main" id="{ED499213-156F-ADA2-B588-418460956BC6}"/>
+              <a16:creationId xmlns:a16="http://schemas.microsoft.com/office/drawing/2014/main" id="{15675AA1-5142-96DD-504A-29A8FBE0CBBB}"/>
             </a:ext>
           </a:extLst>
         </p:cNvPr>
@@ -10590,7 +11031,7 @@
           <p:cNvPr id="2" name="Title 1">
             <a:extLst>
               <a:ext uri="{FF2B5EF4-FFF2-40B4-BE49-F238E27FC236}">
-                <a16:creationId xmlns:a16="http://schemas.microsoft.com/office/drawing/2014/main" id="{332CC830-2E11-AA2B-C492-7459C4B1F126}"/>
+                <a16:creationId xmlns:a16="http://schemas.microsoft.com/office/drawing/2014/main" id="{1084979C-7455-F078-10B1-33D1845CA697}"/>
               </a:ext>
             </a:extLst>
           </p:cNvPr>
@@ -10603,123 +11044,60 @@
         </p:nvSpPr>
         <p:spPr>
           <a:xfrm>
-            <a:off x="6651097" y="422551"/>
-            <a:ext cx="5302778" cy="563930"/>
+            <a:off x="810001" y="1741064"/>
+            <a:ext cx="10571998" cy="1928264"/>
           </a:xfrm>
         </p:spPr>
         <p:txBody>
           <a:bodyPr/>
           <a:lstStyle/>
           <a:p>
+            <a:pPr lvl="0"/>
+            <a:r>
+              <a:rPr lang="en-ZA" sz="4800" noProof="0" dirty="0"/>
+              <a:t>Frontend</a:t>
+            </a:r>
+          </a:p>
+        </p:txBody>
+      </p:sp>
+      <p:sp>
+        <p:nvSpPr>
+          <p:cNvPr id="3" name="Subtitle 2">
+            <a:extLst>
+              <a:ext uri="{FF2B5EF4-FFF2-40B4-BE49-F238E27FC236}">
+                <a16:creationId xmlns:a16="http://schemas.microsoft.com/office/drawing/2014/main" id="{FA1DC89D-3720-8F56-E7BF-F10DA77B6C29}"/>
+              </a:ext>
+            </a:extLst>
+          </p:cNvPr>
+          <p:cNvSpPr>
+            <a:spLocks noGrp="1"/>
+          </p:cNvSpPr>
+          <p:nvPr>
+            <p:ph type="subTitle" idx="1"/>
+          </p:nvPr>
+        </p:nvSpPr>
+        <p:spPr>
+          <a:xfrm>
+            <a:off x="810000" y="3694102"/>
+            <a:ext cx="10572000" cy="896468"/>
+          </a:xfrm>
+        </p:spPr>
+        <p:txBody>
+          <a:bodyPr/>
+          <a:lstStyle/>
+          <a:p>
+            <a:pPr lvl="0"/>
             <a:r>
               <a:rPr lang="en-ZA" noProof="0" dirty="0"/>
-              <a:t>Visitor</a:t>
-            </a:r>
-          </a:p>
-        </p:txBody>
-      </p:sp>
-      <p:sp>
-        <p:nvSpPr>
-          <p:cNvPr id="3" name="Content Placeholder 2">
-            <a:extLst>
-              <a:ext uri="{FF2B5EF4-FFF2-40B4-BE49-F238E27FC236}">
-                <a16:creationId xmlns:a16="http://schemas.microsoft.com/office/drawing/2014/main" id="{D71B98D1-EAC1-240A-94F4-5080A0572BBC}"/>
-              </a:ext>
-            </a:extLst>
-          </p:cNvPr>
-          <p:cNvSpPr>
-            <a:spLocks noGrp="1"/>
-          </p:cNvSpPr>
-          <p:nvPr>
-            <p:ph sz="quarter" idx="10"/>
-          </p:nvPr>
-        </p:nvSpPr>
-        <p:spPr/>
-        <p:txBody>
-          <a:bodyPr>
-            <a:normAutofit/>
-          </a:bodyPr>
-          <a:lstStyle/>
-          <a:p>
-            <a:pPr lvl="0"/>
-            <a:r>
-              <a:rPr lang="en-ZA" b="1" noProof="0" dirty="0"/>
-              <a:t>Role:</a:t>
-            </a:r>
-          </a:p>
-          <a:p>
-            <a:pPr lvl="0"/>
-            <a:r>
-              <a:rPr lang="en-ZA" dirty="0"/>
-              <a:t>Allows for different behaviour of state according to if the state is a leaf or a composite in a Workflow.</a:t>
-            </a:r>
-            <a:endParaRPr lang="en-ZA" noProof="0" dirty="0"/>
-          </a:p>
-          <a:p>
-            <a:pPr lvl="0"/>
-            <a:r>
-              <a:rPr lang="en-ZA" b="1" noProof="0" dirty="0"/>
-              <a:t>Reason: </a:t>
-            </a:r>
-          </a:p>
-          <a:p>
-            <a:pPr lvl="0"/>
-            <a:r>
-              <a:rPr lang="en-ZA" noProof="0" dirty="0"/>
-              <a:t>The leaves and composites of the Workflow have different members and different ways that they get operated on in certain states.</a:t>
-            </a:r>
-          </a:p>
-          <a:p>
-            <a:pPr lvl="0"/>
-            <a:r>
-              <a:rPr lang="en-ZA" b="1" noProof="0" dirty="0"/>
-              <a:t>Relationships: </a:t>
-            </a:r>
-          </a:p>
-          <a:p>
-            <a:pPr lvl="0"/>
-            <a:r>
-              <a:rPr lang="en-ZA" dirty="0"/>
-              <a:t>Encompasses the State and Workflow Composite to enable double dispatching.</a:t>
-            </a:r>
-            <a:endParaRPr lang="en-ZA" noProof="0" dirty="0"/>
-          </a:p>
-        </p:txBody>
-      </p:sp>
-      <p:pic>
-        <p:nvPicPr>
-          <p:cNvPr id="5" name="Picture 4">
-            <a:extLst>
-              <a:ext uri="{FF2B5EF4-FFF2-40B4-BE49-F238E27FC236}">
-                <a16:creationId xmlns:a16="http://schemas.microsoft.com/office/drawing/2014/main" id="{C853FCF9-67A0-8B0E-A179-EEB16937793C}"/>
-              </a:ext>
-            </a:extLst>
-          </p:cNvPr>
-          <p:cNvPicPr>
-            <a:picLocks noChangeAspect="1"/>
-          </p:cNvPicPr>
-          <p:nvPr/>
-        </p:nvPicPr>
-        <p:blipFill>
-          <a:blip r:embed="rId2"/>
-          <a:stretch>
-            <a:fillRect/>
-          </a:stretch>
-        </p:blipFill>
-        <p:spPr>
-          <a:xfrm>
-            <a:off x="728239" y="914167"/>
-            <a:ext cx="4576995" cy="5029665"/>
-          </a:xfrm>
-          <a:prstGeom prst="rect">
-            <a:avLst/>
-          </a:prstGeom>
-        </p:spPr>
-      </p:pic>
+              <a:t>Simple But Effective.</a:t>
+            </a:r>
+          </a:p>
+        </p:txBody>
+      </p:sp>
     </p:spTree>
     <p:extLst>
       <p:ext uri="{BB962C8B-B14F-4D97-AF65-F5344CB8AC3E}">
-        <p14:creationId xmlns:p14="http://schemas.microsoft.com/office/powerpoint/2010/main" val="2448139373"/>
+        <p14:creationId xmlns:p14="http://schemas.microsoft.com/office/powerpoint/2010/main" val="3226493198"/>
       </p:ext>
     </p:extLst>
   </p:cSld>
@@ -10951,380 +11329,6 @@
         <p:cNvPr id="1" name="">
           <a:extLst>
             <a:ext uri="{FF2B5EF4-FFF2-40B4-BE49-F238E27FC236}">
-              <a16:creationId xmlns:a16="http://schemas.microsoft.com/office/drawing/2014/main" id="{C6285946-74E0-C417-9F3F-F42E9EDA28BF}"/>
-            </a:ext>
-          </a:extLst>
-        </p:cNvPr>
-        <p:cNvGrpSpPr/>
-        <p:nvPr/>
-      </p:nvGrpSpPr>
-      <p:grpSpPr>
-        <a:xfrm>
-          <a:off x="0" y="0"/>
-          <a:ext cx="0" cy="0"/>
-          <a:chOff x="0" y="0"/>
-          <a:chExt cx="0" cy="0"/>
-        </a:xfrm>
-      </p:grpSpPr>
-      <p:sp>
-        <p:nvSpPr>
-          <p:cNvPr id="6" name="Title 5">
-            <a:extLst>
-              <a:ext uri="{FF2B5EF4-FFF2-40B4-BE49-F238E27FC236}">
-                <a16:creationId xmlns:a16="http://schemas.microsoft.com/office/drawing/2014/main" id="{CF700F39-F33D-A9A1-979D-5C9B0FBA73F7}"/>
-              </a:ext>
-            </a:extLst>
-          </p:cNvPr>
-          <p:cNvSpPr>
-            <a:spLocks noGrp="1"/>
-          </p:cNvSpPr>
-          <p:nvPr>
-            <p:ph type="title"/>
-          </p:nvPr>
-        </p:nvSpPr>
-        <p:spPr>
-          <a:xfrm>
-            <a:off x="529935" y="633845"/>
-            <a:ext cx="3990110" cy="2192482"/>
-          </a:xfrm>
-        </p:spPr>
-        <p:txBody>
-          <a:bodyPr/>
-          <a:lstStyle/>
-          <a:p>
-            <a:r>
-              <a:rPr lang="en-ZA" noProof="0" dirty="0"/>
-              <a:t>UML Activity Diagram 1</a:t>
-            </a:r>
-          </a:p>
-        </p:txBody>
-      </p:sp>
-      <p:sp>
-        <p:nvSpPr>
-          <p:cNvPr id="7" name="Content Placeholder 6">
-            <a:extLst>
-              <a:ext uri="{FF2B5EF4-FFF2-40B4-BE49-F238E27FC236}">
-                <a16:creationId xmlns:a16="http://schemas.microsoft.com/office/drawing/2014/main" id="{A15ECC69-D8BD-8C2D-97D8-F7AED27DFDE1}"/>
-              </a:ext>
-            </a:extLst>
-          </p:cNvPr>
-          <p:cNvSpPr>
-            <a:spLocks noGrp="1"/>
-          </p:cNvSpPr>
-          <p:nvPr>
-            <p:ph sz="quarter" idx="11"/>
-          </p:nvPr>
-        </p:nvSpPr>
-        <p:spPr>
-          <a:xfrm>
-            <a:off x="747423" y="3174531"/>
-            <a:ext cx="3772622" cy="3122360"/>
-          </a:xfrm>
-        </p:spPr>
-        <p:txBody>
-          <a:bodyPr/>
-          <a:lstStyle/>
-          <a:p>
-            <a:pPr lvl="0"/>
-            <a:r>
-              <a:rPr lang="en-ZA" noProof="0" dirty="0"/>
-              <a:t>Point about Activity Diagram 1</a:t>
-            </a:r>
-          </a:p>
-          <a:p>
-            <a:pPr lvl="0"/>
-            <a:r>
-              <a:rPr lang="en-ZA" noProof="0" dirty="0"/>
-              <a:t>Maybe what it describes</a:t>
-            </a:r>
-          </a:p>
-        </p:txBody>
-      </p:sp>
-      <p:sp>
-        <p:nvSpPr>
-          <p:cNvPr id="3" name="Content Placeholder 2">
-            <a:extLst>
-              <a:ext uri="{FF2B5EF4-FFF2-40B4-BE49-F238E27FC236}">
-                <a16:creationId xmlns:a16="http://schemas.microsoft.com/office/drawing/2014/main" id="{258830CB-F50A-CD82-8F30-3E67B25D8E6F}"/>
-              </a:ext>
-            </a:extLst>
-          </p:cNvPr>
-          <p:cNvSpPr>
-            <a:spLocks noGrp="1"/>
-          </p:cNvSpPr>
-          <p:nvPr>
-            <p:ph sz="quarter" idx="10"/>
-          </p:nvPr>
-        </p:nvSpPr>
-        <p:spPr/>
-        <p:txBody>
-          <a:bodyPr/>
-          <a:lstStyle/>
-          <a:p>
-            <a:endParaRPr lang="en-ZA" noProof="0" dirty="0"/>
-          </a:p>
-        </p:txBody>
-      </p:sp>
-    </p:spTree>
-    <p:extLst>
-      <p:ext uri="{BB962C8B-B14F-4D97-AF65-F5344CB8AC3E}">
-        <p14:creationId xmlns:p14="http://schemas.microsoft.com/office/powerpoint/2010/main" val="4169271549"/>
-      </p:ext>
-    </p:extLst>
-  </p:cSld>
-  <p:clrMapOvr>
-    <a:masterClrMapping/>
-  </p:clrMapOvr>
-</p:sld>
-</file>
-
-<file path=ppt/slides/slide21.xml><?xml version="1.0" encoding="utf-8"?>
-<p:sld xmlns:a="http://schemas.openxmlformats.org/drawingml/2006/main" xmlns:r="http://schemas.openxmlformats.org/officeDocument/2006/relationships" xmlns:p="http://schemas.openxmlformats.org/presentationml/2006/main">
-  <p:cSld>
-    <p:spTree>
-      <p:nvGrpSpPr>
-        <p:cNvPr id="1" name="">
-          <a:extLst>
-            <a:ext uri="{FF2B5EF4-FFF2-40B4-BE49-F238E27FC236}">
-              <a16:creationId xmlns:a16="http://schemas.microsoft.com/office/drawing/2014/main" id="{94D00F05-5789-E77C-DE51-5D35640DF431}"/>
-            </a:ext>
-          </a:extLst>
-        </p:cNvPr>
-        <p:cNvGrpSpPr/>
-        <p:nvPr/>
-      </p:nvGrpSpPr>
-      <p:grpSpPr>
-        <a:xfrm>
-          <a:off x="0" y="0"/>
-          <a:ext cx="0" cy="0"/>
-          <a:chOff x="0" y="0"/>
-          <a:chExt cx="0" cy="0"/>
-        </a:xfrm>
-      </p:grpSpPr>
-      <p:sp>
-        <p:nvSpPr>
-          <p:cNvPr id="6" name="Title 5">
-            <a:extLst>
-              <a:ext uri="{FF2B5EF4-FFF2-40B4-BE49-F238E27FC236}">
-                <a16:creationId xmlns:a16="http://schemas.microsoft.com/office/drawing/2014/main" id="{34528C0D-5DCC-2F8C-26BE-185846F47B6C}"/>
-              </a:ext>
-            </a:extLst>
-          </p:cNvPr>
-          <p:cNvSpPr>
-            <a:spLocks noGrp="1"/>
-          </p:cNvSpPr>
-          <p:nvPr>
-            <p:ph type="title"/>
-          </p:nvPr>
-        </p:nvSpPr>
-        <p:spPr>
-          <a:xfrm>
-            <a:off x="529935" y="633845"/>
-            <a:ext cx="3990110" cy="2192482"/>
-          </a:xfrm>
-        </p:spPr>
-        <p:txBody>
-          <a:bodyPr/>
-          <a:lstStyle/>
-          <a:p>
-            <a:r>
-              <a:rPr lang="en-ZA" noProof="0" dirty="0"/>
-              <a:t>UML Activity Diagram 2</a:t>
-            </a:r>
-          </a:p>
-        </p:txBody>
-      </p:sp>
-      <p:sp>
-        <p:nvSpPr>
-          <p:cNvPr id="7" name="Content Placeholder 6">
-            <a:extLst>
-              <a:ext uri="{FF2B5EF4-FFF2-40B4-BE49-F238E27FC236}">
-                <a16:creationId xmlns:a16="http://schemas.microsoft.com/office/drawing/2014/main" id="{4812A14A-6BB0-7C6D-326F-BA641FF66E98}"/>
-              </a:ext>
-            </a:extLst>
-          </p:cNvPr>
-          <p:cNvSpPr>
-            <a:spLocks noGrp="1"/>
-          </p:cNvSpPr>
-          <p:nvPr>
-            <p:ph sz="quarter" idx="11"/>
-          </p:nvPr>
-        </p:nvSpPr>
-        <p:spPr>
-          <a:xfrm>
-            <a:off x="747423" y="3174531"/>
-            <a:ext cx="3772622" cy="3122360"/>
-          </a:xfrm>
-        </p:spPr>
-        <p:txBody>
-          <a:bodyPr/>
-          <a:lstStyle/>
-          <a:p>
-            <a:pPr lvl="0"/>
-            <a:r>
-              <a:rPr lang="en-ZA" noProof="0" dirty="0"/>
-              <a:t>Point about Activity Diagram 2</a:t>
-            </a:r>
-          </a:p>
-          <a:p>
-            <a:pPr lvl="0"/>
-            <a:r>
-              <a:rPr lang="en-ZA" noProof="0" dirty="0"/>
-              <a:t>Maybe what it describes</a:t>
-            </a:r>
-          </a:p>
-        </p:txBody>
-      </p:sp>
-      <p:sp>
-        <p:nvSpPr>
-          <p:cNvPr id="3" name="Content Placeholder 2">
-            <a:extLst>
-              <a:ext uri="{FF2B5EF4-FFF2-40B4-BE49-F238E27FC236}">
-                <a16:creationId xmlns:a16="http://schemas.microsoft.com/office/drawing/2014/main" id="{D2A1DB48-1D16-21BD-8705-851CA2333006}"/>
-              </a:ext>
-            </a:extLst>
-          </p:cNvPr>
-          <p:cNvSpPr>
-            <a:spLocks noGrp="1"/>
-          </p:cNvSpPr>
-          <p:nvPr>
-            <p:ph sz="quarter" idx="10"/>
-          </p:nvPr>
-        </p:nvSpPr>
-        <p:spPr/>
-        <p:txBody>
-          <a:bodyPr/>
-          <a:lstStyle/>
-          <a:p>
-            <a:endParaRPr lang="en-ZA" noProof="0" dirty="0"/>
-          </a:p>
-        </p:txBody>
-      </p:sp>
-    </p:spTree>
-    <p:extLst>
-      <p:ext uri="{BB962C8B-B14F-4D97-AF65-F5344CB8AC3E}">
-        <p14:creationId xmlns:p14="http://schemas.microsoft.com/office/powerpoint/2010/main" val="3136404827"/>
-      </p:ext>
-    </p:extLst>
-  </p:cSld>
-  <p:clrMapOvr>
-    <a:masterClrMapping/>
-  </p:clrMapOvr>
-</p:sld>
-</file>
-
-<file path=ppt/slides/slide22.xml><?xml version="1.0" encoding="utf-8"?>
-<p:sld xmlns:a="http://schemas.openxmlformats.org/drawingml/2006/main" xmlns:r="http://schemas.openxmlformats.org/officeDocument/2006/relationships" xmlns:p="http://schemas.openxmlformats.org/presentationml/2006/main">
-  <p:cSld>
-    <p:spTree>
-      <p:nvGrpSpPr>
-        <p:cNvPr id="1" name="">
-          <a:extLst>
-            <a:ext uri="{FF2B5EF4-FFF2-40B4-BE49-F238E27FC236}">
-              <a16:creationId xmlns:a16="http://schemas.microsoft.com/office/drawing/2014/main" id="{15675AA1-5142-96DD-504A-29A8FBE0CBBB}"/>
-            </a:ext>
-          </a:extLst>
-        </p:cNvPr>
-        <p:cNvGrpSpPr/>
-        <p:nvPr/>
-      </p:nvGrpSpPr>
-      <p:grpSpPr>
-        <a:xfrm>
-          <a:off x="0" y="0"/>
-          <a:ext cx="0" cy="0"/>
-          <a:chOff x="0" y="0"/>
-          <a:chExt cx="0" cy="0"/>
-        </a:xfrm>
-      </p:grpSpPr>
-      <p:sp>
-        <p:nvSpPr>
-          <p:cNvPr id="2" name="Title 1">
-            <a:extLst>
-              <a:ext uri="{FF2B5EF4-FFF2-40B4-BE49-F238E27FC236}">
-                <a16:creationId xmlns:a16="http://schemas.microsoft.com/office/drawing/2014/main" id="{1084979C-7455-F078-10B1-33D1845CA697}"/>
-              </a:ext>
-            </a:extLst>
-          </p:cNvPr>
-          <p:cNvSpPr>
-            <a:spLocks noGrp="1"/>
-          </p:cNvSpPr>
-          <p:nvPr>
-            <p:ph type="title"/>
-          </p:nvPr>
-        </p:nvSpPr>
-        <p:spPr>
-          <a:xfrm>
-            <a:off x="810001" y="1741064"/>
-            <a:ext cx="10571998" cy="1928264"/>
-          </a:xfrm>
-        </p:spPr>
-        <p:txBody>
-          <a:bodyPr/>
-          <a:lstStyle/>
-          <a:p>
-            <a:pPr lvl="0"/>
-            <a:r>
-              <a:rPr lang="en-ZA" sz="4800" noProof="0" dirty="0"/>
-              <a:t>Frontend</a:t>
-            </a:r>
-          </a:p>
-        </p:txBody>
-      </p:sp>
-      <p:sp>
-        <p:nvSpPr>
-          <p:cNvPr id="3" name="Subtitle 2">
-            <a:extLst>
-              <a:ext uri="{FF2B5EF4-FFF2-40B4-BE49-F238E27FC236}">
-                <a16:creationId xmlns:a16="http://schemas.microsoft.com/office/drawing/2014/main" id="{FA1DC89D-3720-8F56-E7BF-F10DA77B6C29}"/>
-              </a:ext>
-            </a:extLst>
-          </p:cNvPr>
-          <p:cNvSpPr>
-            <a:spLocks noGrp="1"/>
-          </p:cNvSpPr>
-          <p:nvPr>
-            <p:ph type="subTitle" idx="1"/>
-          </p:nvPr>
-        </p:nvSpPr>
-        <p:spPr>
-          <a:xfrm>
-            <a:off x="810000" y="3694102"/>
-            <a:ext cx="10572000" cy="896468"/>
-          </a:xfrm>
-        </p:spPr>
-        <p:txBody>
-          <a:bodyPr/>
-          <a:lstStyle/>
-          <a:p>
-            <a:pPr lvl="0"/>
-            <a:r>
-              <a:rPr lang="en-ZA" noProof="0" dirty="0"/>
-              <a:t>Simple But Effective.</a:t>
-            </a:r>
-          </a:p>
-        </p:txBody>
-      </p:sp>
-    </p:spTree>
-    <p:extLst>
-      <p:ext uri="{BB962C8B-B14F-4D97-AF65-F5344CB8AC3E}">
-        <p14:creationId xmlns:p14="http://schemas.microsoft.com/office/powerpoint/2010/main" val="3226493198"/>
-      </p:ext>
-    </p:extLst>
-  </p:cSld>
-  <p:clrMapOvr>
-    <a:masterClrMapping/>
-  </p:clrMapOvr>
-</p:sld>
-</file>
-
-<file path=ppt/slides/slide23.xml><?xml version="1.0" encoding="utf-8"?>
-<p:sld xmlns:a="http://schemas.openxmlformats.org/drawingml/2006/main" xmlns:r="http://schemas.openxmlformats.org/officeDocument/2006/relationships" xmlns:p="http://schemas.openxmlformats.org/presentationml/2006/main">
-  <p:cSld>
-    <p:spTree>
-      <p:nvGrpSpPr>
-        <p:cNvPr id="1" name="">
-          <a:extLst>
-            <a:ext uri="{FF2B5EF4-FFF2-40B4-BE49-F238E27FC236}">
               <a16:creationId xmlns:a16="http://schemas.microsoft.com/office/drawing/2014/main" id="{C4EA7FA7-BD37-218F-D0B6-A6AA1360A86F}"/>
             </a:ext>
           </a:extLst>
@@ -11469,7 +11473,7 @@
 </p:sld>
 </file>
 
-<file path=ppt/slides/slide24.xml><?xml version="1.0" encoding="utf-8"?>
+<file path=ppt/slides/slide21.xml><?xml version="1.0" encoding="utf-8"?>
 <p:sld xmlns:a="http://schemas.openxmlformats.org/drawingml/2006/main" xmlns:r="http://schemas.openxmlformats.org/officeDocument/2006/relationships" xmlns:p="http://schemas.openxmlformats.org/presentationml/2006/main">
   <p:cSld>
     <p:spTree>
@@ -11574,7 +11578,7 @@
 </p:sld>
 </file>
 
-<file path=ppt/slides/slide25.xml><?xml version="1.0" encoding="utf-8"?>
+<file path=ppt/slides/slide22.xml><?xml version="1.0" encoding="utf-8"?>
 <p:sld xmlns:a="http://schemas.openxmlformats.org/drawingml/2006/main" xmlns:r="http://schemas.openxmlformats.org/officeDocument/2006/relationships" xmlns:p="http://schemas.openxmlformats.org/presentationml/2006/main">
   <p:cSld>
     <p:spTree>
@@ -11697,7 +11701,7 @@
 </p:sld>
 </file>
 
-<file path=ppt/slides/slide26.xml><?xml version="1.0" encoding="utf-8"?>
+<file path=ppt/slides/slide23.xml><?xml version="1.0" encoding="utf-8"?>
 <p:sld xmlns:a="http://schemas.openxmlformats.org/drawingml/2006/main" xmlns:r="http://schemas.openxmlformats.org/officeDocument/2006/relationships" xmlns:p="http://schemas.openxmlformats.org/presentationml/2006/main">
   <p:cSld>
     <p:spTree>
@@ -11801,7 +11805,7 @@
 </p:sld>
 </file>
 
-<file path=ppt/slides/slide27.xml><?xml version="1.0" encoding="utf-8"?>
+<file path=ppt/slides/slide24.xml><?xml version="1.0" encoding="utf-8"?>
 <p:sld xmlns:a="http://schemas.openxmlformats.org/drawingml/2006/main" xmlns:r="http://schemas.openxmlformats.org/officeDocument/2006/relationships" xmlns:p="http://schemas.openxmlformats.org/presentationml/2006/main">
   <p:cSld>
     <p:spTree>
@@ -11902,7 +11906,7 @@
 </p:sld>
 </file>
 
-<file path=ppt/slides/slide28.xml><?xml version="1.0" encoding="utf-8"?>
+<file path=ppt/slides/slide25.xml><?xml version="1.0" encoding="utf-8"?>
 <p:sld xmlns:a="http://schemas.openxmlformats.org/drawingml/2006/main" xmlns:r="http://schemas.openxmlformats.org/officeDocument/2006/relationships" xmlns:p="http://schemas.openxmlformats.org/presentationml/2006/main">
   <p:cSld>
     <p:spTree>
@@ -12006,7 +12010,7 @@
 </p:sld>
 </file>
 
-<file path=ppt/slides/slide29.xml><?xml version="1.0" encoding="utf-8"?>
+<file path=ppt/slides/slide26.xml><?xml version="1.0" encoding="utf-8"?>
 <p:sld xmlns:a="http://schemas.openxmlformats.org/drawingml/2006/main" xmlns:r="http://schemas.openxmlformats.org/officeDocument/2006/relationships" xmlns:p="http://schemas.openxmlformats.org/presentationml/2006/main">
   <p:cSld>
     <p:spTree>
@@ -12046,17 +12050,17 @@
           <a:p>
             <a:r>
               <a:rPr lang="en-ZA" dirty="0"/>
-              <a:t>Pulse</a:t>
+              <a:t>Repo Link</a:t>
             </a:r>
           </a:p>
         </p:txBody>
       </p:sp>
       <p:pic>
         <p:nvPicPr>
-          <p:cNvPr id="10" name="Picture 9">
-            <a:extLst>
-              <a:ext uri="{FF2B5EF4-FFF2-40B4-BE49-F238E27FC236}">
-                <a16:creationId xmlns:a16="http://schemas.microsoft.com/office/drawing/2014/main" id="{2493F3D8-F4EA-4FAA-BBD3-A9B25701C303}"/>
+          <p:cNvPr id="3" name="Picture 2">
+            <a:extLst>
+              <a:ext uri="{FF2B5EF4-FFF2-40B4-BE49-F238E27FC236}">
+                <a16:creationId xmlns:a16="http://schemas.microsoft.com/office/drawing/2014/main" id="{0D8CAFB3-86B4-942A-4C30-F5C1CE68244A}"/>
               </a:ext>
             </a:extLst>
           </p:cNvPr>
@@ -12073,8 +12077,8 @@
         </p:blipFill>
         <p:spPr>
           <a:xfrm>
-            <a:off x="3874717" y="1249325"/>
-            <a:ext cx="7787348" cy="4359349"/>
+            <a:off x="4851691" y="419100"/>
+            <a:ext cx="6019800" cy="6019800"/>
           </a:xfrm>
           <a:prstGeom prst="rect">
             <a:avLst/>
@@ -12085,6 +12089,298 @@
     <p:extLst>
       <p:ext uri="{BB962C8B-B14F-4D97-AF65-F5344CB8AC3E}">
         <p14:creationId xmlns:p14="http://schemas.microsoft.com/office/powerpoint/2010/main" val="3132273718"/>
+      </p:ext>
+    </p:extLst>
+  </p:cSld>
+  <p:clrMapOvr>
+    <a:masterClrMapping/>
+  </p:clrMapOvr>
+</p:sld>
+</file>
+
+<file path=ppt/slides/slide27.xml><?xml version="1.0" encoding="utf-8"?>
+<p:sld xmlns:a="http://schemas.openxmlformats.org/drawingml/2006/main" xmlns:r="http://schemas.openxmlformats.org/officeDocument/2006/relationships" xmlns:p="http://schemas.openxmlformats.org/presentationml/2006/main">
+  <p:cSld>
+    <p:spTree>
+      <p:nvGrpSpPr>
+        <p:cNvPr id="1" name="">
+          <a:extLst>
+            <a:ext uri="{FF2B5EF4-FFF2-40B4-BE49-F238E27FC236}">
+              <a16:creationId xmlns:a16="http://schemas.microsoft.com/office/drawing/2014/main" id="{0B8CB542-4BC7-6469-E818-32103E80F15C}"/>
+            </a:ext>
+          </a:extLst>
+        </p:cNvPr>
+        <p:cNvGrpSpPr/>
+        <p:nvPr/>
+      </p:nvGrpSpPr>
+      <p:grpSpPr>
+        <a:xfrm>
+          <a:off x="0" y="0"/>
+          <a:ext cx="0" cy="0"/>
+          <a:chOff x="0" y="0"/>
+          <a:chExt cx="0" cy="0"/>
+        </a:xfrm>
+      </p:grpSpPr>
+      <p:sp>
+        <p:nvSpPr>
+          <p:cNvPr id="4" name="Title 3">
+            <a:extLst>
+              <a:ext uri="{FF2B5EF4-FFF2-40B4-BE49-F238E27FC236}">
+                <a16:creationId xmlns:a16="http://schemas.microsoft.com/office/drawing/2014/main" id="{7C3F0AC1-40E8-9BD4-6605-8EC964DB15CF}"/>
+              </a:ext>
+            </a:extLst>
+          </p:cNvPr>
+          <p:cNvSpPr>
+            <a:spLocks noGrp="1"/>
+          </p:cNvSpPr>
+          <p:nvPr>
+            <p:ph type="title"/>
+          </p:nvPr>
+        </p:nvSpPr>
+        <p:spPr/>
+        <p:txBody>
+          <a:bodyPr/>
+          <a:lstStyle/>
+          <a:p>
+            <a:r>
+              <a:rPr lang="en-ZA" dirty="0"/>
+              <a:t>Pulse</a:t>
+            </a:r>
+          </a:p>
+        </p:txBody>
+      </p:sp>
+      <p:pic>
+        <p:nvPicPr>
+          <p:cNvPr id="3" name="Picture 2">
+            <a:extLst>
+              <a:ext uri="{FF2B5EF4-FFF2-40B4-BE49-F238E27FC236}">
+                <a16:creationId xmlns:a16="http://schemas.microsoft.com/office/drawing/2014/main" id="{395495AC-1584-CC01-81DD-5663C93F3A6A}"/>
+              </a:ext>
+            </a:extLst>
+          </p:cNvPr>
+          <p:cNvPicPr>
+            <a:picLocks noChangeAspect="1"/>
+          </p:cNvPicPr>
+          <p:nvPr/>
+        </p:nvPicPr>
+        <p:blipFill>
+          <a:blip r:embed="rId2"/>
+          <a:stretch>
+            <a:fillRect/>
+          </a:stretch>
+        </p:blipFill>
+        <p:spPr>
+          <a:xfrm>
+            <a:off x="4037936" y="1189265"/>
+            <a:ext cx="7465780" cy="4479469"/>
+          </a:xfrm>
+          <a:prstGeom prst="rect">
+            <a:avLst/>
+          </a:prstGeom>
+        </p:spPr>
+      </p:pic>
+    </p:spTree>
+    <p:extLst>
+      <p:ext uri="{BB962C8B-B14F-4D97-AF65-F5344CB8AC3E}">
+        <p14:creationId xmlns:p14="http://schemas.microsoft.com/office/powerpoint/2010/main" val="592772776"/>
+      </p:ext>
+    </p:extLst>
+  </p:cSld>
+  <p:clrMapOvr>
+    <a:masterClrMapping/>
+  </p:clrMapOvr>
+</p:sld>
+</file>
+
+<file path=ppt/slides/slide28.xml><?xml version="1.0" encoding="utf-8"?>
+<p:sld xmlns:a="http://schemas.openxmlformats.org/drawingml/2006/main" xmlns:r="http://schemas.openxmlformats.org/officeDocument/2006/relationships" xmlns:p="http://schemas.openxmlformats.org/presentationml/2006/main">
+  <p:cSld>
+    <p:spTree>
+      <p:nvGrpSpPr>
+        <p:cNvPr id="1" name="">
+          <a:extLst>
+            <a:ext uri="{FF2B5EF4-FFF2-40B4-BE49-F238E27FC236}">
+              <a16:creationId xmlns:a16="http://schemas.microsoft.com/office/drawing/2014/main" id="{C3E6BC04-A865-A559-E0DA-5E5356CA358A}"/>
+            </a:ext>
+          </a:extLst>
+        </p:cNvPr>
+        <p:cNvGrpSpPr/>
+        <p:nvPr/>
+      </p:nvGrpSpPr>
+      <p:grpSpPr>
+        <a:xfrm>
+          <a:off x="0" y="0"/>
+          <a:ext cx="0" cy="0"/>
+          <a:chOff x="0" y="0"/>
+          <a:chExt cx="0" cy="0"/>
+        </a:xfrm>
+      </p:grpSpPr>
+      <p:sp>
+        <p:nvSpPr>
+          <p:cNvPr id="4" name="Title 3">
+            <a:extLst>
+              <a:ext uri="{FF2B5EF4-FFF2-40B4-BE49-F238E27FC236}">
+                <a16:creationId xmlns:a16="http://schemas.microsoft.com/office/drawing/2014/main" id="{80C05FD1-4873-6DCE-FB13-60F868601142}"/>
+              </a:ext>
+            </a:extLst>
+          </p:cNvPr>
+          <p:cNvSpPr>
+            <a:spLocks noGrp="1"/>
+          </p:cNvSpPr>
+          <p:nvPr>
+            <p:ph type="title"/>
+          </p:nvPr>
+        </p:nvSpPr>
+        <p:spPr/>
+        <p:txBody>
+          <a:bodyPr/>
+          <a:lstStyle/>
+          <a:p>
+            <a:r>
+              <a:rPr lang="en-ZA" dirty="0"/>
+              <a:t>Contributors</a:t>
+            </a:r>
+          </a:p>
+        </p:txBody>
+      </p:sp>
+      <p:pic>
+        <p:nvPicPr>
+          <p:cNvPr id="3" name="Picture 2">
+            <a:extLst>
+              <a:ext uri="{FF2B5EF4-FFF2-40B4-BE49-F238E27FC236}">
+                <a16:creationId xmlns:a16="http://schemas.microsoft.com/office/drawing/2014/main" id="{BD7DCDA7-06D9-C4B7-6750-50DCB64AD9C8}"/>
+              </a:ext>
+            </a:extLst>
+          </p:cNvPr>
+          <p:cNvPicPr>
+            <a:picLocks noChangeAspect="1"/>
+          </p:cNvPicPr>
+          <p:nvPr/>
+        </p:nvPicPr>
+        <p:blipFill>
+          <a:blip r:embed="rId2"/>
+          <a:stretch>
+            <a:fillRect/>
+          </a:stretch>
+        </p:blipFill>
+        <p:spPr>
+          <a:xfrm>
+            <a:off x="5503179" y="425166"/>
+            <a:ext cx="4726671" cy="6007668"/>
+          </a:xfrm>
+          <a:prstGeom prst="rect">
+            <a:avLst/>
+          </a:prstGeom>
+        </p:spPr>
+      </p:pic>
+    </p:spTree>
+    <p:extLst>
+      <p:ext uri="{BB962C8B-B14F-4D97-AF65-F5344CB8AC3E}">
+        <p14:creationId xmlns:p14="http://schemas.microsoft.com/office/powerpoint/2010/main" val="3708406915"/>
+      </p:ext>
+    </p:extLst>
+  </p:cSld>
+  <p:clrMapOvr>
+    <a:masterClrMapping/>
+  </p:clrMapOvr>
+</p:sld>
+</file>
+
+<file path=ppt/slides/slide29.xml><?xml version="1.0" encoding="utf-8"?>
+<p:sld xmlns:a="http://schemas.openxmlformats.org/drawingml/2006/main" xmlns:r="http://schemas.openxmlformats.org/officeDocument/2006/relationships" xmlns:p="http://schemas.openxmlformats.org/presentationml/2006/main">
+  <p:cSld>
+    <p:spTree>
+      <p:nvGrpSpPr>
+        <p:cNvPr id="1" name="">
+          <a:extLst>
+            <a:ext uri="{FF2B5EF4-FFF2-40B4-BE49-F238E27FC236}">
+              <a16:creationId xmlns:a16="http://schemas.microsoft.com/office/drawing/2014/main" id="{DC02169F-BCD5-1F64-84C0-227C2A3A077C}"/>
+            </a:ext>
+          </a:extLst>
+        </p:cNvPr>
+        <p:cNvGrpSpPr/>
+        <p:nvPr/>
+      </p:nvGrpSpPr>
+      <p:grpSpPr>
+        <a:xfrm>
+          <a:off x="0" y="0"/>
+          <a:ext cx="0" cy="0"/>
+          <a:chOff x="0" y="0"/>
+          <a:chExt cx="0" cy="0"/>
+        </a:xfrm>
+      </p:grpSpPr>
+      <p:sp>
+        <p:nvSpPr>
+          <p:cNvPr id="2" name="Title 1">
+            <a:extLst>
+              <a:ext uri="{FF2B5EF4-FFF2-40B4-BE49-F238E27FC236}">
+                <a16:creationId xmlns:a16="http://schemas.microsoft.com/office/drawing/2014/main" id="{DA1035ED-08C8-62D3-6919-B441653A4A01}"/>
+              </a:ext>
+            </a:extLst>
+          </p:cNvPr>
+          <p:cNvSpPr>
+            <a:spLocks noGrp="1"/>
+          </p:cNvSpPr>
+          <p:nvPr>
+            <p:ph type="title"/>
+          </p:nvPr>
+        </p:nvSpPr>
+        <p:spPr>
+          <a:xfrm>
+            <a:off x="810001" y="1741064"/>
+            <a:ext cx="10571998" cy="1928264"/>
+          </a:xfrm>
+        </p:spPr>
+        <p:txBody>
+          <a:bodyPr/>
+          <a:lstStyle/>
+          <a:p>
+            <a:pPr lvl="0"/>
+            <a:r>
+              <a:rPr lang="en-ZA" sz="4800" noProof="0" dirty="0"/>
+              <a:t>Testing</a:t>
+            </a:r>
+          </a:p>
+        </p:txBody>
+      </p:sp>
+      <p:sp>
+        <p:nvSpPr>
+          <p:cNvPr id="3" name="Subtitle 2">
+            <a:extLst>
+              <a:ext uri="{FF2B5EF4-FFF2-40B4-BE49-F238E27FC236}">
+                <a16:creationId xmlns:a16="http://schemas.microsoft.com/office/drawing/2014/main" id="{C334B120-275C-0233-5DE2-FD9361CE52AB}"/>
+              </a:ext>
+            </a:extLst>
+          </p:cNvPr>
+          <p:cNvSpPr>
+            <a:spLocks noGrp="1"/>
+          </p:cNvSpPr>
+          <p:nvPr>
+            <p:ph type="subTitle" idx="1"/>
+          </p:nvPr>
+        </p:nvSpPr>
+        <p:spPr>
+          <a:xfrm>
+            <a:off x="810000" y="3694102"/>
+            <a:ext cx="10572000" cy="896468"/>
+          </a:xfrm>
+        </p:spPr>
+        <p:txBody>
+          <a:bodyPr/>
+          <a:lstStyle/>
+          <a:p>
+            <a:pPr lvl="0"/>
+            <a:r>
+              <a:rPr lang="en-ZA" noProof="0" dirty="0"/>
+              <a:t>How we tested our system.</a:t>
+            </a:r>
+          </a:p>
+        </p:txBody>
+      </p:sp>
+    </p:spTree>
+    <p:extLst>
+      <p:ext uri="{BB962C8B-B14F-4D97-AF65-F5344CB8AC3E}">
+        <p14:creationId xmlns:p14="http://schemas.microsoft.com/office/powerpoint/2010/main" val="3793484625"/>
       </p:ext>
     </p:extLst>
   </p:cSld>
@@ -12200,204 +12496,6 @@
         <p:cNvPr id="1" name="">
           <a:extLst>
             <a:ext uri="{FF2B5EF4-FFF2-40B4-BE49-F238E27FC236}">
-              <a16:creationId xmlns:a16="http://schemas.microsoft.com/office/drawing/2014/main" id="{C3E6BC04-A865-A559-E0DA-5E5356CA358A}"/>
-            </a:ext>
-          </a:extLst>
-        </p:cNvPr>
-        <p:cNvGrpSpPr/>
-        <p:nvPr/>
-      </p:nvGrpSpPr>
-      <p:grpSpPr>
-        <a:xfrm>
-          <a:off x="0" y="0"/>
-          <a:ext cx="0" cy="0"/>
-          <a:chOff x="0" y="0"/>
-          <a:chExt cx="0" cy="0"/>
-        </a:xfrm>
-      </p:grpSpPr>
-      <p:sp>
-        <p:nvSpPr>
-          <p:cNvPr id="4" name="Title 3">
-            <a:extLst>
-              <a:ext uri="{FF2B5EF4-FFF2-40B4-BE49-F238E27FC236}">
-                <a16:creationId xmlns:a16="http://schemas.microsoft.com/office/drawing/2014/main" id="{80C05FD1-4873-6DCE-FB13-60F868601142}"/>
-              </a:ext>
-            </a:extLst>
-          </p:cNvPr>
-          <p:cNvSpPr>
-            <a:spLocks noGrp="1"/>
-          </p:cNvSpPr>
-          <p:nvPr>
-            <p:ph type="title"/>
-          </p:nvPr>
-        </p:nvSpPr>
-        <p:spPr/>
-        <p:txBody>
-          <a:bodyPr/>
-          <a:lstStyle/>
-          <a:p>
-            <a:r>
-              <a:rPr lang="en-ZA" dirty="0"/>
-              <a:t>Contributors</a:t>
-            </a:r>
-          </a:p>
-        </p:txBody>
-      </p:sp>
-      <p:pic>
-        <p:nvPicPr>
-          <p:cNvPr id="8" name="Picture 7">
-            <a:extLst>
-              <a:ext uri="{FF2B5EF4-FFF2-40B4-BE49-F238E27FC236}">
-                <a16:creationId xmlns:a16="http://schemas.microsoft.com/office/drawing/2014/main" id="{A35B2405-B765-B06B-A5C2-BAFF2F4F0C54}"/>
-              </a:ext>
-            </a:extLst>
-          </p:cNvPr>
-          <p:cNvPicPr>
-            <a:picLocks noChangeAspect="1"/>
-          </p:cNvPicPr>
-          <p:nvPr/>
-        </p:nvPicPr>
-        <p:blipFill>
-          <a:blip r:embed="rId2"/>
-          <a:stretch>
-            <a:fillRect/>
-          </a:stretch>
-        </p:blipFill>
-        <p:spPr>
-          <a:xfrm>
-            <a:off x="4362450" y="794382"/>
-            <a:ext cx="6730012" cy="5269235"/>
-          </a:xfrm>
-          <a:prstGeom prst="rect">
-            <a:avLst/>
-          </a:prstGeom>
-        </p:spPr>
-      </p:pic>
-    </p:spTree>
-    <p:extLst>
-      <p:ext uri="{BB962C8B-B14F-4D97-AF65-F5344CB8AC3E}">
-        <p14:creationId xmlns:p14="http://schemas.microsoft.com/office/powerpoint/2010/main" val="3708406915"/>
-      </p:ext>
-    </p:extLst>
-  </p:cSld>
-  <p:clrMapOvr>
-    <a:masterClrMapping/>
-  </p:clrMapOvr>
-</p:sld>
-</file>
-
-<file path=ppt/slides/slide31.xml><?xml version="1.0" encoding="utf-8"?>
-<p:sld xmlns:a="http://schemas.openxmlformats.org/drawingml/2006/main" xmlns:r="http://schemas.openxmlformats.org/officeDocument/2006/relationships" xmlns:p="http://schemas.openxmlformats.org/presentationml/2006/main">
-  <p:cSld>
-    <p:spTree>
-      <p:nvGrpSpPr>
-        <p:cNvPr id="1" name="">
-          <a:extLst>
-            <a:ext uri="{FF2B5EF4-FFF2-40B4-BE49-F238E27FC236}">
-              <a16:creationId xmlns:a16="http://schemas.microsoft.com/office/drawing/2014/main" id="{DC02169F-BCD5-1F64-84C0-227C2A3A077C}"/>
-            </a:ext>
-          </a:extLst>
-        </p:cNvPr>
-        <p:cNvGrpSpPr/>
-        <p:nvPr/>
-      </p:nvGrpSpPr>
-      <p:grpSpPr>
-        <a:xfrm>
-          <a:off x="0" y="0"/>
-          <a:ext cx="0" cy="0"/>
-          <a:chOff x="0" y="0"/>
-          <a:chExt cx="0" cy="0"/>
-        </a:xfrm>
-      </p:grpSpPr>
-      <p:sp>
-        <p:nvSpPr>
-          <p:cNvPr id="2" name="Title 1">
-            <a:extLst>
-              <a:ext uri="{FF2B5EF4-FFF2-40B4-BE49-F238E27FC236}">
-                <a16:creationId xmlns:a16="http://schemas.microsoft.com/office/drawing/2014/main" id="{DA1035ED-08C8-62D3-6919-B441653A4A01}"/>
-              </a:ext>
-            </a:extLst>
-          </p:cNvPr>
-          <p:cNvSpPr>
-            <a:spLocks noGrp="1"/>
-          </p:cNvSpPr>
-          <p:nvPr>
-            <p:ph type="title"/>
-          </p:nvPr>
-        </p:nvSpPr>
-        <p:spPr>
-          <a:xfrm>
-            <a:off x="810001" y="1741064"/>
-            <a:ext cx="10571998" cy="1928264"/>
-          </a:xfrm>
-        </p:spPr>
-        <p:txBody>
-          <a:bodyPr/>
-          <a:lstStyle/>
-          <a:p>
-            <a:pPr lvl="0"/>
-            <a:r>
-              <a:rPr lang="en-ZA" sz="4800" noProof="0" dirty="0"/>
-              <a:t>Testing</a:t>
-            </a:r>
-          </a:p>
-        </p:txBody>
-      </p:sp>
-      <p:sp>
-        <p:nvSpPr>
-          <p:cNvPr id="3" name="Subtitle 2">
-            <a:extLst>
-              <a:ext uri="{FF2B5EF4-FFF2-40B4-BE49-F238E27FC236}">
-                <a16:creationId xmlns:a16="http://schemas.microsoft.com/office/drawing/2014/main" id="{C334B120-275C-0233-5DE2-FD9361CE52AB}"/>
-              </a:ext>
-            </a:extLst>
-          </p:cNvPr>
-          <p:cNvSpPr>
-            <a:spLocks noGrp="1"/>
-          </p:cNvSpPr>
-          <p:nvPr>
-            <p:ph type="subTitle" idx="1"/>
-          </p:nvPr>
-        </p:nvSpPr>
-        <p:spPr>
-          <a:xfrm>
-            <a:off x="810000" y="3694102"/>
-            <a:ext cx="10572000" cy="896468"/>
-          </a:xfrm>
-        </p:spPr>
-        <p:txBody>
-          <a:bodyPr/>
-          <a:lstStyle/>
-          <a:p>
-            <a:pPr lvl="0"/>
-            <a:r>
-              <a:rPr lang="en-ZA" noProof="0" dirty="0"/>
-              <a:t>How we tested our system.</a:t>
-            </a:r>
-          </a:p>
-        </p:txBody>
-      </p:sp>
-    </p:spTree>
-    <p:extLst>
-      <p:ext uri="{BB962C8B-B14F-4D97-AF65-F5344CB8AC3E}">
-        <p14:creationId xmlns:p14="http://schemas.microsoft.com/office/powerpoint/2010/main" val="3793484625"/>
-      </p:ext>
-    </p:extLst>
-  </p:cSld>
-  <p:clrMapOvr>
-    <a:masterClrMapping/>
-  </p:clrMapOvr>
-</p:sld>
-</file>
-
-<file path=ppt/slides/slide32.xml><?xml version="1.0" encoding="utf-8"?>
-<p:sld xmlns:a="http://schemas.openxmlformats.org/drawingml/2006/main" xmlns:r="http://schemas.openxmlformats.org/officeDocument/2006/relationships" xmlns:p="http://schemas.openxmlformats.org/presentationml/2006/main">
-  <p:cSld>
-    <p:spTree>
-      <p:nvGrpSpPr>
-        <p:cNvPr id="1" name="">
-          <a:extLst>
-            <a:ext uri="{FF2B5EF4-FFF2-40B4-BE49-F238E27FC236}">
               <a16:creationId xmlns:a16="http://schemas.microsoft.com/office/drawing/2014/main" id="{E6F50098-5446-564E-3192-677D7030A696}"/>
             </a:ext>
           </a:extLst>
@@ -12544,7 +12642,7 @@
 </p:sld>
 </file>
 
-<file path=ppt/slides/slide33.xml><?xml version="1.0" encoding="utf-8"?>
+<file path=ppt/slides/slide31.xml><?xml version="1.0" encoding="utf-8"?>
 <p:sld xmlns:a="http://schemas.openxmlformats.org/drawingml/2006/main" xmlns:r="http://schemas.openxmlformats.org/officeDocument/2006/relationships" xmlns:p="http://schemas.openxmlformats.org/presentationml/2006/main">
   <p:cSld>
     <p:spTree>
@@ -12635,13 +12733,13 @@
             </a:r>
             <a:r>
               <a:rPr lang="en-ZA" noProof="0" dirty="0"/>
-              <a:t>25------</a:t>
+              <a:t>24------</a:t>
             </a:r>
           </a:p>
           <a:p>
             <a:r>
               <a:rPr lang="en-ZA" dirty="0"/>
-              <a:t>u25------</a:t>
+              <a:t>u24------</a:t>
             </a:r>
           </a:p>
           <a:p>
@@ -12934,7 +13032,7 @@
         <p:spPr>
           <a:xfrm>
             <a:off x="529935" y="633845"/>
-            <a:ext cx="3990110" cy="2192482"/>
+            <a:ext cx="3990110" cy="2137930"/>
           </a:xfrm>
         </p:spPr>
         <p:txBody>
@@ -12943,8 +13041,12 @@
           <a:p>
             <a:r>
               <a:rPr lang="en-ZA" noProof="0" dirty="0"/>
-              <a:t>UML Class Diagram</a:t>
-            </a:r>
+              <a:t>UML Diagrams</a:t>
+            </a:r>
+            <a:br>
+              <a:rPr lang="en-ZA" noProof="0" dirty="0"/>
+            </a:br>
+            <a:endParaRPr lang="en-ZA" noProof="0" dirty="0"/>
           </a:p>
         </p:txBody>
       </p:sp>
@@ -12966,13 +13068,30 @@
         </p:nvSpPr>
         <p:spPr>
           <a:xfrm>
-            <a:off x="747423" y="3174531"/>
-            <a:ext cx="3772622" cy="3122360"/>
-          </a:xfrm>
-        </p:spPr>
-        <p:txBody>
-          <a:bodyPr/>
+            <a:off x="638679" y="2022005"/>
+            <a:ext cx="3772622" cy="2940519"/>
+          </a:xfrm>
+        </p:spPr>
+        <p:txBody>
+          <a:bodyPr>
+            <a:normAutofit/>
+          </a:bodyPr>
           <a:lstStyle/>
+          <a:p>
+            <a:pPr marL="0" lvl="0" indent="0" algn="ctr">
+              <a:buNone/>
+            </a:pPr>
+            <a:r>
+              <a:rPr lang="en-ZA" noProof="0" dirty="0"/>
+              <a:t>All diagrams are provided upon scanning the QR-code.</a:t>
+            </a:r>
+          </a:p>
+          <a:p>
+            <a:pPr marL="0" lvl="0" indent="0" algn="ctr">
+              <a:buNone/>
+            </a:pPr>
+            <a:endParaRPr lang="en-ZA" noProof="0" dirty="0"/>
+          </a:p>
           <a:p>
             <a:pPr lvl="0"/>
             <a:r>
@@ -12991,19 +13110,17 @@
       </p:sp>
       <p:pic>
         <p:nvPicPr>
-          <p:cNvPr id="8" name="Content Placeholder 7">
-            <a:extLst>
-              <a:ext uri="{FF2B5EF4-FFF2-40B4-BE49-F238E27FC236}">
-                <a16:creationId xmlns:a16="http://schemas.microsoft.com/office/drawing/2014/main" id="{AE46D458-C42C-8C39-1F40-ACCA9FEA126B}"/>
+          <p:cNvPr id="3" name="Picture 2">
+            <a:extLst>
+              <a:ext uri="{FF2B5EF4-FFF2-40B4-BE49-F238E27FC236}">
+                <a16:creationId xmlns:a16="http://schemas.microsoft.com/office/drawing/2014/main" id="{BDE3DC65-A925-6F94-CD67-B54FF3A9AF06}"/>
               </a:ext>
             </a:extLst>
           </p:cNvPr>
           <p:cNvPicPr>
-            <a:picLocks noGrp="1" noChangeAspect="1"/>
+            <a:picLocks noChangeAspect="1"/>
           </p:cNvPicPr>
-          <p:nvPr>
-            <p:ph sz="quarter" idx="10"/>
-          </p:nvPr>
+          <p:nvPr/>
         </p:nvPicPr>
         <p:blipFill>
           <a:blip r:embed="rId3"/>
@@ -13013,13 +13130,12 @@
         </p:blipFill>
         <p:spPr>
           <a:xfrm>
-            <a:off x="4776297" y="1104900"/>
-            <a:ext cx="6873571" cy="4829175"/>
+            <a:off x="5267325" y="428625"/>
+            <a:ext cx="6000750" cy="6000750"/>
           </a:xfrm>
           <a:prstGeom prst="rect">
             <a:avLst/>
           </a:prstGeom>
-          <a:effectLst/>
         </p:spPr>
       </p:pic>
     </p:spTree>
@@ -13297,7 +13413,7 @@
             </a:pPr>
             <a:r>
               <a:rPr lang="en-ZA" noProof="0" dirty="0"/>
-              <a:t>Adapter</a:t>
+              <a:t>Template Method</a:t>
             </a:r>
           </a:p>
           <a:p>
@@ -13314,41 +13430,9 @@
               <a:buAutoNum type="arabicPeriod"/>
             </a:pPr>
             <a:r>
-              <a:rPr lang="en-ZA" noProof="0" dirty="0"/>
-              <a:t>State</a:t>
-            </a:r>
-          </a:p>
-          <a:p>
-            <a:pPr marL="342900" lvl="0" indent="-342900" algn="l">
-              <a:lnSpc>
-                <a:spcPct val="100000"/>
-              </a:lnSpc>
-              <a:buClr>
-                <a:schemeClr val="accent1">
-                  <a:lumMod val="50000"/>
-                </a:schemeClr>
-              </a:buClr>
-              <a:buFont typeface="+mj-lt"/>
-              <a:buAutoNum type="arabicPeriod"/>
-            </a:pPr>
-            <a:r>
-              <a:rPr lang="en-ZA" noProof="0" dirty="0"/>
-              <a:t>(Accidental Visitor)</a:t>
-            </a:r>
-          </a:p>
-          <a:p>
-            <a:pPr marL="342900" lvl="0" indent="-342900">
-              <a:lnSpc>
-                <a:spcPct val="100000"/>
-              </a:lnSpc>
-              <a:buClr>
-                <a:schemeClr val="accent1">
-                  <a:lumMod val="50000"/>
-                </a:schemeClr>
-              </a:buClr>
-              <a:buFont typeface="+mj-lt"/>
-              <a:buAutoNum type="arabicPeriod"/>
-            </a:pPr>
+              <a:rPr lang="en-ZA" dirty="0"/>
+              <a:t>Visitor</a:t>
+            </a:r>
             <a:endParaRPr lang="en-ZA" noProof="0" dirty="0"/>
           </a:p>
           <a:p>
@@ -13540,10 +13624,10 @@
       </p:sp>
       <p:pic>
         <p:nvPicPr>
-          <p:cNvPr id="7" name="Picture 6">
-            <a:extLst>
-              <a:ext uri="{FF2B5EF4-FFF2-40B4-BE49-F238E27FC236}">
-                <a16:creationId xmlns:a16="http://schemas.microsoft.com/office/drawing/2014/main" id="{3A0F00F5-A326-515B-D635-57F41C898702}"/>
+          <p:cNvPr id="5" name="Picture 4">
+            <a:extLst>
+              <a:ext uri="{FF2B5EF4-FFF2-40B4-BE49-F238E27FC236}">
+                <a16:creationId xmlns:a16="http://schemas.microsoft.com/office/drawing/2014/main" id="{321E5F2E-69FC-CB20-CFE0-A3355C5D05BC}"/>
               </a:ext>
             </a:extLst>
           </p:cNvPr>
@@ -13560,8 +13644,8 @@
         </p:blipFill>
         <p:spPr>
           <a:xfrm>
-            <a:off x="1350275" y="835613"/>
-            <a:ext cx="3213380" cy="5186774"/>
+            <a:off x="1047528" y="840903"/>
+            <a:ext cx="3956176" cy="5176194"/>
           </a:xfrm>
           <a:prstGeom prst="rect">
             <a:avLst/>
@@ -13589,7 +13673,7 @@
         <p:cNvPr id="1" name="">
           <a:extLst>
             <a:ext uri="{FF2B5EF4-FFF2-40B4-BE49-F238E27FC236}">
-              <a16:creationId xmlns:a16="http://schemas.microsoft.com/office/drawing/2014/main" id="{4821863A-9F16-28AC-0CF2-F43AABA963B0}"/>
+              <a16:creationId xmlns:a16="http://schemas.microsoft.com/office/drawing/2014/main" id="{0D086A51-AFEF-F42E-BFB5-65545E543311}"/>
             </a:ext>
           </a:extLst>
         </p:cNvPr>
@@ -13604,123 +13688,12 @@
           <a:chExt cx="0" cy="0"/>
         </a:xfrm>
       </p:grpSpPr>
-      <p:sp>
-        <p:nvSpPr>
-          <p:cNvPr id="2" name="Title 1">
-            <a:extLst>
-              <a:ext uri="{FF2B5EF4-FFF2-40B4-BE49-F238E27FC236}">
-                <a16:creationId xmlns:a16="http://schemas.microsoft.com/office/drawing/2014/main" id="{68DAEA9A-8AA5-711C-6EFC-C92AAD1E78B1}"/>
-              </a:ext>
-            </a:extLst>
-          </p:cNvPr>
-          <p:cNvSpPr>
-            <a:spLocks noGrp="1"/>
-          </p:cNvSpPr>
-          <p:nvPr>
-            <p:ph type="title"/>
-          </p:nvPr>
-        </p:nvSpPr>
-        <p:spPr/>
-        <p:txBody>
-          <a:bodyPr/>
-          <a:lstStyle/>
-          <a:p>
-            <a:r>
-              <a:rPr lang="en-ZA" noProof="0" dirty="0"/>
-              <a:t>Memento</a:t>
-            </a:r>
-          </a:p>
-        </p:txBody>
-      </p:sp>
-      <p:sp>
-        <p:nvSpPr>
-          <p:cNvPr id="3" name="Content Placeholder 2">
-            <a:extLst>
-              <a:ext uri="{FF2B5EF4-FFF2-40B4-BE49-F238E27FC236}">
-                <a16:creationId xmlns:a16="http://schemas.microsoft.com/office/drawing/2014/main" id="{D8FB1B4E-0018-68AB-F987-6978ED6249D0}"/>
-              </a:ext>
-            </a:extLst>
-          </p:cNvPr>
-          <p:cNvSpPr>
-            <a:spLocks noGrp="1"/>
-          </p:cNvSpPr>
-          <p:nvPr>
-            <p:ph sz="quarter" idx="10"/>
-          </p:nvPr>
-        </p:nvSpPr>
-        <p:spPr/>
-        <p:txBody>
-          <a:bodyPr>
-            <a:normAutofit fontScale="92500"/>
-          </a:bodyPr>
-          <a:lstStyle/>
-          <a:p>
-            <a:pPr lvl="0"/>
-            <a:r>
-              <a:rPr lang="en-ZA" b="1" noProof="0" dirty="0"/>
-              <a:t>Role:</a:t>
-            </a:r>
-          </a:p>
-          <a:p>
-            <a:pPr lvl="0"/>
-            <a:r>
-              <a:rPr lang="en-ZA" noProof="0" dirty="0"/>
-              <a:t>Saves a snapshot of the current version of the system.</a:t>
-            </a:r>
-          </a:p>
-          <a:p>
-            <a:pPr lvl="0"/>
-            <a:r>
-              <a:rPr lang="en-ZA" noProof="0" dirty="0"/>
-              <a:t>Provides version history.</a:t>
-            </a:r>
-          </a:p>
-          <a:p>
-            <a:pPr lvl="0"/>
-            <a:r>
-              <a:rPr lang="en-ZA" b="1" noProof="0" dirty="0"/>
-              <a:t>Reason: </a:t>
-            </a:r>
-          </a:p>
-          <a:p>
-            <a:pPr lvl="0"/>
-            <a:r>
-              <a:rPr lang="en-ZA" noProof="0" dirty="0"/>
-              <a:t>Often people give way to human error. Allows easy restoration after a mistake. </a:t>
-            </a:r>
-          </a:p>
-          <a:p>
-            <a:pPr lvl="0"/>
-            <a:r>
-              <a:rPr lang="en-ZA" noProof="0" dirty="0"/>
-              <a:t>Memento tracks a process history so it can be documented throughout its lifecycle.</a:t>
-            </a:r>
-          </a:p>
-          <a:p>
-            <a:pPr lvl="0"/>
-            <a:r>
-              <a:rPr lang="en-ZA" b="1" noProof="0" dirty="0"/>
-              <a:t>Relationships: </a:t>
-            </a:r>
-          </a:p>
-          <a:p>
-            <a:pPr lvl="0"/>
-            <a:r>
-              <a:rPr lang="en-ZA" noProof="0" dirty="0"/>
-              <a:t>Works alongside Façade so versions can easily be saved, regressed or retrieved. Records State of the Workflow Composite. Uses Iterator to traverse version histories.</a:t>
-            </a:r>
-          </a:p>
-          <a:p>
-            <a:endParaRPr lang="en-ZA" noProof="0" dirty="0"/>
-          </a:p>
-        </p:txBody>
-      </p:sp>
       <p:pic>
         <p:nvPicPr>
-          <p:cNvPr id="6" name="Picture 5">
-            <a:extLst>
-              <a:ext uri="{FF2B5EF4-FFF2-40B4-BE49-F238E27FC236}">
-                <a16:creationId xmlns:a16="http://schemas.microsoft.com/office/drawing/2014/main" id="{498D73B5-F85F-43FF-5FE8-DE5312FE9CA3}"/>
+          <p:cNvPr id="14" name="Picture 13">
+            <a:extLst>
+              <a:ext uri="{FF2B5EF4-FFF2-40B4-BE49-F238E27FC236}">
+                <a16:creationId xmlns:a16="http://schemas.microsoft.com/office/drawing/2014/main" id="{311A12E5-6121-E32E-7458-477279DB8C82}"/>
               </a:ext>
             </a:extLst>
           </p:cNvPr>
@@ -13730,15 +13703,172 @@
           <p:nvPr/>
         </p:nvPicPr>
         <p:blipFill>
-          <a:blip r:embed="rId2"/>
+          <a:blip r:embed="rId3"/>
           <a:stretch>
             <a:fillRect/>
           </a:stretch>
         </p:blipFill>
         <p:spPr>
           <a:xfrm>
-            <a:off x="632799" y="1753681"/>
-            <a:ext cx="4721584" cy="3350637"/>
+            <a:off x="2329323" y="4509050"/>
+            <a:ext cx="3161322" cy="1644434"/>
+          </a:xfrm>
+          <a:prstGeom prst="rect">
+            <a:avLst/>
+          </a:prstGeom>
+        </p:spPr>
+      </p:pic>
+      <p:sp>
+        <p:nvSpPr>
+          <p:cNvPr id="2" name="Title 1">
+            <a:extLst>
+              <a:ext uri="{FF2B5EF4-FFF2-40B4-BE49-F238E27FC236}">
+                <a16:creationId xmlns:a16="http://schemas.microsoft.com/office/drawing/2014/main" id="{A5D0654D-BAA9-4383-8C36-F9F56988D298}"/>
+              </a:ext>
+            </a:extLst>
+          </p:cNvPr>
+          <p:cNvSpPr>
+            <a:spLocks noGrp="1"/>
+          </p:cNvSpPr>
+          <p:nvPr>
+            <p:ph type="title"/>
+          </p:nvPr>
+        </p:nvSpPr>
+        <p:spPr/>
+        <p:txBody>
+          <a:bodyPr/>
+          <a:lstStyle/>
+          <a:p>
+            <a:r>
+              <a:rPr lang="en-ZA" noProof="0" dirty="0"/>
+              <a:t>Composite 1</a:t>
+            </a:r>
+          </a:p>
+        </p:txBody>
+      </p:sp>
+      <p:sp>
+        <p:nvSpPr>
+          <p:cNvPr id="3" name="Content Placeholder 2">
+            <a:extLst>
+              <a:ext uri="{FF2B5EF4-FFF2-40B4-BE49-F238E27FC236}">
+                <a16:creationId xmlns:a16="http://schemas.microsoft.com/office/drawing/2014/main" id="{4944273A-1F30-01D9-9A95-1509553BF907}"/>
+              </a:ext>
+            </a:extLst>
+          </p:cNvPr>
+          <p:cNvSpPr>
+            <a:spLocks noGrp="1"/>
+          </p:cNvSpPr>
+          <p:nvPr>
+            <p:ph sz="quarter" idx="10"/>
+          </p:nvPr>
+        </p:nvSpPr>
+        <p:spPr/>
+        <p:txBody>
+          <a:bodyPr>
+            <a:normAutofit lnSpcReduction="10000"/>
+          </a:bodyPr>
+          <a:lstStyle/>
+          <a:p>
+            <a:pPr lvl="0"/>
+            <a:r>
+              <a:rPr lang="en-ZA" b="1" noProof="0" dirty="0"/>
+              <a:t>Role:</a:t>
+            </a:r>
+          </a:p>
+          <a:p>
+            <a:pPr lvl="0"/>
+            <a:r>
+              <a:rPr lang="en-ZA" noProof="0" dirty="0"/>
+              <a:t>Provide a recursive tree-like structure to store Workflows and Work Items to be worked upon.</a:t>
+            </a:r>
+          </a:p>
+          <a:p>
+            <a:pPr lvl="0"/>
+            <a:r>
+              <a:rPr lang="en-ZA" b="1" noProof="0" dirty="0"/>
+              <a:t>Reason: </a:t>
+            </a:r>
+          </a:p>
+          <a:p>
+            <a:pPr lvl="0"/>
+            <a:r>
+              <a:rPr lang="en-ZA" noProof="0" dirty="0"/>
+              <a:t>A workflow can consist of multiple smaller workflows, both containing work items.</a:t>
+            </a:r>
+          </a:p>
+          <a:p>
+            <a:pPr lvl="0"/>
+            <a:r>
+              <a:rPr lang="en-ZA" b="1" noProof="0" dirty="0"/>
+              <a:t>Relationships: </a:t>
+            </a:r>
+          </a:p>
+          <a:p>
+            <a:pPr lvl="0"/>
+            <a:r>
+              <a:rPr lang="en-ZA" noProof="0" dirty="0"/>
+              <a:t>Works alongside Façade and Visitor to change states of its Booleans, Memento to store snapshots of its states, Participant Composite to do work on work items, Observer to notify other patterns upon change, Decorator to provide addition functionality, and Iterator to traverse the tree.</a:t>
+            </a:r>
+          </a:p>
+          <a:p>
+            <a:endParaRPr lang="en-ZA" noProof="0" dirty="0"/>
+          </a:p>
+        </p:txBody>
+      </p:sp>
+      <p:pic>
+        <p:nvPicPr>
+          <p:cNvPr id="12" name="Picture 11">
+            <a:extLst>
+              <a:ext uri="{FF2B5EF4-FFF2-40B4-BE49-F238E27FC236}">
+                <a16:creationId xmlns:a16="http://schemas.microsoft.com/office/drawing/2014/main" id="{4A25C298-39C8-E9E4-DC72-3F9A1D825F4E}"/>
+              </a:ext>
+            </a:extLst>
+          </p:cNvPr>
+          <p:cNvPicPr>
+            <a:picLocks noChangeAspect="1"/>
+          </p:cNvPicPr>
+          <p:nvPr/>
+        </p:nvPicPr>
+        <p:blipFill>
+          <a:blip r:embed="rId4"/>
+          <a:stretch>
+            <a:fillRect/>
+          </a:stretch>
+        </p:blipFill>
+        <p:spPr>
+          <a:xfrm>
+            <a:off x="492157" y="2922656"/>
+            <a:ext cx="2819860" cy="1701829"/>
+          </a:xfrm>
+          <a:prstGeom prst="rect">
+            <a:avLst/>
+          </a:prstGeom>
+        </p:spPr>
+      </p:pic>
+      <p:pic>
+        <p:nvPicPr>
+          <p:cNvPr id="10" name="Picture 9">
+            <a:extLst>
+              <a:ext uri="{FF2B5EF4-FFF2-40B4-BE49-F238E27FC236}">
+                <a16:creationId xmlns:a16="http://schemas.microsoft.com/office/drawing/2014/main" id="{60DC340D-60AF-E499-3D2E-C6A51D1E5929}"/>
+              </a:ext>
+            </a:extLst>
+          </p:cNvPr>
+          <p:cNvPicPr>
+            <a:picLocks noChangeAspect="1"/>
+          </p:cNvPicPr>
+          <p:nvPr/>
+        </p:nvPicPr>
+        <p:blipFill>
+          <a:blip r:embed="rId5"/>
+          <a:stretch>
+            <a:fillRect/>
+          </a:stretch>
+        </p:blipFill>
+        <p:spPr>
+          <a:xfrm>
+            <a:off x="2737671" y="704516"/>
+            <a:ext cx="2752974" cy="2333575"/>
           </a:xfrm>
           <a:prstGeom prst="rect">
             <a:avLst/>
@@ -13748,7 +13878,7 @@
     </p:spTree>
     <p:extLst>
       <p:ext uri="{BB962C8B-B14F-4D97-AF65-F5344CB8AC3E}">
-        <p14:creationId xmlns:p14="http://schemas.microsoft.com/office/powerpoint/2010/main" val="1447967475"/>
+        <p14:creationId xmlns:p14="http://schemas.microsoft.com/office/powerpoint/2010/main" val="2478020933"/>
       </p:ext>
     </p:extLst>
   </p:cSld>
@@ -14606,12 +14736,23 @@
 </file>
 
 <file path=customXml/item1.xml><?xml version="1.0" encoding="utf-8"?>
-<?mso-contentType ?>
-<FormTemplates xmlns="http://schemas.microsoft.com/sharepoint/v3/contenttype/forms">
-  <Display>DocumentLibraryForm</Display>
-  <Edit>DocumentLibraryForm</Edit>
-  <New>DocumentLibraryForm</New>
-</FormTemplates>
+<p:properties xmlns:p="http://schemas.microsoft.com/office/2006/metadata/properties" xmlns:xsi="http://www.w3.org/2001/XMLSchema-instance" xmlns:pc="http://schemas.microsoft.com/office/infopath/2007/PartnerControls">
+  <documentManagement>
+    <_ip_UnifiedCompliancePolicyUIAction xmlns="http://schemas.microsoft.com/sharepoint/v3" xsi:nil="true"/>
+    <Image xmlns="71af3243-3dd4-4a8d-8c0d-dd76da1f02a5">
+      <Url xsi:nil="true"/>
+      <Description xsi:nil="true"/>
+    </Image>
+    <Status xmlns="71af3243-3dd4-4a8d-8c0d-dd76da1f02a5">Not started</Status>
+    <Background xmlns="71af3243-3dd4-4a8d-8c0d-dd76da1f02a5">false</Background>
+    <_ip_UnifiedCompliancePolicyProperties xmlns="http://schemas.microsoft.com/sharepoint/v3" xsi:nil="true"/>
+    <ImageTagsTaxHTField xmlns="71af3243-3dd4-4a8d-8c0d-dd76da1f02a5">
+      <Terms xmlns="http://schemas.microsoft.com/office/infopath/2007/PartnerControls"/>
+    </ImageTagsTaxHTField>
+    <TaxCatchAll xmlns="230e9df3-be65-4c73-a93b-d1236ebd677e" xsi:nil="true"/>
+    <MediaServiceKeyPoints xmlns="71af3243-3dd4-4a8d-8c0d-dd76da1f02a5" xsi:nil="true"/>
+  </documentManagement>
+</p:properties>
 </file>
 
 <file path=customXml/item2.xml><?xml version="1.0" encoding="utf-8"?>
@@ -14927,29 +15068,22 @@
 </file>
 
 <file path=customXml/item3.xml><?xml version="1.0" encoding="utf-8"?>
-<p:properties xmlns:p="http://schemas.microsoft.com/office/2006/metadata/properties" xmlns:xsi="http://www.w3.org/2001/XMLSchema-instance" xmlns:pc="http://schemas.microsoft.com/office/infopath/2007/PartnerControls">
-  <documentManagement>
-    <_ip_UnifiedCompliancePolicyUIAction xmlns="http://schemas.microsoft.com/sharepoint/v3" xsi:nil="true"/>
-    <Image xmlns="71af3243-3dd4-4a8d-8c0d-dd76da1f02a5">
-      <Url xsi:nil="true"/>
-      <Description xsi:nil="true"/>
-    </Image>
-    <Status xmlns="71af3243-3dd4-4a8d-8c0d-dd76da1f02a5">Not started</Status>
-    <Background xmlns="71af3243-3dd4-4a8d-8c0d-dd76da1f02a5">false</Background>
-    <_ip_UnifiedCompliancePolicyProperties xmlns="http://schemas.microsoft.com/sharepoint/v3" xsi:nil="true"/>
-    <ImageTagsTaxHTField xmlns="71af3243-3dd4-4a8d-8c0d-dd76da1f02a5">
-      <Terms xmlns="http://schemas.microsoft.com/office/infopath/2007/PartnerControls"/>
-    </ImageTagsTaxHTField>
-    <TaxCatchAll xmlns="230e9df3-be65-4c73-a93b-d1236ebd677e" xsi:nil="true"/>
-    <MediaServiceKeyPoints xmlns="71af3243-3dd4-4a8d-8c0d-dd76da1f02a5" xsi:nil="true"/>
-  </documentManagement>
-</p:properties>
+<?mso-contentType ?>
+<FormTemplates xmlns="http://schemas.microsoft.com/sharepoint/v3/contenttype/forms">
+  <Display>DocumentLibraryForm</Display>
+  <Edit>DocumentLibraryForm</Edit>
+  <New>DocumentLibraryForm</New>
+</FormTemplates>
 </file>
 
 <file path=customXml/itemProps1.xml><?xml version="1.0" encoding="utf-8"?>
-<ds:datastoreItem xmlns:ds="http://schemas.openxmlformats.org/officeDocument/2006/customXml" ds:itemID="{F29F0C84-2C14-4FB8-88C2-9577181F2CC2}">
+<ds:datastoreItem xmlns:ds="http://schemas.openxmlformats.org/officeDocument/2006/customXml" ds:itemID="{E4ACCF44-01D5-4C40-9EAC-D3C3683409FE}">
   <ds:schemaRefs>
-    <ds:schemaRef ds:uri="http://schemas.microsoft.com/sharepoint/v3/contenttype/forms"/>
+    <ds:schemaRef ds:uri="http://schemas.microsoft.com/office/2006/metadata/properties"/>
+    <ds:schemaRef ds:uri="http://schemas.microsoft.com/office/infopath/2007/PartnerControls"/>
+    <ds:schemaRef ds:uri="http://schemas.microsoft.com/sharepoint/v3"/>
+    <ds:schemaRef ds:uri="71af3243-3dd4-4a8d-8c0d-dd76da1f02a5"/>
+    <ds:schemaRef ds:uri="230e9df3-be65-4c73-a93b-d1236ebd677e"/>
   </ds:schemaRefs>
 </ds:datastoreItem>
 </file>
@@ -14976,13 +15110,9 @@
 </file>
 
 <file path=customXml/itemProps3.xml><?xml version="1.0" encoding="utf-8"?>
-<ds:datastoreItem xmlns:ds="http://schemas.openxmlformats.org/officeDocument/2006/customXml" ds:itemID="{E4ACCF44-01D5-4C40-9EAC-D3C3683409FE}">
+<ds:datastoreItem xmlns:ds="http://schemas.openxmlformats.org/officeDocument/2006/customXml" ds:itemID="{F29F0C84-2C14-4FB8-88C2-9577181F2CC2}">
   <ds:schemaRefs>
-    <ds:schemaRef ds:uri="http://schemas.microsoft.com/office/2006/metadata/properties"/>
-    <ds:schemaRef ds:uri="http://schemas.microsoft.com/office/infopath/2007/PartnerControls"/>
-    <ds:schemaRef ds:uri="http://schemas.microsoft.com/sharepoint/v3"/>
-    <ds:schemaRef ds:uri="71af3243-3dd4-4a8d-8c0d-dd76da1f02a5"/>
-    <ds:schemaRef ds:uri="230e9df3-be65-4c73-a93b-d1236ebd677e"/>
+    <ds:schemaRef ds:uri="http://schemas.microsoft.com/sharepoint/v3/contenttype/forms"/>
   </ds:schemaRefs>
 </ds:datastoreItem>
 </file>

</xml_diff>

<commit_message>
changes to presentation and state diagram
</commit_message>
<xml_diff>
--- a/Presentation/TIVIDY-Presentation.pptx
+++ b/Presentation/TIVIDY-Presentation.pptx
@@ -5,10 +5,10 @@
     <p:sldMasterId id="2147483648" r:id="rId4"/>
   </p:sldMasterIdLst>
   <p:notesMasterIdLst>
-    <p:notesMasterId r:id="rId36"/>
+    <p:notesMasterId r:id="rId38"/>
   </p:notesMasterIdLst>
   <p:handoutMasterIdLst>
-    <p:handoutMasterId r:id="rId37"/>
+    <p:handoutMasterId r:id="rId39"/>
   </p:handoutMasterIdLst>
   <p:sldIdLst>
     <p:sldId id="340" r:id="rId5"/>
@@ -40,8 +40,10 @@
     <p:sldId id="387" r:id="rId31"/>
     <p:sldId id="384" r:id="rId32"/>
     <p:sldId id="385" r:id="rId33"/>
-    <p:sldId id="386" r:id="rId34"/>
-    <p:sldId id="355" r:id="rId35"/>
+    <p:sldId id="392" r:id="rId34"/>
+    <p:sldId id="393" r:id="rId35"/>
+    <p:sldId id="386" r:id="rId36"/>
+    <p:sldId id="355" r:id="rId37"/>
   </p:sldIdLst>
   <p:sldSz cx="12192000" cy="6858000"/>
   <p:notesSz cx="6858000" cy="9144000"/>
@@ -1543,6 +1545,222 @@
         <p:cNvPr id="1" name="">
           <a:extLst>
             <a:ext uri="{FF2B5EF4-FFF2-40B4-BE49-F238E27FC236}">
+              <a16:creationId xmlns:a16="http://schemas.microsoft.com/office/drawing/2014/main" id="{A5FD6433-A25C-5885-14C4-0CF01C4C5AF8}"/>
+            </a:ext>
+          </a:extLst>
+        </p:cNvPr>
+        <p:cNvGrpSpPr/>
+        <p:nvPr/>
+      </p:nvGrpSpPr>
+      <p:grpSpPr>
+        <a:xfrm>
+          <a:off x="0" y="0"/>
+          <a:ext cx="0" cy="0"/>
+          <a:chOff x="0" y="0"/>
+          <a:chExt cx="0" cy="0"/>
+        </a:xfrm>
+      </p:grpSpPr>
+      <p:sp>
+        <p:nvSpPr>
+          <p:cNvPr id="2" name="Slide Image Placeholder 1">
+            <a:extLst>
+              <a:ext uri="{FF2B5EF4-FFF2-40B4-BE49-F238E27FC236}">
+                <a16:creationId xmlns:a16="http://schemas.microsoft.com/office/drawing/2014/main" id="{31DD4BD8-6A7A-A361-24D4-62FDA8CF0FAC}"/>
+              </a:ext>
+            </a:extLst>
+          </p:cNvPr>
+          <p:cNvSpPr>
+            <a:spLocks noGrp="1" noRot="1" noChangeAspect="1"/>
+          </p:cNvSpPr>
+          <p:nvPr>
+            <p:ph type="sldImg"/>
+          </p:nvPr>
+        </p:nvSpPr>
+        <p:spPr/>
+      </p:sp>
+      <p:sp>
+        <p:nvSpPr>
+          <p:cNvPr id="3" name="Notes Placeholder 2">
+            <a:extLst>
+              <a:ext uri="{FF2B5EF4-FFF2-40B4-BE49-F238E27FC236}">
+                <a16:creationId xmlns:a16="http://schemas.microsoft.com/office/drawing/2014/main" id="{286DF3EA-751F-9568-8AFF-9246ACFB8FFE}"/>
+              </a:ext>
+            </a:extLst>
+          </p:cNvPr>
+          <p:cNvSpPr>
+            <a:spLocks noGrp="1"/>
+          </p:cNvSpPr>
+          <p:nvPr>
+            <p:ph type="body" idx="1"/>
+          </p:nvPr>
+        </p:nvSpPr>
+        <p:spPr/>
+        <p:txBody>
+          <a:bodyPr/>
+          <a:lstStyle/>
+          <a:p>
+            <a:endParaRPr lang="en-US" dirty="0"/>
+          </a:p>
+        </p:txBody>
+      </p:sp>
+      <p:sp>
+        <p:nvSpPr>
+          <p:cNvPr id="4" name="Slide Number Placeholder 3">
+            <a:extLst>
+              <a:ext uri="{FF2B5EF4-FFF2-40B4-BE49-F238E27FC236}">
+                <a16:creationId xmlns:a16="http://schemas.microsoft.com/office/drawing/2014/main" id="{6CEC5F93-C566-5E64-2A8D-549057E856ED}"/>
+              </a:ext>
+            </a:extLst>
+          </p:cNvPr>
+          <p:cNvSpPr>
+            <a:spLocks noGrp="1"/>
+          </p:cNvSpPr>
+          <p:nvPr>
+            <p:ph type="sldNum" sz="quarter" idx="5"/>
+          </p:nvPr>
+        </p:nvSpPr>
+        <p:spPr/>
+        <p:txBody>
+          <a:bodyPr/>
+          <a:lstStyle/>
+          <a:p>
+            <a:fld id="{17732C3C-A191-48C2-A7E8-9C96AF841A7A}" type="slidenum">
+              <a:rPr lang="en-US" smtClean="0"/>
+              <a:t>30</a:t>
+            </a:fld>
+            <a:endParaRPr lang="en-US" dirty="0"/>
+          </a:p>
+        </p:txBody>
+      </p:sp>
+    </p:spTree>
+    <p:extLst>
+      <p:ext uri="{BB962C8B-B14F-4D97-AF65-F5344CB8AC3E}">
+        <p14:creationId xmlns:p14="http://schemas.microsoft.com/office/powerpoint/2010/main" val="2500667757"/>
+      </p:ext>
+    </p:extLst>
+  </p:cSld>
+  <p:clrMapOvr>
+    <a:masterClrMapping/>
+  </p:clrMapOvr>
+</p:notes>
+</file>
+
+<file path=ppt/notesSlides/notesSlide18.xml><?xml version="1.0" encoding="utf-8"?>
+<p:notes xmlns:a="http://schemas.openxmlformats.org/drawingml/2006/main" xmlns:r="http://schemas.openxmlformats.org/officeDocument/2006/relationships" xmlns:p="http://schemas.openxmlformats.org/presentationml/2006/main">
+  <p:cSld>
+    <p:spTree>
+      <p:nvGrpSpPr>
+        <p:cNvPr id="1" name="">
+          <a:extLst>
+            <a:ext uri="{FF2B5EF4-FFF2-40B4-BE49-F238E27FC236}">
+              <a16:creationId xmlns:a16="http://schemas.microsoft.com/office/drawing/2014/main" id="{06CAD221-620C-9313-6A99-3D5A19667172}"/>
+            </a:ext>
+          </a:extLst>
+        </p:cNvPr>
+        <p:cNvGrpSpPr/>
+        <p:nvPr/>
+      </p:nvGrpSpPr>
+      <p:grpSpPr>
+        <a:xfrm>
+          <a:off x="0" y="0"/>
+          <a:ext cx="0" cy="0"/>
+          <a:chOff x="0" y="0"/>
+          <a:chExt cx="0" cy="0"/>
+        </a:xfrm>
+      </p:grpSpPr>
+      <p:sp>
+        <p:nvSpPr>
+          <p:cNvPr id="2" name="Slide Image Placeholder 1">
+            <a:extLst>
+              <a:ext uri="{FF2B5EF4-FFF2-40B4-BE49-F238E27FC236}">
+                <a16:creationId xmlns:a16="http://schemas.microsoft.com/office/drawing/2014/main" id="{4F2F0059-2121-1EE6-E134-A1EC3B580664}"/>
+              </a:ext>
+            </a:extLst>
+          </p:cNvPr>
+          <p:cNvSpPr>
+            <a:spLocks noGrp="1" noRot="1" noChangeAspect="1"/>
+          </p:cNvSpPr>
+          <p:nvPr>
+            <p:ph type="sldImg"/>
+          </p:nvPr>
+        </p:nvSpPr>
+        <p:spPr/>
+      </p:sp>
+      <p:sp>
+        <p:nvSpPr>
+          <p:cNvPr id="3" name="Notes Placeholder 2">
+            <a:extLst>
+              <a:ext uri="{FF2B5EF4-FFF2-40B4-BE49-F238E27FC236}">
+                <a16:creationId xmlns:a16="http://schemas.microsoft.com/office/drawing/2014/main" id="{7228240A-CBFA-2622-B4C4-13A31D14C159}"/>
+              </a:ext>
+            </a:extLst>
+          </p:cNvPr>
+          <p:cNvSpPr>
+            <a:spLocks noGrp="1"/>
+          </p:cNvSpPr>
+          <p:nvPr>
+            <p:ph type="body" idx="1"/>
+          </p:nvPr>
+        </p:nvSpPr>
+        <p:spPr/>
+        <p:txBody>
+          <a:bodyPr/>
+          <a:lstStyle/>
+          <a:p>
+            <a:endParaRPr lang="en-US" dirty="0"/>
+          </a:p>
+        </p:txBody>
+      </p:sp>
+      <p:sp>
+        <p:nvSpPr>
+          <p:cNvPr id="4" name="Slide Number Placeholder 3">
+            <a:extLst>
+              <a:ext uri="{FF2B5EF4-FFF2-40B4-BE49-F238E27FC236}">
+                <a16:creationId xmlns:a16="http://schemas.microsoft.com/office/drawing/2014/main" id="{4619B180-CE89-B743-702C-B719CB3DEFC9}"/>
+              </a:ext>
+            </a:extLst>
+          </p:cNvPr>
+          <p:cNvSpPr>
+            <a:spLocks noGrp="1"/>
+          </p:cNvSpPr>
+          <p:nvPr>
+            <p:ph type="sldNum" sz="quarter" idx="5"/>
+          </p:nvPr>
+        </p:nvSpPr>
+        <p:spPr/>
+        <p:txBody>
+          <a:bodyPr/>
+          <a:lstStyle/>
+          <a:p>
+            <a:fld id="{17732C3C-A191-48C2-A7E8-9C96AF841A7A}" type="slidenum">
+              <a:rPr lang="en-US" smtClean="0"/>
+              <a:t>31</a:t>
+            </a:fld>
+            <a:endParaRPr lang="en-US" dirty="0"/>
+          </a:p>
+        </p:txBody>
+      </p:sp>
+    </p:spTree>
+    <p:extLst>
+      <p:ext uri="{BB962C8B-B14F-4D97-AF65-F5344CB8AC3E}">
+        <p14:creationId xmlns:p14="http://schemas.microsoft.com/office/powerpoint/2010/main" val="2135439659"/>
+      </p:ext>
+    </p:extLst>
+  </p:cSld>
+  <p:clrMapOvr>
+    <a:masterClrMapping/>
+  </p:clrMapOvr>
+</p:notes>
+</file>
+
+<file path=ppt/notesSlides/notesSlide19.xml><?xml version="1.0" encoding="utf-8"?>
+<p:notes xmlns:a="http://schemas.openxmlformats.org/drawingml/2006/main" xmlns:r="http://schemas.openxmlformats.org/officeDocument/2006/relationships" xmlns:p="http://schemas.openxmlformats.org/presentationml/2006/main">
+  <p:cSld>
+    <p:spTree>
+      <p:nvGrpSpPr>
+        <p:cNvPr id="1" name="">
+          <a:extLst>
+            <a:ext uri="{FF2B5EF4-FFF2-40B4-BE49-F238E27FC236}">
               <a16:creationId xmlns:a16="http://schemas.microsoft.com/office/drawing/2014/main" id="{3C78D306-437B-83DF-B52D-F6D6174814BC}"/>
             </a:ext>
           </a:extLst>
@@ -1624,7 +1842,7 @@
           <a:p>
             <a:fld id="{17732C3C-A191-48C2-A7E8-9C96AF841A7A}" type="slidenum">
               <a:rPr lang="en-US" smtClean="0"/>
-              <a:t>30</a:t>
+              <a:t>32</a:t>
             </a:fld>
             <a:endParaRPr lang="en-US" dirty="0"/>
           </a:p>
@@ -1634,90 +1852,6 @@
     <p:extLst>
       <p:ext uri="{BB962C8B-B14F-4D97-AF65-F5344CB8AC3E}">
         <p14:creationId xmlns:p14="http://schemas.microsoft.com/office/powerpoint/2010/main" val="3037106054"/>
-      </p:ext>
-    </p:extLst>
-  </p:cSld>
-  <p:clrMapOvr>
-    <a:masterClrMapping/>
-  </p:clrMapOvr>
-</p:notes>
-</file>
-
-<file path=ppt/notesSlides/notesSlide18.xml><?xml version="1.0" encoding="utf-8"?>
-<p:notes xmlns:a="http://schemas.openxmlformats.org/drawingml/2006/main" xmlns:r="http://schemas.openxmlformats.org/officeDocument/2006/relationships" xmlns:p="http://schemas.openxmlformats.org/presentationml/2006/main">
-  <p:cSld>
-    <p:spTree>
-      <p:nvGrpSpPr>
-        <p:cNvPr id="1" name=""/>
-        <p:cNvGrpSpPr/>
-        <p:nvPr/>
-      </p:nvGrpSpPr>
-      <p:grpSpPr>
-        <a:xfrm>
-          <a:off x="0" y="0"/>
-          <a:ext cx="0" cy="0"/>
-          <a:chOff x="0" y="0"/>
-          <a:chExt cx="0" cy="0"/>
-        </a:xfrm>
-      </p:grpSpPr>
-      <p:sp>
-        <p:nvSpPr>
-          <p:cNvPr id="2" name="Slide Image Placeholder 1"/>
-          <p:cNvSpPr>
-            <a:spLocks noGrp="1" noRot="1" noChangeAspect="1"/>
-          </p:cNvSpPr>
-          <p:nvPr>
-            <p:ph type="sldImg"/>
-          </p:nvPr>
-        </p:nvSpPr>
-        <p:spPr/>
-      </p:sp>
-      <p:sp>
-        <p:nvSpPr>
-          <p:cNvPr id="3" name="Notes Placeholder 2"/>
-          <p:cNvSpPr>
-            <a:spLocks noGrp="1"/>
-          </p:cNvSpPr>
-          <p:nvPr>
-            <p:ph type="body" idx="1"/>
-          </p:nvPr>
-        </p:nvSpPr>
-        <p:spPr/>
-        <p:txBody>
-          <a:bodyPr/>
-          <a:lstStyle/>
-          <a:p>
-            <a:endParaRPr lang="en-US" dirty="0"/>
-          </a:p>
-        </p:txBody>
-      </p:sp>
-      <p:sp>
-        <p:nvSpPr>
-          <p:cNvPr id="4" name="Slide Number Placeholder 3"/>
-          <p:cNvSpPr>
-            <a:spLocks noGrp="1"/>
-          </p:cNvSpPr>
-          <p:nvPr>
-            <p:ph type="sldNum" sz="quarter" idx="5"/>
-          </p:nvPr>
-        </p:nvSpPr>
-        <p:spPr/>
-        <p:txBody>
-          <a:bodyPr/>
-          <a:lstStyle/>
-          <a:p>
-            <a:fld id="{17732C3C-A191-48C2-A7E8-9C96AF841A7A}" type="slidenum">
-              <a:rPr lang="en-US" smtClean="0"/>
-              <a:t>31</a:t>
-            </a:fld>
-            <a:endParaRPr lang="en-US" dirty="0"/>
-          </a:p>
-        </p:txBody>
-      </p:sp>
-    </p:spTree>
-    <p:extLst>
-      <p:ext uri="{BB962C8B-B14F-4D97-AF65-F5344CB8AC3E}">
-        <p14:creationId xmlns:p14="http://schemas.microsoft.com/office/powerpoint/2010/main" val="3823118588"/>
       </p:ext>
     </p:extLst>
   </p:cSld>
@@ -1802,6 +1936,90 @@
     <p:extLst>
       <p:ext uri="{BB962C8B-B14F-4D97-AF65-F5344CB8AC3E}">
         <p14:creationId xmlns:p14="http://schemas.microsoft.com/office/powerpoint/2010/main" val="4016480218"/>
+      </p:ext>
+    </p:extLst>
+  </p:cSld>
+  <p:clrMapOvr>
+    <a:masterClrMapping/>
+  </p:clrMapOvr>
+</p:notes>
+</file>
+
+<file path=ppt/notesSlides/notesSlide20.xml><?xml version="1.0" encoding="utf-8"?>
+<p:notes xmlns:a="http://schemas.openxmlformats.org/drawingml/2006/main" xmlns:r="http://schemas.openxmlformats.org/officeDocument/2006/relationships" xmlns:p="http://schemas.openxmlformats.org/presentationml/2006/main">
+  <p:cSld>
+    <p:spTree>
+      <p:nvGrpSpPr>
+        <p:cNvPr id="1" name=""/>
+        <p:cNvGrpSpPr/>
+        <p:nvPr/>
+      </p:nvGrpSpPr>
+      <p:grpSpPr>
+        <a:xfrm>
+          <a:off x="0" y="0"/>
+          <a:ext cx="0" cy="0"/>
+          <a:chOff x="0" y="0"/>
+          <a:chExt cx="0" cy="0"/>
+        </a:xfrm>
+      </p:grpSpPr>
+      <p:sp>
+        <p:nvSpPr>
+          <p:cNvPr id="2" name="Slide Image Placeholder 1"/>
+          <p:cNvSpPr>
+            <a:spLocks noGrp="1" noRot="1" noChangeAspect="1"/>
+          </p:cNvSpPr>
+          <p:nvPr>
+            <p:ph type="sldImg"/>
+          </p:nvPr>
+        </p:nvSpPr>
+        <p:spPr/>
+      </p:sp>
+      <p:sp>
+        <p:nvSpPr>
+          <p:cNvPr id="3" name="Notes Placeholder 2"/>
+          <p:cNvSpPr>
+            <a:spLocks noGrp="1"/>
+          </p:cNvSpPr>
+          <p:nvPr>
+            <p:ph type="body" idx="1"/>
+          </p:nvPr>
+        </p:nvSpPr>
+        <p:spPr/>
+        <p:txBody>
+          <a:bodyPr/>
+          <a:lstStyle/>
+          <a:p>
+            <a:endParaRPr lang="en-US" dirty="0"/>
+          </a:p>
+        </p:txBody>
+      </p:sp>
+      <p:sp>
+        <p:nvSpPr>
+          <p:cNvPr id="4" name="Slide Number Placeholder 3"/>
+          <p:cNvSpPr>
+            <a:spLocks noGrp="1"/>
+          </p:cNvSpPr>
+          <p:nvPr>
+            <p:ph type="sldNum" sz="quarter" idx="5"/>
+          </p:nvPr>
+        </p:nvSpPr>
+        <p:spPr/>
+        <p:txBody>
+          <a:bodyPr/>
+          <a:lstStyle/>
+          <a:p>
+            <a:fld id="{17732C3C-A191-48C2-A7E8-9C96AF841A7A}" type="slidenum">
+              <a:rPr lang="en-US" smtClean="0"/>
+              <a:t>33</a:t>
+            </a:fld>
+            <a:endParaRPr lang="en-US" dirty="0"/>
+          </a:p>
+        </p:txBody>
+      </p:sp>
+    </p:spTree>
+    <p:extLst>
+      <p:ext uri="{BB962C8B-B14F-4D97-AF65-F5344CB8AC3E}">
+        <p14:creationId xmlns:p14="http://schemas.microsoft.com/office/powerpoint/2010/main" val="3823118588"/>
       </p:ext>
     </p:extLst>
   </p:cSld>
@@ -12496,6 +12714,300 @@
         <p:cNvPr id="1" name="">
           <a:extLst>
             <a:ext uri="{FF2B5EF4-FFF2-40B4-BE49-F238E27FC236}">
+              <a16:creationId xmlns:a16="http://schemas.microsoft.com/office/drawing/2014/main" id="{5DA3E546-2083-ADC3-2F06-3E59921E27B7}"/>
+            </a:ext>
+          </a:extLst>
+        </p:cNvPr>
+        <p:cNvGrpSpPr/>
+        <p:nvPr/>
+      </p:nvGrpSpPr>
+      <p:grpSpPr>
+        <a:xfrm>
+          <a:off x="0" y="0"/>
+          <a:ext cx="0" cy="0"/>
+          <a:chOff x="0" y="0"/>
+          <a:chExt cx="0" cy="0"/>
+        </a:xfrm>
+      </p:grpSpPr>
+      <p:sp>
+        <p:nvSpPr>
+          <p:cNvPr id="6" name="Title 5">
+            <a:extLst>
+              <a:ext uri="{FF2B5EF4-FFF2-40B4-BE49-F238E27FC236}">
+                <a16:creationId xmlns:a16="http://schemas.microsoft.com/office/drawing/2014/main" id="{CCF29F6C-EDFD-F2AE-488C-F8D17193134D}"/>
+              </a:ext>
+            </a:extLst>
+          </p:cNvPr>
+          <p:cNvSpPr>
+            <a:spLocks noGrp="1"/>
+          </p:cNvSpPr>
+          <p:nvPr>
+            <p:ph type="title"/>
+          </p:nvPr>
+        </p:nvSpPr>
+        <p:spPr>
+          <a:xfrm>
+            <a:off x="529935" y="1510145"/>
+            <a:ext cx="3990110" cy="2137930"/>
+          </a:xfrm>
+        </p:spPr>
+        <p:txBody>
+          <a:bodyPr/>
+          <a:lstStyle/>
+          <a:p>
+            <a:r>
+              <a:rPr lang="en-ZA" dirty="0"/>
+              <a:t>Unit Testing</a:t>
+            </a:r>
+            <a:br>
+              <a:rPr lang="en-ZA" dirty="0"/>
+            </a:br>
+            <a:endParaRPr lang="en-ZA" noProof="0" dirty="0"/>
+          </a:p>
+        </p:txBody>
+      </p:sp>
+      <p:sp>
+        <p:nvSpPr>
+          <p:cNvPr id="7" name="Content Placeholder 6">
+            <a:extLst>
+              <a:ext uri="{FF2B5EF4-FFF2-40B4-BE49-F238E27FC236}">
+                <a16:creationId xmlns:a16="http://schemas.microsoft.com/office/drawing/2014/main" id="{2F0A0D30-EDE7-CA2C-B816-7461DB364A1E}"/>
+              </a:ext>
+            </a:extLst>
+          </p:cNvPr>
+          <p:cNvSpPr>
+            <a:spLocks noGrp="1"/>
+          </p:cNvSpPr>
+          <p:nvPr>
+            <p:ph sz="quarter" idx="11"/>
+          </p:nvPr>
+        </p:nvSpPr>
+        <p:spPr>
+          <a:xfrm>
+            <a:off x="638679" y="3022130"/>
+            <a:ext cx="3772622" cy="2940519"/>
+          </a:xfrm>
+        </p:spPr>
+        <p:txBody>
+          <a:bodyPr>
+            <a:normAutofit/>
+          </a:bodyPr>
+          <a:lstStyle/>
+          <a:p>
+            <a:pPr marL="0" lvl="0" indent="0" algn="ctr">
+              <a:buNone/>
+            </a:pPr>
+            <a:r>
+              <a:rPr lang="en-ZA" noProof="0" dirty="0"/>
+              <a:t>Our team conducted unit testing on our classes that we built through blood sweat and tears.</a:t>
+            </a:r>
+          </a:p>
+          <a:p>
+            <a:pPr marL="0" lvl="0" indent="0" algn="ctr">
+              <a:buNone/>
+            </a:pPr>
+            <a:endParaRPr lang="en-ZA" noProof="0" dirty="0"/>
+          </a:p>
+        </p:txBody>
+      </p:sp>
+      <p:pic>
+        <p:nvPicPr>
+          <p:cNvPr id="8" name="Picture 7">
+            <a:extLst>
+              <a:ext uri="{FF2B5EF4-FFF2-40B4-BE49-F238E27FC236}">
+                <a16:creationId xmlns:a16="http://schemas.microsoft.com/office/drawing/2014/main" id="{9453DDE6-DFB4-81C8-1C52-C315A43D9A07}"/>
+              </a:ext>
+            </a:extLst>
+          </p:cNvPr>
+          <p:cNvPicPr>
+            <a:picLocks noChangeAspect="1"/>
+          </p:cNvPicPr>
+          <p:nvPr/>
+        </p:nvPicPr>
+        <p:blipFill>
+          <a:blip r:embed="rId3"/>
+          <a:stretch>
+            <a:fillRect/>
+          </a:stretch>
+        </p:blipFill>
+        <p:spPr>
+          <a:xfrm>
+            <a:off x="5705474" y="949627"/>
+            <a:ext cx="5038725" cy="4958746"/>
+          </a:xfrm>
+          <a:prstGeom prst="rect">
+            <a:avLst/>
+          </a:prstGeom>
+        </p:spPr>
+      </p:pic>
+    </p:spTree>
+    <p:extLst>
+      <p:ext uri="{BB962C8B-B14F-4D97-AF65-F5344CB8AC3E}">
+        <p14:creationId xmlns:p14="http://schemas.microsoft.com/office/powerpoint/2010/main" val="556010014"/>
+      </p:ext>
+    </p:extLst>
+  </p:cSld>
+  <p:clrMapOvr>
+    <a:masterClrMapping/>
+  </p:clrMapOvr>
+</p:sld>
+</file>
+
+<file path=ppt/slides/slide31.xml><?xml version="1.0" encoding="utf-8"?>
+<p:sld xmlns:a="http://schemas.openxmlformats.org/drawingml/2006/main" xmlns:r="http://schemas.openxmlformats.org/officeDocument/2006/relationships" xmlns:p="http://schemas.openxmlformats.org/presentationml/2006/main">
+  <p:cSld>
+    <p:spTree>
+      <p:nvGrpSpPr>
+        <p:cNvPr id="1" name="">
+          <a:extLst>
+            <a:ext uri="{FF2B5EF4-FFF2-40B4-BE49-F238E27FC236}">
+              <a16:creationId xmlns:a16="http://schemas.microsoft.com/office/drawing/2014/main" id="{B096ADDD-050D-6A2F-52E8-288AE80D20C1}"/>
+            </a:ext>
+          </a:extLst>
+        </p:cNvPr>
+        <p:cNvGrpSpPr/>
+        <p:nvPr/>
+      </p:nvGrpSpPr>
+      <p:grpSpPr>
+        <a:xfrm>
+          <a:off x="0" y="0"/>
+          <a:ext cx="0" cy="0"/>
+          <a:chOff x="0" y="0"/>
+          <a:chExt cx="0" cy="0"/>
+        </a:xfrm>
+      </p:grpSpPr>
+      <p:sp>
+        <p:nvSpPr>
+          <p:cNvPr id="6" name="Title 5">
+            <a:extLst>
+              <a:ext uri="{FF2B5EF4-FFF2-40B4-BE49-F238E27FC236}">
+                <a16:creationId xmlns:a16="http://schemas.microsoft.com/office/drawing/2014/main" id="{67D58F2A-B6D3-0166-DFD2-32C489F2338F}"/>
+              </a:ext>
+            </a:extLst>
+          </p:cNvPr>
+          <p:cNvSpPr>
+            <a:spLocks noGrp="1"/>
+          </p:cNvSpPr>
+          <p:nvPr>
+            <p:ph type="title"/>
+          </p:nvPr>
+        </p:nvSpPr>
+        <p:spPr>
+          <a:xfrm>
+            <a:off x="529935" y="1510145"/>
+            <a:ext cx="3990110" cy="2137930"/>
+          </a:xfrm>
+        </p:spPr>
+        <p:txBody>
+          <a:bodyPr/>
+          <a:lstStyle/>
+          <a:p>
+            <a:r>
+              <a:rPr lang="en-ZA" dirty="0"/>
+              <a:t>Error Example</a:t>
+            </a:r>
+            <a:br>
+              <a:rPr lang="en-ZA" dirty="0"/>
+            </a:br>
+            <a:endParaRPr lang="en-ZA" noProof="0" dirty="0"/>
+          </a:p>
+        </p:txBody>
+      </p:sp>
+      <p:sp>
+        <p:nvSpPr>
+          <p:cNvPr id="7" name="Content Placeholder 6">
+            <a:extLst>
+              <a:ext uri="{FF2B5EF4-FFF2-40B4-BE49-F238E27FC236}">
+                <a16:creationId xmlns:a16="http://schemas.microsoft.com/office/drawing/2014/main" id="{CC391C91-F2AB-8B93-83FC-42CDFF85CB73}"/>
+              </a:ext>
+            </a:extLst>
+          </p:cNvPr>
+          <p:cNvSpPr>
+            <a:spLocks noGrp="1"/>
+          </p:cNvSpPr>
+          <p:nvPr>
+            <p:ph sz="quarter" idx="11"/>
+          </p:nvPr>
+        </p:nvSpPr>
+        <p:spPr>
+          <a:xfrm>
+            <a:off x="638679" y="3022130"/>
+            <a:ext cx="3772622" cy="2940519"/>
+          </a:xfrm>
+        </p:spPr>
+        <p:txBody>
+          <a:bodyPr>
+            <a:normAutofit/>
+          </a:bodyPr>
+          <a:lstStyle/>
+          <a:p>
+            <a:pPr marL="0" lvl="0" indent="0" algn="ctr">
+              <a:buNone/>
+            </a:pPr>
+            <a:r>
+              <a:rPr lang="en-ZA" noProof="0" dirty="0"/>
+              <a:t>While focusing on testing, errors were found.</a:t>
+            </a:r>
+          </a:p>
+          <a:p>
+            <a:pPr marL="0" lvl="0" indent="0" algn="ctr">
+              <a:buNone/>
+            </a:pPr>
+            <a:endParaRPr lang="en-ZA" noProof="0" dirty="0"/>
+          </a:p>
+        </p:txBody>
+      </p:sp>
+      <p:pic>
+        <p:nvPicPr>
+          <p:cNvPr id="4" name="Picture 3">
+            <a:extLst>
+              <a:ext uri="{FF2B5EF4-FFF2-40B4-BE49-F238E27FC236}">
+                <a16:creationId xmlns:a16="http://schemas.microsoft.com/office/drawing/2014/main" id="{8310250C-4DD5-8E75-6EE4-E8855A081CB7}"/>
+              </a:ext>
+            </a:extLst>
+          </p:cNvPr>
+          <p:cNvPicPr>
+            <a:picLocks noChangeAspect="1"/>
+          </p:cNvPicPr>
+          <p:nvPr/>
+        </p:nvPicPr>
+        <p:blipFill>
+          <a:blip r:embed="rId3"/>
+          <a:stretch>
+            <a:fillRect/>
+          </a:stretch>
+        </p:blipFill>
+        <p:spPr>
+          <a:xfrm>
+            <a:off x="4628789" y="1978072"/>
+            <a:ext cx="7172685" cy="3110279"/>
+          </a:xfrm>
+          <a:prstGeom prst="rect">
+            <a:avLst/>
+          </a:prstGeom>
+        </p:spPr>
+      </p:pic>
+    </p:spTree>
+    <p:extLst>
+      <p:ext uri="{BB962C8B-B14F-4D97-AF65-F5344CB8AC3E}">
+        <p14:creationId xmlns:p14="http://schemas.microsoft.com/office/powerpoint/2010/main" val="3524834476"/>
+      </p:ext>
+    </p:extLst>
+  </p:cSld>
+  <p:clrMapOvr>
+    <a:masterClrMapping/>
+  </p:clrMapOvr>
+</p:sld>
+</file>
+
+<file path=ppt/slides/slide32.xml><?xml version="1.0" encoding="utf-8"?>
+<p:sld xmlns:a="http://schemas.openxmlformats.org/drawingml/2006/main" xmlns:r="http://schemas.openxmlformats.org/officeDocument/2006/relationships" xmlns:p="http://schemas.openxmlformats.org/presentationml/2006/main">
+  <p:cSld>
+    <p:spTree>
+      <p:nvGrpSpPr>
+        <p:cNvPr id="1" name="">
+          <a:extLst>
+            <a:ext uri="{FF2B5EF4-FFF2-40B4-BE49-F238E27FC236}">
               <a16:creationId xmlns:a16="http://schemas.microsoft.com/office/drawing/2014/main" id="{E6F50098-5446-564E-3192-677D7030A696}"/>
             </a:ext>
           </a:extLst>
@@ -12642,7 +13154,7 @@
 </p:sld>
 </file>
 
-<file path=ppt/slides/slide31.xml><?xml version="1.0" encoding="utf-8"?>
+<file path=ppt/slides/slide33.xml><?xml version="1.0" encoding="utf-8"?>
 <p:sld xmlns:a="http://schemas.openxmlformats.org/drawingml/2006/main" xmlns:r="http://schemas.openxmlformats.org/officeDocument/2006/relationships" xmlns:p="http://schemas.openxmlformats.org/presentationml/2006/main">
   <p:cSld>
     <p:spTree>
@@ -12729,33 +13241,29 @@
             <a:pPr lvl="0"/>
             <a:r>
               <a:rPr lang="en-ZA" dirty="0"/>
-              <a:t>u</a:t>
-            </a:r>
-            <a:r>
-              <a:rPr lang="en-ZA" noProof="0" dirty="0"/>
-              <a:t>24------</a:t>
-            </a:r>
-          </a:p>
-          <a:p>
+              <a:t>u24583741</a:t>
+            </a:r>
+          </a:p>
+          <a:p>
+            <a:pPr lvl="0"/>
             <a:r>
               <a:rPr lang="en-ZA" dirty="0"/>
-              <a:t>u24------</a:t>
-            </a:r>
-          </a:p>
-          <a:p>
+              <a:t>u24566935</a:t>
+            </a:r>
+          </a:p>
+          <a:p>
+            <a:pPr lvl="0"/>
             <a:r>
               <a:rPr lang="en-ZA" dirty="0"/>
-              <a:t>u25------</a:t>
-            </a:r>
-          </a:p>
-          <a:p>
+              <a:t>u25161360</a:t>
+            </a:r>
+          </a:p>
+          <a:p>
+            <a:pPr lvl="0"/>
             <a:r>
               <a:rPr lang="en-ZA" dirty="0"/>
-              <a:t>u25------</a:t>
-            </a:r>
-          </a:p>
-          <a:p>
-            <a:pPr lvl="0"/>
+              <a:t>u25678592</a:t>
+            </a:r>
             <a:endParaRPr lang="en-ZA" noProof="0" dirty="0"/>
           </a:p>
         </p:txBody>

</xml_diff>

<commit_message>
final changes I hope, mostly updating diagrams.
</commit_message>
<xml_diff>
--- a/Presentation/TIVIDY-Presentation.pptx
+++ b/Presentation/TIVIDY-Presentation.pptx
@@ -253,7 +253,7 @@
           <a:p>
             <a:fld id="{E4E69F83-204D-4778-AAD0-A0F851A3AEEE}" type="datetimeFigureOut">
               <a:rPr lang="en-US" smtClean="0"/>
-              <a:t>11/1/2026</a:t>
+              <a:t>11/2/2026</a:t>
             </a:fld>
             <a:endParaRPr lang="en-US" dirty="0"/>
           </a:p>
@@ -430,7 +430,7 @@
           <a:p>
             <a:fld id="{85AE3C21-C3CB-4B8D-9033-56C1B3CE75FA}" type="datetimeFigureOut">
               <a:rPr lang="en-US" smtClean="0"/>
-              <a:t>11/1/2026</a:t>
+              <a:t>11/2/2026</a:t>
             </a:fld>
             <a:endParaRPr lang="en-US" dirty="0"/>
           </a:p>
@@ -8521,7 +8521,7 @@
           <a:p>
             <a:fld id="{86F7BD38-A805-4B2C-9BDF-D56E94387879}" type="datetime1">
               <a:rPr lang="en-US" smtClean="0"/>
-              <a:t>11/1/2026</a:t>
+              <a:t>11/2/2026</a:t>
             </a:fld>
             <a:endParaRPr lang="en-US" dirty="0"/>
           </a:p>
@@ -9774,10 +9774,10 @@
       </p:sp>
       <p:pic>
         <p:nvPicPr>
-          <p:cNvPr id="5" name="Picture 4">
-            <a:extLst>
-              <a:ext uri="{FF2B5EF4-FFF2-40B4-BE49-F238E27FC236}">
-                <a16:creationId xmlns:a16="http://schemas.microsoft.com/office/drawing/2014/main" id="{21EB1AEA-1E20-5471-CC32-0082950DE596}"/>
+          <p:cNvPr id="8" name="Picture 7">
+            <a:extLst>
+              <a:ext uri="{FF2B5EF4-FFF2-40B4-BE49-F238E27FC236}">
+                <a16:creationId xmlns:a16="http://schemas.microsoft.com/office/drawing/2014/main" id="{1B5EF201-490F-3E7A-702E-146213991C1F}"/>
               </a:ext>
             </a:extLst>
           </p:cNvPr>
@@ -9794,8 +9794,8 @@
         </p:blipFill>
         <p:spPr>
           <a:xfrm>
-            <a:off x="498709" y="704516"/>
-            <a:ext cx="3073997" cy="3198125"/>
+            <a:off x="3707833" y="1886127"/>
+            <a:ext cx="1832716" cy="1387315"/>
           </a:xfrm>
           <a:prstGeom prst="rect">
             <a:avLst/>
@@ -9804,10 +9804,10 @@
       </p:pic>
       <p:pic>
         <p:nvPicPr>
-          <p:cNvPr id="8" name="Picture 7">
-            <a:extLst>
-              <a:ext uri="{FF2B5EF4-FFF2-40B4-BE49-F238E27FC236}">
-                <a16:creationId xmlns:a16="http://schemas.microsoft.com/office/drawing/2014/main" id="{1B5EF201-490F-3E7A-702E-146213991C1F}"/>
+          <p:cNvPr id="6" name="Picture 5">
+            <a:extLst>
+              <a:ext uri="{FF2B5EF4-FFF2-40B4-BE49-F238E27FC236}">
+                <a16:creationId xmlns:a16="http://schemas.microsoft.com/office/drawing/2014/main" id="{FFCB8C7C-9383-BF31-796D-5AAD290804A0}"/>
               </a:ext>
             </a:extLst>
           </p:cNvPr>
@@ -9824,8 +9824,8 @@
         </p:blipFill>
         <p:spPr>
           <a:xfrm>
-            <a:off x="3634014" y="1895652"/>
-            <a:ext cx="1832716" cy="1387315"/>
+            <a:off x="470318" y="704516"/>
+            <a:ext cx="3237515" cy="3014878"/>
           </a:xfrm>
           <a:prstGeom prst="rect">
             <a:avLst/>
@@ -9834,10 +9834,10 @@
       </p:pic>
       <p:pic>
         <p:nvPicPr>
-          <p:cNvPr id="10" name="Picture 9">
-            <a:extLst>
-              <a:ext uri="{FF2B5EF4-FFF2-40B4-BE49-F238E27FC236}">
-                <a16:creationId xmlns:a16="http://schemas.microsoft.com/office/drawing/2014/main" id="{7210501A-32AE-1F4A-1072-BA8B6C992A48}"/>
+          <p:cNvPr id="9" name="Picture 8">
+            <a:extLst>
+              <a:ext uri="{FF2B5EF4-FFF2-40B4-BE49-F238E27FC236}">
+                <a16:creationId xmlns:a16="http://schemas.microsoft.com/office/drawing/2014/main" id="{C320D46A-BCB5-F37D-7ED7-760C0AC8131C}"/>
               </a:ext>
             </a:extLst>
           </p:cNvPr>
@@ -9854,8 +9854,8 @@
         </p:blipFill>
         <p:spPr>
           <a:xfrm>
-            <a:off x="1595644" y="4050607"/>
-            <a:ext cx="3117807" cy="2102877"/>
+            <a:off x="1823821" y="3828445"/>
+            <a:ext cx="3564328" cy="2325039"/>
           </a:xfrm>
           <a:prstGeom prst="rect">
             <a:avLst/>
@@ -10985,10 +10985,10 @@
       </p:pic>
       <p:pic>
         <p:nvPicPr>
-          <p:cNvPr id="12" name="Picture 11">
-            <a:extLst>
-              <a:ext uri="{FF2B5EF4-FFF2-40B4-BE49-F238E27FC236}">
-                <a16:creationId xmlns:a16="http://schemas.microsoft.com/office/drawing/2014/main" id="{2BCCC11C-33A4-56AE-1BF2-63B222766756}"/>
+          <p:cNvPr id="5" name="Picture 4">
+            <a:extLst>
+              <a:ext uri="{FF2B5EF4-FFF2-40B4-BE49-F238E27FC236}">
+                <a16:creationId xmlns:a16="http://schemas.microsoft.com/office/drawing/2014/main" id="{EB24534F-B4D5-9E19-8946-5DAFE3EC6A5B}"/>
               </a:ext>
             </a:extLst>
           </p:cNvPr>
@@ -11005,8 +11005,8 @@
         </p:blipFill>
         <p:spPr>
           <a:xfrm>
-            <a:off x="2281535" y="1667728"/>
-            <a:ext cx="3259369" cy="2133134"/>
+            <a:off x="2342978" y="1610858"/>
+            <a:ext cx="3121997" cy="2274943"/>
           </a:xfrm>
           <a:prstGeom prst="rect">
             <a:avLst/>
@@ -11629,55 +11629,36 @@
           </a:p>
         </p:txBody>
       </p:sp>
-      <p:sp>
-        <p:nvSpPr>
-          <p:cNvPr id="4" name="Rectangle 3">
-            <a:extLst>
-              <a:ext uri="{FF2B5EF4-FFF2-40B4-BE49-F238E27FC236}">
-                <a16:creationId xmlns:a16="http://schemas.microsoft.com/office/drawing/2014/main" id="{BA304CD6-91DE-5BC4-2F9C-64A3835CB3D9}"/>
-              </a:ext>
-            </a:extLst>
-          </p:cNvPr>
-          <p:cNvSpPr/>
+      <p:pic>
+        <p:nvPicPr>
+          <p:cNvPr id="6" name="Picture 5">
+            <a:extLst>
+              <a:ext uri="{FF2B5EF4-FFF2-40B4-BE49-F238E27FC236}">
+                <a16:creationId xmlns:a16="http://schemas.microsoft.com/office/drawing/2014/main" id="{359DEE57-8653-6FE0-D97E-F9310CD3B8EF}"/>
+              </a:ext>
+            </a:extLst>
+          </p:cNvPr>
+          <p:cNvPicPr>
+            <a:picLocks noChangeAspect="1"/>
+          </p:cNvPicPr>
           <p:nvPr/>
-        </p:nvSpPr>
+        </p:nvPicPr>
+        <p:blipFill>
+          <a:blip r:embed="rId3"/>
+          <a:stretch>
+            <a:fillRect/>
+          </a:stretch>
+        </p:blipFill>
         <p:spPr>
           <a:xfrm>
-            <a:off x="4991101" y="1724025"/>
-            <a:ext cx="6457950" cy="4476335"/>
+            <a:off x="4769918" y="2071244"/>
+            <a:ext cx="6871365" cy="3862417"/>
           </a:xfrm>
           <a:prstGeom prst="rect">
             <a:avLst/>
           </a:prstGeom>
         </p:spPr>
-        <p:style>
-          <a:lnRef idx="2">
-            <a:schemeClr val="accent1">
-              <a:shade val="15000"/>
-            </a:schemeClr>
-          </a:lnRef>
-          <a:fillRef idx="1001">
-            <a:schemeClr val="dk2"/>
-          </a:fillRef>
-          <a:effectRef idx="0">
-            <a:schemeClr val="accent1"/>
-          </a:effectRef>
-          <a:fontRef idx="minor">
-            <a:schemeClr val="lt1"/>
-          </a:fontRef>
-        </p:style>
-        <p:txBody>
-          <a:bodyPr rtlCol="0" anchor="ctr"/>
-          <a:lstStyle/>
-          <a:p>
-            <a:pPr algn="ctr"/>
-            <a:r>
-              <a:rPr lang="en-ZA" dirty="0"/>
-              <a:t>Terminal Image</a:t>
-            </a:r>
-          </a:p>
-        </p:txBody>
-      </p:sp>
+      </p:pic>
     </p:spTree>
     <p:extLst>
       <p:ext uri="{BB962C8B-B14F-4D97-AF65-F5344CB8AC3E}">
@@ -11837,75 +11818,72 @@
         </p:nvSpPr>
         <p:spPr>
           <a:xfrm>
-            <a:off x="550717" y="924339"/>
-            <a:ext cx="3990110" cy="5009322"/>
-          </a:xfrm>
-        </p:spPr>
-        <p:txBody>
-          <a:bodyPr/>
+            <a:off x="529935" y="571499"/>
+            <a:ext cx="11118274" cy="1154114"/>
+          </a:xfrm>
+        </p:spPr>
+        <p:txBody>
+          <a:bodyPr vert="horz" lIns="91440" tIns="45720" rIns="91440" bIns="45720" rtlCol="0" anchor="ctr">
+            <a:normAutofit/>
+          </a:bodyPr>
           <a:lstStyle/>
           <a:p>
             <a:r>
-              <a:rPr lang="en-ZA" noProof="0" dirty="0" err="1"/>
-              <a:t>DoxyFile</a:t>
-            </a:r>
-            <a:endParaRPr lang="en-ZA" noProof="0" dirty="0"/>
-          </a:p>
-        </p:txBody>
-      </p:sp>
-      <p:sp>
-        <p:nvSpPr>
-          <p:cNvPr id="4" name="Rectangle 3">
-            <a:extLst>
-              <a:ext uri="{FF2B5EF4-FFF2-40B4-BE49-F238E27FC236}">
-                <a16:creationId xmlns:a16="http://schemas.microsoft.com/office/drawing/2014/main" id="{EFCD5A76-3277-8912-B0A7-06C6ACB5308E}"/>
-              </a:ext>
-            </a:extLst>
-          </p:cNvPr>
-          <p:cNvSpPr/>
+              <a:rPr lang="en-US" b="1" kern="1200" spc="0" baseline="0" noProof="0" dirty="0" err="1">
+                <a:ln>
+                  <a:noFill/>
+                </a:ln>
+                <a:effectLst/>
+                <a:latin typeface="+mj-lt"/>
+                <a:ea typeface="+mj-ea"/>
+                <a:cs typeface="+mj-cs"/>
+              </a:rPr>
+              <a:t>Doxygen</a:t>
+            </a:r>
+            <a:endParaRPr lang="en-US" b="1" kern="1200" spc="0" baseline="0" noProof="0" dirty="0">
+              <a:ln>
+                <a:noFill/>
+              </a:ln>
+              <a:effectLst/>
+              <a:latin typeface="+mj-lt"/>
+              <a:ea typeface="+mj-ea"/>
+              <a:cs typeface="+mj-cs"/>
+            </a:endParaRPr>
+          </a:p>
+        </p:txBody>
+      </p:sp>
+      <p:pic>
+        <p:nvPicPr>
+          <p:cNvPr id="5" name="Picture 4">
+            <a:extLst>
+              <a:ext uri="{FF2B5EF4-FFF2-40B4-BE49-F238E27FC236}">
+                <a16:creationId xmlns:a16="http://schemas.microsoft.com/office/drawing/2014/main" id="{CE8607FE-E4E1-9995-BE3C-5CFDED0C8E82}"/>
+              </a:ext>
+            </a:extLst>
+          </p:cNvPr>
+          <p:cNvPicPr>
+            <a:picLocks noChangeAspect="1"/>
+          </p:cNvPicPr>
           <p:nvPr/>
-        </p:nvSpPr>
+        </p:nvPicPr>
+        <p:blipFill>
+          <a:blip r:embed="rId3"/>
+          <a:stretch>
+            <a:fillRect/>
+          </a:stretch>
+        </p:blipFill>
         <p:spPr>
           <a:xfrm>
-            <a:off x="4933951" y="685801"/>
-            <a:ext cx="6515100" cy="5514560"/>
+            <a:off x="1885950" y="1878189"/>
+            <a:ext cx="8582025" cy="4548473"/>
           </a:xfrm>
           <a:prstGeom prst="rect">
             <a:avLst/>
           </a:prstGeom>
-        </p:spPr>
-        <p:style>
-          <a:lnRef idx="2">
-            <a:schemeClr val="accent1">
-              <a:shade val="15000"/>
-            </a:schemeClr>
-          </a:lnRef>
-          <a:fillRef idx="1001">
-            <a:schemeClr val="dk2"/>
-          </a:fillRef>
-          <a:effectRef idx="0">
-            <a:schemeClr val="accent1"/>
-          </a:effectRef>
-          <a:fontRef idx="minor">
-            <a:schemeClr val="lt1"/>
-          </a:fontRef>
-        </p:style>
-        <p:txBody>
-          <a:bodyPr rtlCol="0" anchor="ctr"/>
-          <a:lstStyle/>
-          <a:p>
-            <a:pPr algn="ctr"/>
-            <a:r>
-              <a:rPr lang="en-ZA" dirty="0" err="1"/>
-              <a:t>Doxygen</a:t>
-            </a:r>
-            <a:r>
-              <a:rPr lang="en-ZA" dirty="0"/>
-              <a:t> file</a:t>
-            </a:r>
-          </a:p>
-        </p:txBody>
-      </p:sp>
+          <a:noFill/>
+          <a:effectLst/>
+        </p:spPr>
+      </p:pic>
     </p:spTree>
     <p:extLst>
       <p:ext uri="{BB962C8B-B14F-4D97-AF65-F5344CB8AC3E}">
@@ -12064,29 +12042,30 @@
         </p:nvSpPr>
         <p:spPr>
           <a:xfrm>
-            <a:off x="529935" y="571499"/>
-            <a:ext cx="11118274" cy="1154114"/>
-          </a:xfrm>
-        </p:spPr>
-        <p:txBody>
-          <a:bodyPr/>
+            <a:off x="529935" y="924339"/>
+            <a:ext cx="2908590" cy="5009322"/>
+          </a:xfrm>
+        </p:spPr>
+        <p:txBody>
+          <a:bodyPr anchor="ctr">
+            <a:normAutofit/>
+          </a:bodyPr>
           <a:lstStyle/>
           <a:p>
             <a:pPr lvl="0"/>
             <a:r>
-              <a:rPr lang="en-ZA" noProof="0" dirty="0" err="1"/>
-              <a:t>DockerFile</a:t>
-            </a:r>
-            <a:endParaRPr lang="en-ZA" noProof="0" dirty="0"/>
+              <a:rPr lang="en-ZA" noProof="0" dirty="0"/>
+              <a:t>Docker</a:t>
+            </a:r>
           </a:p>
         </p:txBody>
       </p:sp>
       <p:pic>
         <p:nvPicPr>
-          <p:cNvPr id="10" name="Picture 9">
-            <a:extLst>
-              <a:ext uri="{FF2B5EF4-FFF2-40B4-BE49-F238E27FC236}">
-                <a16:creationId xmlns:a16="http://schemas.microsoft.com/office/drawing/2014/main" id="{4B75C5A3-6F0B-361E-B0EC-8449CBF3B6A4}"/>
+          <p:cNvPr id="4" name="Picture 3">
+            <a:extLst>
+              <a:ext uri="{FF2B5EF4-FFF2-40B4-BE49-F238E27FC236}">
+                <a16:creationId xmlns:a16="http://schemas.microsoft.com/office/drawing/2014/main" id="{77930C0D-C013-245D-C549-6BEDAF3B2BF7}"/>
               </a:ext>
             </a:extLst>
           </p:cNvPr>
@@ -12103,12 +12082,14 @@
         </p:blipFill>
         <p:spPr>
           <a:xfrm>
-            <a:off x="1104900" y="1872954"/>
-            <a:ext cx="9696450" cy="4569961"/>
+            <a:off x="4021655" y="1261127"/>
+            <a:ext cx="7357115" cy="4524625"/>
           </a:xfrm>
           <a:prstGeom prst="rect">
             <a:avLst/>
           </a:prstGeom>
+          <a:noFill/>
+          <a:effectLst/>
         </p:spPr>
       </p:pic>
     </p:spTree>
@@ -12894,7 +12875,7 @@
         </p:nvSpPr>
         <p:spPr>
           <a:xfrm>
-            <a:off x="529935" y="1510145"/>
+            <a:off x="539460" y="2360035"/>
             <a:ext cx="3990110" cy="2137930"/>
           </a:xfrm>
         </p:spPr>
@@ -12904,7 +12885,7 @@
           <a:p>
             <a:r>
               <a:rPr lang="en-ZA" dirty="0"/>
-              <a:t>Error Example</a:t>
+              <a:t>Diving In</a:t>
             </a:r>
             <a:br>
               <a:rPr lang="en-ZA" dirty="0"/>
@@ -12913,56 +12894,12 @@
           </a:p>
         </p:txBody>
       </p:sp>
-      <p:sp>
-        <p:nvSpPr>
-          <p:cNvPr id="7" name="Content Placeholder 6">
-            <a:extLst>
-              <a:ext uri="{FF2B5EF4-FFF2-40B4-BE49-F238E27FC236}">
-                <a16:creationId xmlns:a16="http://schemas.microsoft.com/office/drawing/2014/main" id="{CC391C91-F2AB-8B93-83FC-42CDFF85CB73}"/>
-              </a:ext>
-            </a:extLst>
-          </p:cNvPr>
-          <p:cNvSpPr>
-            <a:spLocks noGrp="1"/>
-          </p:cNvSpPr>
-          <p:nvPr>
-            <p:ph sz="quarter" idx="11"/>
-          </p:nvPr>
-        </p:nvSpPr>
-        <p:spPr>
-          <a:xfrm>
-            <a:off x="638679" y="3022130"/>
-            <a:ext cx="3772622" cy="2940519"/>
-          </a:xfrm>
-        </p:spPr>
-        <p:txBody>
-          <a:bodyPr>
-            <a:normAutofit/>
-          </a:bodyPr>
-          <a:lstStyle/>
-          <a:p>
-            <a:pPr marL="0" lvl="0" indent="0" algn="ctr">
-              <a:buNone/>
-            </a:pPr>
-            <a:r>
-              <a:rPr lang="en-ZA" noProof="0" dirty="0"/>
-              <a:t>While focusing on testing, errors were found.</a:t>
-            </a:r>
-          </a:p>
-          <a:p>
-            <a:pPr marL="0" lvl="0" indent="0" algn="ctr">
-              <a:buNone/>
-            </a:pPr>
-            <a:endParaRPr lang="en-ZA" noProof="0" dirty="0"/>
-          </a:p>
-        </p:txBody>
-      </p:sp>
       <p:pic>
         <p:nvPicPr>
-          <p:cNvPr id="4" name="Picture 3">
-            <a:extLst>
-              <a:ext uri="{FF2B5EF4-FFF2-40B4-BE49-F238E27FC236}">
-                <a16:creationId xmlns:a16="http://schemas.microsoft.com/office/drawing/2014/main" id="{8310250C-4DD5-8E75-6EE4-E8855A081CB7}"/>
+          <p:cNvPr id="3" name="Picture 2">
+            <a:extLst>
+              <a:ext uri="{FF2B5EF4-FFF2-40B4-BE49-F238E27FC236}">
+                <a16:creationId xmlns:a16="http://schemas.microsoft.com/office/drawing/2014/main" id="{DE468B36-56ED-6541-BE24-8053AA7BF0C4}"/>
               </a:ext>
             </a:extLst>
           </p:cNvPr>
@@ -12979,8 +12916,8 @@
         </p:blipFill>
         <p:spPr>
           <a:xfrm>
-            <a:off x="4628789" y="1978072"/>
-            <a:ext cx="7172685" cy="3110279"/>
+            <a:off x="4817304" y="540318"/>
+            <a:ext cx="6736017" cy="5777364"/>
           </a:xfrm>
           <a:prstGeom prst="rect">
             <a:avLst/>
@@ -14132,10 +14069,10 @@
       </p:sp>
       <p:pic>
         <p:nvPicPr>
-          <p:cNvPr id="5" name="Picture 4">
-            <a:extLst>
-              <a:ext uri="{FF2B5EF4-FFF2-40B4-BE49-F238E27FC236}">
-                <a16:creationId xmlns:a16="http://schemas.microsoft.com/office/drawing/2014/main" id="{321E5F2E-69FC-CB20-CFE0-A3355C5D05BC}"/>
+          <p:cNvPr id="8" name="Picture 7">
+            <a:extLst>
+              <a:ext uri="{FF2B5EF4-FFF2-40B4-BE49-F238E27FC236}">
+                <a16:creationId xmlns:a16="http://schemas.microsoft.com/office/drawing/2014/main" id="{B97B528E-6E8B-877E-6093-4E66E96518BD}"/>
               </a:ext>
             </a:extLst>
           </p:cNvPr>
@@ -14152,8 +14089,8 @@
         </p:blipFill>
         <p:spPr>
           <a:xfrm>
-            <a:off x="1047528" y="840903"/>
-            <a:ext cx="3956176" cy="5176194"/>
+            <a:off x="771133" y="716364"/>
+            <a:ext cx="4458092" cy="5425272"/>
           </a:xfrm>
           <a:prstGeom prst="rect">
             <a:avLst/>
@@ -15244,23 +15181,12 @@
 </file>
 
 <file path=customXml/item1.xml><?xml version="1.0" encoding="utf-8"?>
-<p:properties xmlns:p="http://schemas.microsoft.com/office/2006/metadata/properties" xmlns:xsi="http://www.w3.org/2001/XMLSchema-instance" xmlns:pc="http://schemas.microsoft.com/office/infopath/2007/PartnerControls">
-  <documentManagement>
-    <_ip_UnifiedCompliancePolicyUIAction xmlns="http://schemas.microsoft.com/sharepoint/v3" xsi:nil="true"/>
-    <Image xmlns="71af3243-3dd4-4a8d-8c0d-dd76da1f02a5">
-      <Url xsi:nil="true"/>
-      <Description xsi:nil="true"/>
-    </Image>
-    <Status xmlns="71af3243-3dd4-4a8d-8c0d-dd76da1f02a5">Not started</Status>
-    <Background xmlns="71af3243-3dd4-4a8d-8c0d-dd76da1f02a5">false</Background>
-    <_ip_UnifiedCompliancePolicyProperties xmlns="http://schemas.microsoft.com/sharepoint/v3" xsi:nil="true"/>
-    <ImageTagsTaxHTField xmlns="71af3243-3dd4-4a8d-8c0d-dd76da1f02a5">
-      <Terms xmlns="http://schemas.microsoft.com/office/infopath/2007/PartnerControls"/>
-    </ImageTagsTaxHTField>
-    <TaxCatchAll xmlns="230e9df3-be65-4c73-a93b-d1236ebd677e" xsi:nil="true"/>
-    <MediaServiceKeyPoints xmlns="71af3243-3dd4-4a8d-8c0d-dd76da1f02a5" xsi:nil="true"/>
-  </documentManagement>
-</p:properties>
+<?mso-contentType ?>
+<FormTemplates xmlns="http://schemas.microsoft.com/sharepoint/v3/contenttype/forms">
+  <Display>DocumentLibraryForm</Display>
+  <Edit>DocumentLibraryForm</Edit>
+  <New>DocumentLibraryForm</New>
+</FormTemplates>
 </file>
 
 <file path=customXml/item2.xml><?xml version="1.0" encoding="utf-8"?>
@@ -15576,22 +15502,29 @@
 </file>
 
 <file path=customXml/item3.xml><?xml version="1.0" encoding="utf-8"?>
-<?mso-contentType ?>
-<FormTemplates xmlns="http://schemas.microsoft.com/sharepoint/v3/contenttype/forms">
-  <Display>DocumentLibraryForm</Display>
-  <Edit>DocumentLibraryForm</Edit>
-  <New>DocumentLibraryForm</New>
-</FormTemplates>
+<p:properties xmlns:p="http://schemas.microsoft.com/office/2006/metadata/properties" xmlns:xsi="http://www.w3.org/2001/XMLSchema-instance" xmlns:pc="http://schemas.microsoft.com/office/infopath/2007/PartnerControls">
+  <documentManagement>
+    <_ip_UnifiedCompliancePolicyUIAction xmlns="http://schemas.microsoft.com/sharepoint/v3" xsi:nil="true"/>
+    <Image xmlns="71af3243-3dd4-4a8d-8c0d-dd76da1f02a5">
+      <Url xsi:nil="true"/>
+      <Description xsi:nil="true"/>
+    </Image>
+    <Status xmlns="71af3243-3dd4-4a8d-8c0d-dd76da1f02a5">Not started</Status>
+    <Background xmlns="71af3243-3dd4-4a8d-8c0d-dd76da1f02a5">false</Background>
+    <_ip_UnifiedCompliancePolicyProperties xmlns="http://schemas.microsoft.com/sharepoint/v3" xsi:nil="true"/>
+    <ImageTagsTaxHTField xmlns="71af3243-3dd4-4a8d-8c0d-dd76da1f02a5">
+      <Terms xmlns="http://schemas.microsoft.com/office/infopath/2007/PartnerControls"/>
+    </ImageTagsTaxHTField>
+    <TaxCatchAll xmlns="230e9df3-be65-4c73-a93b-d1236ebd677e" xsi:nil="true"/>
+    <MediaServiceKeyPoints xmlns="71af3243-3dd4-4a8d-8c0d-dd76da1f02a5" xsi:nil="true"/>
+  </documentManagement>
+</p:properties>
 </file>
 
 <file path=customXml/itemProps1.xml><?xml version="1.0" encoding="utf-8"?>
-<ds:datastoreItem xmlns:ds="http://schemas.openxmlformats.org/officeDocument/2006/customXml" ds:itemID="{E4ACCF44-01D5-4C40-9EAC-D3C3683409FE}">
+<ds:datastoreItem xmlns:ds="http://schemas.openxmlformats.org/officeDocument/2006/customXml" ds:itemID="{F29F0C84-2C14-4FB8-88C2-9577181F2CC2}">
   <ds:schemaRefs>
-    <ds:schemaRef ds:uri="http://schemas.microsoft.com/office/2006/metadata/properties"/>
-    <ds:schemaRef ds:uri="http://schemas.microsoft.com/office/infopath/2007/PartnerControls"/>
-    <ds:schemaRef ds:uri="http://schemas.microsoft.com/sharepoint/v3"/>
-    <ds:schemaRef ds:uri="71af3243-3dd4-4a8d-8c0d-dd76da1f02a5"/>
-    <ds:schemaRef ds:uri="230e9df3-be65-4c73-a93b-d1236ebd677e"/>
+    <ds:schemaRef ds:uri="http://schemas.microsoft.com/sharepoint/v3/contenttype/forms"/>
   </ds:schemaRefs>
 </ds:datastoreItem>
 </file>
@@ -15618,9 +15551,13 @@
 </file>
 
 <file path=customXml/itemProps3.xml><?xml version="1.0" encoding="utf-8"?>
-<ds:datastoreItem xmlns:ds="http://schemas.openxmlformats.org/officeDocument/2006/customXml" ds:itemID="{F29F0C84-2C14-4FB8-88C2-9577181F2CC2}">
+<ds:datastoreItem xmlns:ds="http://schemas.openxmlformats.org/officeDocument/2006/customXml" ds:itemID="{E4ACCF44-01D5-4C40-9EAC-D3C3683409FE}">
   <ds:schemaRefs>
-    <ds:schemaRef ds:uri="http://schemas.microsoft.com/sharepoint/v3/contenttype/forms"/>
+    <ds:schemaRef ds:uri="http://schemas.microsoft.com/office/2006/metadata/properties"/>
+    <ds:schemaRef ds:uri="http://schemas.microsoft.com/office/infopath/2007/PartnerControls"/>
+    <ds:schemaRef ds:uri="http://schemas.microsoft.com/sharepoint/v3"/>
+    <ds:schemaRef ds:uri="71af3243-3dd4-4a8d-8c0d-dd76da1f02a5"/>
+    <ds:schemaRef ds:uri="230e9df3-be65-4c73-a93b-d1236ebd677e"/>
   </ds:schemaRefs>
 </ds:datastoreItem>
 </file>

</xml_diff>